<commit_message>
Section2 (Era II 2016) PPTX: update to current HTML — drop 'Winner Therapixel' line, current Salim numbers (0.956/0.922/0.920, 96.6%, 81.9% vs 77.4%, +77%/+8%), 'but still' divider, expanded adoption labels; inherits gradient bg + transparent time-machine SVG; output to sections/
</commit_message>
<xml_diff>
--- a/keynote-iwbi-2026/pptx/sections/IWBI2026_Trivedi_02_EraII.pptx
+++ b/keynote-iwbi-2026/pptx/sections/IWBI2026_Trivedi_02_EraII.pptx
@@ -3871,16 +3871,40 @@
         <p:nvPr/>
       </p:nvGrpSpPr>
       <p:grpSpPr/>
-      <p:sp>
-        <p:nvSpPr>
-          <p:cNvPr id="2" name="Rectangle 1"/>
+      <p:pic>
+        <p:nvPicPr>
+          <p:cNvPr id="2" name="Picture 1" descr="bg_motif.png"/>
+          <p:cNvPicPr>
+            <a:picLocks noChangeAspect="1"/>
+          </p:cNvPicPr>
+          <p:nvPr/>
+        </p:nvPicPr>
+        <p:blipFill>
+          <a:blip r:embed="rId2"/>
+          <a:stretch>
+            <a:fillRect/>
+          </a:stretch>
+        </p:blipFill>
+        <p:spPr>
+          <a:xfrm>
+            <a:off x="0" y="0"/>
+            <a:ext cx="12191695" cy="6858000"/>
+          </a:xfrm>
+          <a:prstGeom prst="rect">
+            <a:avLst/>
+          </a:prstGeom>
+        </p:spPr>
+      </p:pic>
+      <p:sp>
+        <p:nvSpPr>
+          <p:cNvPr id="3" name="Rectangle 2"/>
           <p:cNvSpPr/>
           <p:nvPr/>
         </p:nvSpPr>
         <p:spPr>
           <a:xfrm>
             <a:off x="0" y="0"/>
-            <a:ext cx="12191695" cy="38100"/>
+            <a:ext cx="5486400" cy="38100"/>
           </a:xfrm>
           <a:prstGeom prst="rect">
             <a:avLst/>
@@ -3917,14 +3941,14 @@
       </p:sp>
       <p:sp>
         <p:nvSpPr>
-          <p:cNvPr id="3" name="TextBox 2"/>
+          <p:cNvPr id="4" name="TextBox 3"/>
           <p:cNvSpPr txBox="1"/>
           <p:nvPr/>
         </p:nvSpPr>
         <p:spPr>
           <a:xfrm>
-            <a:off x="777240" y="2756408"/>
-            <a:ext cx="5989320" cy="346456"/>
+            <a:off x="777240" y="566928"/>
+            <a:ext cx="8229600" cy="365760"/>
           </a:xfrm>
           <a:prstGeom prst="rect">
             <a:avLst/>
@@ -3932,41 +3956,38 @@
           <a:noFill/>
         </p:spPr>
         <p:txBody>
-          <a:bodyPr wrap="square" lIns="25400" rIns="25400" tIns="12700" bIns="12700">
-            <a:noAutofit/>
+          <a:bodyPr wrap="square" anchor="t" lIns="0" rIns="0" tIns="0" bIns="0">
+            <a:spAutoFit/>
           </a:bodyPr>
           <a:lstStyle/>
           <a:p>
             <a:pPr algn="l">
               <a:lnSpc>
-                <a:spcPct val="128000"/>
+                <a:spcPct val="100000"/>
               </a:lnSpc>
-              <a:spcAft>
-                <a:spcPts val="400"/>
-              </a:spcAft>
             </a:pPr>
             <a:r>
-              <a:rPr sz="1400" b="0">
-                <a:solidFill>
-                  <a:srgbClr val="9DA9B5"/>
-                </a:solidFill>
-                <a:latin typeface="Arial"/>
+              <a:rPr sz="1100" b="1" i="0">
+                <a:solidFill>
+                  <a:srgbClr val="E7AC51"/>
+                </a:solidFill>
+                <a:latin typeface="Consolas"/>
               </a:rPr>
-              <a:t>Era II</a:t>
-            </a:r>
-          </a:p>
-        </p:txBody>
-      </p:sp>
-      <p:sp>
-        <p:nvSpPr>
-          <p:cNvPr id="4" name="TextBox 3"/>
+              <a:t>ERA II</a:t>
+            </a:r>
+          </a:p>
+        </p:txBody>
+      </p:sp>
+      <p:sp>
+        <p:nvSpPr>
+          <p:cNvPr id="5" name="TextBox 4"/>
           <p:cNvSpPr txBox="1"/>
           <p:nvPr/>
         </p:nvSpPr>
         <p:spPr>
           <a:xfrm>
-            <a:off x="777240" y="3102864"/>
-            <a:ext cx="5989320" cy="790447"/>
+            <a:off x="777240" y="2286000"/>
+            <a:ext cx="6126480" cy="1463040"/>
           </a:xfrm>
           <a:prstGeom prst="rect">
             <a:avLst/>
@@ -3974,21 +3995,18 @@
           <a:noFill/>
         </p:spPr>
         <p:txBody>
-          <a:bodyPr wrap="square" lIns="25400" rIns="25400" tIns="12700" bIns="12700">
-            <a:noAutofit/>
+          <a:bodyPr wrap="square" anchor="t" lIns="0" rIns="0" tIns="0" bIns="0">
+            <a:spAutoFit/>
           </a:bodyPr>
           <a:lstStyle/>
           <a:p>
             <a:pPr algn="l">
               <a:lnSpc>
-                <a:spcPct val="106000"/>
+                <a:spcPct val="100000"/>
               </a:lnSpc>
-              <a:spcAft>
-                <a:spcPts val="400"/>
-              </a:spcAft>
             </a:pPr>
             <a:r>
-              <a:rPr sz="4400" b="0">
+              <a:rPr sz="5000" b="1" i="0">
                 <a:solidFill>
                   <a:srgbClr val="ECEFF3"/>
                 </a:solidFill>
@@ -3997,7 +4015,7 @@
               <a:t>The year is </a:t>
             </a:r>
             <a:r>
-              <a:rPr sz="4400" b="0">
+              <a:rPr sz="5000" b="1" i="0">
                 <a:solidFill>
                   <a:srgbClr val="E7AC51"/>
                 </a:solidFill>
@@ -4010,14 +4028,14 @@
       </p:sp>
       <p:sp>
         <p:nvSpPr>
-          <p:cNvPr id="5" name="TextBox 4"/>
+          <p:cNvPr id="6" name="TextBox 5"/>
           <p:cNvSpPr txBox="1"/>
           <p:nvPr/>
         </p:nvSpPr>
         <p:spPr>
           <a:xfrm>
-            <a:off x="777240" y="3893312"/>
-            <a:ext cx="5989320" cy="574040"/>
+            <a:off x="777240" y="3977639"/>
+            <a:ext cx="6035040" cy="1463040"/>
           </a:xfrm>
           <a:prstGeom prst="rect">
             <a:avLst/>
@@ -4025,21 +4043,18 @@
           <a:noFill/>
         </p:spPr>
         <p:txBody>
-          <a:bodyPr wrap="square" lIns="25400" rIns="25400" tIns="12700" bIns="12700">
-            <a:noAutofit/>
+          <a:bodyPr wrap="square" anchor="t" lIns="0" rIns="0" tIns="0" bIns="0">
+            <a:spAutoFit/>
           </a:bodyPr>
           <a:lstStyle/>
           <a:p>
             <a:pPr algn="l">
               <a:lnSpc>
-                <a:spcPct val="128000"/>
+                <a:spcPct val="130000"/>
               </a:lnSpc>
-              <a:spcAft>
-                <a:spcPts val="400"/>
-              </a:spcAft>
             </a:pPr>
             <a:r>
-              <a:rPr sz="1400" b="0">
+              <a:rPr sz="1900" b="0" i="0">
                 <a:solidFill>
                   <a:srgbClr val="9DA9B5"/>
                 </a:solidFill>
@@ -4048,7 +4063,7 @@
               <a:t>You're beginning to hear about AI — but still </a:t>
             </a:r>
             <a:r>
-              <a:rPr sz="1400" b="1">
+              <a:rPr sz="1900" b="1" i="0">
                 <a:solidFill>
                   <a:srgbClr val="ECEFF3"/>
                 </a:solidFill>
@@ -4061,22 +4076,22 @@
       </p:sp>
       <p:pic>
         <p:nvPicPr>
-          <p:cNvPr id="6" name="Picture 5" descr="s_1e85465c01.png"/>
+          <p:cNvPr id="7" name="Picture 6" descr="svg_7e3644f729.png"/>
           <p:cNvPicPr>
             <a:picLocks noChangeAspect="1"/>
           </p:cNvPicPr>
           <p:nvPr/>
         </p:nvPicPr>
         <p:blipFill>
-          <a:blip r:embed="rId3"/>
+          <a:blip r:embed="rId4"/>
           <a:stretch>
             <a:fillRect/>
           </a:stretch>
         </p:blipFill>
         <p:spPr>
           <a:xfrm>
-            <a:off x="6995160" y="2109651"/>
-            <a:ext cx="4617720" cy="2638697"/>
+            <a:off x="7040880" y="2305594"/>
+            <a:ext cx="4572000" cy="2612571"/>
           </a:xfrm>
           <a:prstGeom prst="rect">
             <a:avLst/>
@@ -4109,16 +4124,40 @@
         <p:nvPr/>
       </p:nvGrpSpPr>
       <p:grpSpPr/>
-      <p:sp>
-        <p:nvSpPr>
-          <p:cNvPr id="2" name="Rectangle 1"/>
+      <p:pic>
+        <p:nvPicPr>
+          <p:cNvPr id="2" name="Picture 1" descr="bg_motif.png"/>
+          <p:cNvPicPr>
+            <a:picLocks noChangeAspect="1"/>
+          </p:cNvPicPr>
+          <p:nvPr/>
+        </p:nvPicPr>
+        <p:blipFill>
+          <a:blip r:embed="rId2"/>
+          <a:stretch>
+            <a:fillRect/>
+          </a:stretch>
+        </p:blipFill>
+        <p:spPr>
+          <a:xfrm>
+            <a:off x="0" y="0"/>
+            <a:ext cx="12191695" cy="6858000"/>
+          </a:xfrm>
+          <a:prstGeom prst="rect">
+            <a:avLst/>
+          </a:prstGeom>
+        </p:spPr>
+      </p:pic>
+      <p:sp>
+        <p:nvSpPr>
+          <p:cNvPr id="3" name="Rectangle 2"/>
           <p:cNvSpPr/>
           <p:nvPr/>
         </p:nvSpPr>
         <p:spPr>
           <a:xfrm>
             <a:off x="0" y="0"/>
-            <a:ext cx="12191695" cy="38100"/>
+            <a:ext cx="5486400" cy="38100"/>
           </a:xfrm>
           <a:prstGeom prst="rect">
             <a:avLst/>
@@ -4155,14 +4194,14 @@
       </p:sp>
       <p:sp>
         <p:nvSpPr>
-          <p:cNvPr id="3" name="TextBox 2"/>
+          <p:cNvPr id="4" name="TextBox 3"/>
           <p:cNvSpPr txBox="1"/>
           <p:nvPr/>
         </p:nvSpPr>
         <p:spPr>
           <a:xfrm>
-            <a:off x="777240" y="411480"/>
-            <a:ext cx="8686800" cy="365760"/>
+            <a:off x="777240" y="502920"/>
+            <a:ext cx="8229600" cy="320040"/>
           </a:xfrm>
           <a:prstGeom prst="rect">
             <a:avLst/>
@@ -4170,21 +4209,18 @@
           <a:noFill/>
         </p:spPr>
         <p:txBody>
-          <a:bodyPr wrap="square" lIns="25400" rIns="25400" tIns="12700" bIns="12700">
-            <a:noAutofit/>
+          <a:bodyPr wrap="square" anchor="t" lIns="0" rIns="0" tIns="0" bIns="0">
+            <a:spAutoFit/>
           </a:bodyPr>
           <a:lstStyle/>
           <a:p>
             <a:pPr algn="l">
               <a:lnSpc>
-                <a:spcPct val="128000"/>
+                <a:spcPct val="100000"/>
               </a:lnSpc>
-              <a:spcAft>
-                <a:spcPts val="400"/>
-              </a:spcAft>
             </a:pPr>
             <a:r>
-              <a:rPr sz="1100" b="1">
+              <a:rPr sz="1100" b="1" i="0">
                 <a:solidFill>
                   <a:srgbClr val="E7AC51"/>
                 </a:solidFill>
@@ -4197,14 +4233,14 @@
       </p:sp>
       <p:sp>
         <p:nvSpPr>
-          <p:cNvPr id="4" name="TextBox 3"/>
+          <p:cNvPr id="5" name="TextBox 4"/>
           <p:cNvSpPr txBox="1"/>
           <p:nvPr/>
         </p:nvSpPr>
         <p:spPr>
           <a:xfrm>
-            <a:off x="777240" y="1966975"/>
-            <a:ext cx="5989320" cy="1274064"/>
+            <a:off x="777240" y="1051560"/>
+            <a:ext cx="5852160" cy="1371600"/>
           </a:xfrm>
           <a:prstGeom prst="rect">
             <a:avLst/>
@@ -4212,21 +4248,18 @@
           <a:noFill/>
         </p:spPr>
         <p:txBody>
-          <a:bodyPr wrap="square" lIns="25400" rIns="25400" tIns="12700" bIns="12700">
-            <a:noAutofit/>
+          <a:bodyPr wrap="square" anchor="t" lIns="0" rIns="0" tIns="0" bIns="0">
+            <a:spAutoFit/>
           </a:bodyPr>
           <a:lstStyle/>
           <a:p>
             <a:pPr algn="l">
               <a:lnSpc>
-                <a:spcPct val="106000"/>
+                <a:spcPct val="112000"/>
               </a:lnSpc>
-              <a:spcAft>
-                <a:spcPts val="400"/>
-              </a:spcAft>
             </a:pPr>
             <a:r>
-              <a:rPr sz="2600" b="0">
+              <a:rPr sz="2600" b="1" i="0">
                 <a:solidFill>
                   <a:srgbClr val="ECEFF3"/>
                 </a:solidFill>
@@ -4235,7 +4268,7 @@
               <a:t>2016: the first large-scale push — and a </a:t>
             </a:r>
             <a:r>
-              <a:rPr sz="2600" b="0">
+              <a:rPr sz="2600" b="1" i="0">
                 <a:solidFill>
                   <a:srgbClr val="E7AC51"/>
                 </a:solidFill>
@@ -4248,14 +4281,14 @@
       </p:sp>
       <p:sp>
         <p:nvSpPr>
-          <p:cNvPr id="5" name="TextBox 4"/>
+          <p:cNvPr id="6" name="TextBox 5"/>
           <p:cNvSpPr txBox="1"/>
           <p:nvPr/>
         </p:nvSpPr>
         <p:spPr>
           <a:xfrm>
-            <a:off x="777240" y="3241040"/>
-            <a:ext cx="5989320" cy="1029208"/>
+            <a:off x="777240" y="2834640"/>
+            <a:ext cx="5852160" cy="1463040"/>
           </a:xfrm>
           <a:prstGeom prst="rect">
             <a:avLst/>
@@ -4263,59 +4296,38 @@
           <a:noFill/>
         </p:spPr>
         <p:txBody>
-          <a:bodyPr wrap="square" lIns="25400" rIns="25400" tIns="12700" bIns="12700">
-            <a:noAutofit/>
+          <a:bodyPr wrap="square" anchor="t" lIns="0" rIns="0" tIns="0" bIns="0">
+            <a:spAutoFit/>
           </a:bodyPr>
           <a:lstStyle/>
           <a:p>
             <a:pPr algn="l">
               <a:lnSpc>
-                <a:spcPct val="128000"/>
+                <a:spcPct val="140000"/>
               </a:lnSpc>
-              <a:spcAft>
-                <a:spcPts val="400"/>
-              </a:spcAft>
             </a:pPr>
             <a:r>
-              <a:rPr sz="1400" b="0">
+              <a:rPr sz="1450" b="0" i="0">
                 <a:solidFill>
                   <a:srgbClr val="9DA9B5"/>
                 </a:solidFill>
                 <a:latin typeface="Arial"/>
               </a:rPr>
-              <a:t>The </a:t>
-            </a:r>
-            <a:r>
-              <a:rPr sz="1400" b="1">
-                <a:solidFill>
-                  <a:srgbClr val="ECEFF3"/>
-                </a:solidFill>
-                <a:latin typeface="Arial"/>
-              </a:rPr>
-              <a:t>Digital Mammography DREAM Challenge</a:t>
-            </a:r>
-            <a:r>
-              <a:rPr sz="1400" b="0">
-                <a:solidFill>
-                  <a:srgbClr val="9DA9B5"/>
-                </a:solidFill>
-                <a:latin typeface="Arial"/>
-              </a:rPr>
-              <a:t> was the first large-scale effort to build breast-cancer AI — and we took part. The hope was that a crowdsourced competition would simply solve it.</a:t>
-            </a:r>
-          </a:p>
-        </p:txBody>
-      </p:sp>
-      <p:sp>
-        <p:nvSpPr>
-          <p:cNvPr id="6" name="Rounded Rectangle 5"/>
+              <a:t>The Digital Mammography DREAM Challenge was the first large-scale effort to build breast-cancer AI — and we took part. The hope was that a crowdsourced competition would simply solve it.</a:t>
+            </a:r>
+          </a:p>
+        </p:txBody>
+      </p:sp>
+      <p:sp>
+        <p:nvSpPr>
+          <p:cNvPr id="7" name="Rounded Rectangle 6"/>
           <p:cNvSpPr/>
           <p:nvPr/>
         </p:nvSpPr>
         <p:spPr>
           <a:xfrm>
-            <a:off x="777240" y="4270248"/>
-            <a:ext cx="4181221" cy="365760"/>
+            <a:off x="777240" y="4617720"/>
+            <a:ext cx="5669280" cy="384048"/>
           </a:xfrm>
           <a:prstGeom prst="roundRect">
             <a:avLst/>
@@ -4325,7 +4337,7 @@
           </a:solidFill>
           <a:ln w="9525">
             <a:solidFill>
-              <a:srgbClr val="2A333E"/>
+              <a:srgbClr val="2A333D"/>
             </a:solidFill>
           </a:ln>
           <a:effectLst/>
@@ -4345,41 +4357,36 @@
           </a:fontRef>
         </p:style>
         <p:txBody>
-          <a:bodyPr rtlCol="0" anchor="ctr" wrap="none" lIns="109728" rIns="73152" tIns="0" bIns="0"/>
-          <a:lstStyle/>
-          <a:p>
-            <a:pPr algn="ctr"/>
-            <a:r>
-              <a:rPr sz="1100">
+          <a:bodyPr rtlCol="0" anchor="ctr" wrap="square" lIns="128016"/>
+          <a:lstStyle/>
+          <a:p>
+            <a:pPr algn="l">
+              <a:lnSpc>
+                <a:spcPct val="100000"/>
+              </a:lnSpc>
+            </a:pPr>
+            <a:r>
+              <a:rPr sz="1100" b="0" i="0">
                 <a:solidFill>
                   <a:srgbClr val="ECEFF3"/>
                 </a:solidFill>
                 <a:latin typeface="Consolas"/>
               </a:rPr>
-              <a:t>1,000+</a:t>
-            </a:r>
-            <a:r>
-              <a:rPr sz="1100">
-                <a:solidFill>
-                  <a:srgbClr val="ECEFF3"/>
-                </a:solidFill>
-                <a:latin typeface="Consolas"/>
-              </a:rPr>
-              <a:t> participants · 126 teams · 44 countries</a:t>
-            </a:r>
-          </a:p>
-        </p:txBody>
-      </p:sp>
-      <p:sp>
-        <p:nvSpPr>
-          <p:cNvPr id="7" name="Rectangle 6"/>
+              <a:t>1,000+ participants · 126 teams · 44 countries</a:t>
+            </a:r>
+          </a:p>
+        </p:txBody>
+      </p:sp>
+      <p:sp>
+        <p:nvSpPr>
+          <p:cNvPr id="8" name="Rectangle 7"/>
           <p:cNvSpPr/>
           <p:nvPr/>
         </p:nvSpPr>
         <p:spPr>
           <a:xfrm>
-            <a:off x="777240" y="4270248"/>
-            <a:ext cx="36576" cy="365760"/>
+            <a:off x="777240" y="4617720"/>
+            <a:ext cx="36576" cy="384048"/>
           </a:xfrm>
           <a:prstGeom prst="rect">
             <a:avLst/>
@@ -4416,14 +4423,14 @@
       </p:sp>
       <p:sp>
         <p:nvSpPr>
-          <p:cNvPr id="8" name="Rounded Rectangle 7"/>
+          <p:cNvPr id="9" name="Rounded Rectangle 8"/>
           <p:cNvSpPr/>
           <p:nvPr/>
         </p:nvSpPr>
         <p:spPr>
           <a:xfrm>
-            <a:off x="777240" y="4709160"/>
-            <a:ext cx="1909508" cy="365760"/>
+            <a:off x="777240" y="5074920"/>
+            <a:ext cx="5669280" cy="384048"/>
           </a:xfrm>
           <a:prstGeom prst="roundRect">
             <a:avLst/>
@@ -4433,7 +4440,7 @@
           </a:solidFill>
           <a:ln w="9525">
             <a:solidFill>
-              <a:srgbClr val="2A333E"/>
+              <a:srgbClr val="2A333D"/>
             </a:solidFill>
           </a:ln>
           <a:effectLst/>
@@ -4453,41 +4460,36 @@
           </a:fontRef>
         </p:style>
         <p:txBody>
-          <a:bodyPr rtlCol="0" anchor="ctr" wrap="none" lIns="109728" rIns="73152" tIns="0" bIns="0"/>
-          <a:lstStyle/>
-          <a:p>
-            <a:pPr algn="ctr"/>
-            <a:r>
-              <a:rPr sz="1100">
+          <a:bodyPr rtlCol="0" anchor="ctr" wrap="square" lIns="128016"/>
+          <a:lstStyle/>
+          <a:p>
+            <a:pPr algn="l">
+              <a:lnSpc>
+                <a:spcPct val="100000"/>
+              </a:lnSpc>
+            </a:pPr>
+            <a:r>
+              <a:rPr sz="1100" b="0" i="0">
                 <a:solidFill>
                   <a:srgbClr val="ECEFF3"/>
                 </a:solidFill>
                 <a:latin typeface="Consolas"/>
               </a:rPr>
-              <a:t>~640,000</a:t>
-            </a:r>
-            <a:r>
-              <a:rPr sz="1100">
-                <a:solidFill>
-                  <a:srgbClr val="ECEFF3"/>
-                </a:solidFill>
-                <a:latin typeface="Consolas"/>
-              </a:rPr>
-              <a:t> mammograms</a:t>
-            </a:r>
-          </a:p>
-        </p:txBody>
-      </p:sp>
-      <p:sp>
-        <p:nvSpPr>
-          <p:cNvPr id="9" name="Rectangle 8"/>
+              <a:t>~640,000 mammograms</a:t>
+            </a:r>
+          </a:p>
+        </p:txBody>
+      </p:sp>
+      <p:sp>
+        <p:nvSpPr>
+          <p:cNvPr id="10" name="Rectangle 9"/>
           <p:cNvSpPr/>
           <p:nvPr/>
         </p:nvSpPr>
         <p:spPr>
           <a:xfrm>
-            <a:off x="777240" y="4709160"/>
-            <a:ext cx="36576" cy="365760"/>
+            <a:off x="777240" y="5074920"/>
+            <a:ext cx="36576" cy="384048"/>
           </a:xfrm>
           <a:prstGeom prst="rect">
             <a:avLst/>
@@ -4524,14 +4526,14 @@
       </p:sp>
       <p:sp>
         <p:nvSpPr>
-          <p:cNvPr id="10" name="TextBox 9"/>
+          <p:cNvPr id="11" name="TextBox 10"/>
           <p:cNvSpPr txBox="1"/>
           <p:nvPr/>
         </p:nvSpPr>
         <p:spPr>
           <a:xfrm>
-            <a:off x="777240" y="5202936"/>
-            <a:ext cx="5989320" cy="346456"/>
+            <a:off x="777240" y="5852160"/>
+            <a:ext cx="5852160" cy="365760"/>
           </a:xfrm>
           <a:prstGeom prst="rect">
             <a:avLst/>
@@ -4539,25 +4541,22 @@
           <a:noFill/>
         </p:spPr>
         <p:txBody>
-          <a:bodyPr wrap="square" lIns="25400" rIns="25400" tIns="12700" bIns="12700">
-            <a:noAutofit/>
+          <a:bodyPr wrap="square" anchor="t" lIns="0" rIns="0" tIns="0" bIns="0">
+            <a:spAutoFit/>
           </a:bodyPr>
           <a:lstStyle/>
           <a:p>
             <a:pPr algn="l">
               <a:lnSpc>
-                <a:spcPct val="128000"/>
+                <a:spcPct val="100000"/>
               </a:lnSpc>
-              <a:spcAft>
-                <a:spcPts val="400"/>
-              </a:spcAft>
             </a:pPr>
             <a:r>
-              <a:rPr sz="1400" b="0">
-                <a:solidFill>
-                  <a:srgbClr val="9DA9B5"/>
-                </a:solidFill>
-                <a:latin typeface="Arial"/>
+              <a:rPr sz="1000" b="0" i="0">
+                <a:solidFill>
+                  <a:srgbClr val="5C6975"/>
+                </a:solidFill>
+                <a:latin typeface="Consolas"/>
               </a:rPr>
               <a:t>Schaffter et al., JAMA Network Open 2020;3(3):e200265.</a:t>
             </a:r>
@@ -4566,14 +4565,14 @@
       </p:sp>
       <p:sp>
         <p:nvSpPr>
-          <p:cNvPr id="11" name="Rounded Rectangle 10"/>
+          <p:cNvPr id="12" name="Rounded Rectangle 11"/>
           <p:cNvSpPr/>
           <p:nvPr/>
         </p:nvSpPr>
         <p:spPr>
           <a:xfrm>
-            <a:off x="6964218" y="832104"/>
-            <a:ext cx="4679602" cy="5193792"/>
+            <a:off x="6949440" y="1019819"/>
+            <a:ext cx="4754880" cy="5275560"/>
           </a:xfrm>
           <a:prstGeom prst="roundRect">
             <a:avLst/>
@@ -4612,22 +4611,22 @@
       </p:sp>
       <p:pic>
         <p:nvPicPr>
-          <p:cNvPr id="12" name="Picture 11" descr="i_920569b1aa.png"/>
+          <p:cNvPr id="13" name="Picture 12" descr="img_920569b1aa.png"/>
           <p:cNvPicPr>
             <a:picLocks noChangeAspect="1"/>
           </p:cNvPicPr>
           <p:nvPr/>
         </p:nvPicPr>
         <p:blipFill>
-          <a:blip r:embed="rId3"/>
+          <a:blip r:embed="rId4"/>
           <a:stretch>
             <a:fillRect/>
           </a:stretch>
         </p:blipFill>
         <p:spPr>
           <a:xfrm>
-            <a:off x="7046514" y="914400"/>
-            <a:ext cx="4515010" cy="5029200"/>
+            <a:off x="7040880" y="1111259"/>
+            <a:ext cx="4572000" cy="5092680"/>
           </a:xfrm>
           <a:prstGeom prst="rect">
             <a:avLst/>
@@ -4660,16 +4659,40 @@
         <p:nvPr/>
       </p:nvGrpSpPr>
       <p:grpSpPr/>
-      <p:sp>
-        <p:nvSpPr>
-          <p:cNvPr id="2" name="Rectangle 1"/>
+      <p:pic>
+        <p:nvPicPr>
+          <p:cNvPr id="2" name="Picture 1" descr="bg_motif.png"/>
+          <p:cNvPicPr>
+            <a:picLocks noChangeAspect="1"/>
+          </p:cNvPicPr>
+          <p:nvPr/>
+        </p:nvPicPr>
+        <p:blipFill>
+          <a:blip r:embed="rId2"/>
+          <a:stretch>
+            <a:fillRect/>
+          </a:stretch>
+        </p:blipFill>
+        <p:spPr>
+          <a:xfrm>
+            <a:off x="0" y="0"/>
+            <a:ext cx="12191695" cy="6858000"/>
+          </a:xfrm>
+          <a:prstGeom prst="rect">
+            <a:avLst/>
+          </a:prstGeom>
+        </p:spPr>
+      </p:pic>
+      <p:sp>
+        <p:nvSpPr>
+          <p:cNvPr id="3" name="Rectangle 2"/>
           <p:cNvSpPr/>
           <p:nvPr/>
         </p:nvSpPr>
         <p:spPr>
           <a:xfrm>
             <a:off x="0" y="0"/>
-            <a:ext cx="12191695" cy="38100"/>
+            <a:ext cx="5486400" cy="38100"/>
           </a:xfrm>
           <a:prstGeom prst="rect">
             <a:avLst/>
@@ -4706,14 +4729,14 @@
       </p:sp>
       <p:sp>
         <p:nvSpPr>
-          <p:cNvPr id="3" name="TextBox 2"/>
+          <p:cNvPr id="4" name="TextBox 3"/>
           <p:cNvSpPr txBox="1"/>
           <p:nvPr/>
         </p:nvSpPr>
         <p:spPr>
           <a:xfrm>
-            <a:off x="777240" y="411480"/>
-            <a:ext cx="8686800" cy="365760"/>
+            <a:off x="777240" y="502920"/>
+            <a:ext cx="8229600" cy="320040"/>
           </a:xfrm>
           <a:prstGeom prst="rect">
             <a:avLst/>
@@ -4721,21 +4744,18 @@
           <a:noFill/>
         </p:spPr>
         <p:txBody>
-          <a:bodyPr wrap="square" lIns="25400" rIns="25400" tIns="12700" bIns="12700">
-            <a:noAutofit/>
+          <a:bodyPr wrap="square" anchor="t" lIns="0" rIns="0" tIns="0" bIns="0">
+            <a:spAutoFit/>
           </a:bodyPr>
           <a:lstStyle/>
           <a:p>
             <a:pPr algn="l">
               <a:lnSpc>
-                <a:spcPct val="128000"/>
+                <a:spcPct val="100000"/>
               </a:lnSpc>
-              <a:spcAft>
-                <a:spcPts val="400"/>
-              </a:spcAft>
             </a:pPr>
             <a:r>
-              <a:rPr sz="1100" b="1">
+              <a:rPr sz="1100" b="1" i="0">
                 <a:solidFill>
                   <a:srgbClr val="E7AC51"/>
                 </a:solidFill>
@@ -4748,14 +4768,14 @@
       </p:sp>
       <p:sp>
         <p:nvSpPr>
-          <p:cNvPr id="4" name="TextBox 3"/>
+          <p:cNvPr id="5" name="TextBox 4"/>
           <p:cNvSpPr txBox="1"/>
           <p:nvPr/>
         </p:nvSpPr>
         <p:spPr>
           <a:xfrm>
-            <a:off x="777240" y="2082800"/>
-            <a:ext cx="5989320" cy="904240"/>
+            <a:off x="777240" y="1051560"/>
+            <a:ext cx="5760720" cy="1280160"/>
           </a:xfrm>
           <a:prstGeom prst="rect">
             <a:avLst/>
@@ -4763,21 +4783,18 @@
           <a:noFill/>
         </p:spPr>
         <p:txBody>
-          <a:bodyPr wrap="square" lIns="25400" rIns="25400" tIns="12700" bIns="12700">
-            <a:noAutofit/>
+          <a:bodyPr wrap="square" anchor="t" lIns="0" rIns="0" tIns="0" bIns="0">
+            <a:spAutoFit/>
           </a:bodyPr>
           <a:lstStyle/>
           <a:p>
             <a:pPr algn="l">
               <a:lnSpc>
-                <a:spcPct val="106000"/>
+                <a:spcPct val="112000"/>
               </a:lnSpc>
-              <a:spcAft>
-                <a:spcPts val="400"/>
-              </a:spcAft>
             </a:pPr>
             <a:r>
-              <a:rPr sz="2600" b="0">
+              <a:rPr sz="2600" b="1" i="0">
                 <a:solidFill>
                   <a:srgbClr val="ECEFF3"/>
                 </a:solidFill>
@@ -4786,7 +4803,7 @@
               <a:t>2020: Google publishes its </a:t>
             </a:r>
             <a:r>
-              <a:rPr sz="2600" b="0">
+              <a:rPr sz="2600" b="1" i="0">
                 <a:solidFill>
                   <a:srgbClr val="E7AC51"/>
                 </a:solidFill>
@@ -4799,14 +4816,14 @@
       </p:sp>
       <p:sp>
         <p:nvSpPr>
-          <p:cNvPr id="5" name="TextBox 4"/>
+          <p:cNvPr id="6" name="TextBox 5"/>
           <p:cNvSpPr txBox="1"/>
           <p:nvPr/>
         </p:nvSpPr>
         <p:spPr>
           <a:xfrm>
-            <a:off x="777240" y="2987040"/>
-            <a:ext cx="5989320" cy="801623"/>
+            <a:off x="777240" y="2331720"/>
+            <a:ext cx="5852160" cy="822960"/>
           </a:xfrm>
           <a:prstGeom prst="rect">
             <a:avLst/>
@@ -4814,21 +4831,18 @@
           <a:noFill/>
         </p:spPr>
         <p:txBody>
-          <a:bodyPr wrap="square" lIns="25400" rIns="25400" tIns="12700" bIns="12700">
-            <a:noAutofit/>
+          <a:bodyPr wrap="square" anchor="t" lIns="0" rIns="0" tIns="0" bIns="0">
+            <a:spAutoFit/>
           </a:bodyPr>
           <a:lstStyle/>
           <a:p>
             <a:pPr algn="l">
               <a:lnSpc>
-                <a:spcPct val="128000"/>
+                <a:spcPct val="135000"/>
               </a:lnSpc>
-              <a:spcAft>
-                <a:spcPts val="400"/>
-              </a:spcAft>
             </a:pPr>
             <a:r>
-              <a:rPr sz="1400" b="1">
+              <a:rPr sz="1400" b="1" i="0">
                 <a:solidFill>
                   <a:srgbClr val="ECEFF3"/>
                 </a:solidFill>
@@ -4837,7 +4851,7 @@
               <a:t>McKinney et al., Nature 2020</a:t>
             </a:r>
             <a:r>
-              <a:rPr sz="1400" b="0">
+              <a:rPr sz="1400" b="0" i="0">
                 <a:solidFill>
                   <a:srgbClr val="9DA9B5"/>
                 </a:solidFill>
@@ -4850,24 +4864,375 @@
       </p:sp>
       <p:sp>
         <p:nvSpPr>
-          <p:cNvPr id="6" name="Rounded Rectangle 5"/>
+          <p:cNvPr id="7" name="TextBox 6"/>
+          <p:cNvSpPr txBox="1"/>
+          <p:nvPr/>
+        </p:nvSpPr>
+        <p:spPr>
+          <a:xfrm>
+            <a:off x="777240" y="3246120"/>
+            <a:ext cx="5669280" cy="384048"/>
+          </a:xfrm>
+          <a:prstGeom prst="rect">
+            <a:avLst/>
+          </a:prstGeom>
+          <a:noFill/>
+        </p:spPr>
+        <p:txBody>
+          <a:bodyPr wrap="square" anchor="t" lIns="0" rIns="0" tIns="0" bIns="0">
+            <a:spAutoFit/>
+          </a:bodyPr>
+          <a:lstStyle/>
+          <a:p>
+            <a:pPr algn="l">
+              <a:lnSpc>
+                <a:spcPct val="100000"/>
+              </a:lnSpc>
+            </a:pPr>
+            <a:r>
+              <a:rPr sz="1900" b="1" i="0">
+                <a:solidFill>
+                  <a:srgbClr val="E7AC51"/>
+                </a:solidFill>
+                <a:latin typeface="Arial"/>
+              </a:rPr>
+              <a:t>−5.7% / −1.2%</a:t>
+            </a:r>
+          </a:p>
+        </p:txBody>
+      </p:sp>
+      <p:sp>
+        <p:nvSpPr>
+          <p:cNvPr id="8" name="TextBox 7"/>
+          <p:cNvSpPr txBox="1"/>
+          <p:nvPr/>
+        </p:nvSpPr>
+        <p:spPr>
+          <a:xfrm>
+            <a:off x="777240" y="3611879"/>
+            <a:ext cx="5669280" cy="310896"/>
+          </a:xfrm>
+          <a:prstGeom prst="rect">
+            <a:avLst/>
+          </a:prstGeom>
+          <a:noFill/>
+        </p:spPr>
+        <p:txBody>
+          <a:bodyPr wrap="square" anchor="t" lIns="0" rIns="0" tIns="0" bIns="0">
+            <a:spAutoFit/>
+          </a:bodyPr>
+          <a:lstStyle/>
+          <a:p>
+            <a:pPr algn="l">
+              <a:lnSpc>
+                <a:spcPct val="100000"/>
+              </a:lnSpc>
+            </a:pPr>
+            <a:r>
+              <a:rPr sz="1100" b="0" i="0">
+                <a:solidFill>
+                  <a:srgbClr val="9DA9B5"/>
+                </a:solidFill>
+                <a:latin typeface="Consolas"/>
+              </a:rPr>
+              <a:t>false positives (US / UK)</a:t>
+            </a:r>
+          </a:p>
+        </p:txBody>
+      </p:sp>
+      <p:sp>
+        <p:nvSpPr>
+          <p:cNvPr id="9" name="TextBox 8"/>
+          <p:cNvSpPr txBox="1"/>
+          <p:nvPr/>
+        </p:nvSpPr>
+        <p:spPr>
+          <a:xfrm>
+            <a:off x="777240" y="3959352"/>
+            <a:ext cx="5669280" cy="384048"/>
+          </a:xfrm>
+          <a:prstGeom prst="rect">
+            <a:avLst/>
+          </a:prstGeom>
+          <a:noFill/>
+        </p:spPr>
+        <p:txBody>
+          <a:bodyPr wrap="square" anchor="t" lIns="0" rIns="0" tIns="0" bIns="0">
+            <a:spAutoFit/>
+          </a:bodyPr>
+          <a:lstStyle/>
+          <a:p>
+            <a:pPr algn="l">
+              <a:lnSpc>
+                <a:spcPct val="100000"/>
+              </a:lnSpc>
+            </a:pPr>
+            <a:r>
+              <a:rPr sz="1900" b="1" i="0">
+                <a:solidFill>
+                  <a:srgbClr val="E7AC51"/>
+                </a:solidFill>
+                <a:latin typeface="Arial"/>
+              </a:rPr>
+              <a:t>−9.4% / −2.7%</a:t>
+            </a:r>
+          </a:p>
+        </p:txBody>
+      </p:sp>
+      <p:sp>
+        <p:nvSpPr>
+          <p:cNvPr id="10" name="TextBox 9"/>
+          <p:cNvSpPr txBox="1"/>
+          <p:nvPr/>
+        </p:nvSpPr>
+        <p:spPr>
+          <a:xfrm>
+            <a:off x="777240" y="4325112"/>
+            <a:ext cx="5669280" cy="310896"/>
+          </a:xfrm>
+          <a:prstGeom prst="rect">
+            <a:avLst/>
+          </a:prstGeom>
+          <a:noFill/>
+        </p:spPr>
+        <p:txBody>
+          <a:bodyPr wrap="square" anchor="t" lIns="0" rIns="0" tIns="0" bIns="0">
+            <a:spAutoFit/>
+          </a:bodyPr>
+          <a:lstStyle/>
+          <a:p>
+            <a:pPr algn="l">
+              <a:lnSpc>
+                <a:spcPct val="100000"/>
+              </a:lnSpc>
+            </a:pPr>
+            <a:r>
+              <a:rPr sz="1100" b="0" i="0">
+                <a:solidFill>
+                  <a:srgbClr val="9DA9B5"/>
+                </a:solidFill>
+                <a:latin typeface="Consolas"/>
+              </a:rPr>
+              <a:t>false negatives (US / UK)</a:t>
+            </a:r>
+          </a:p>
+        </p:txBody>
+      </p:sp>
+      <p:sp>
+        <p:nvSpPr>
+          <p:cNvPr id="11" name="TextBox 10"/>
+          <p:cNvSpPr txBox="1"/>
+          <p:nvPr/>
+        </p:nvSpPr>
+        <p:spPr>
+          <a:xfrm>
+            <a:off x="777240" y="4672584"/>
+            <a:ext cx="5669280" cy="384048"/>
+          </a:xfrm>
+          <a:prstGeom prst="rect">
+            <a:avLst/>
+          </a:prstGeom>
+          <a:noFill/>
+        </p:spPr>
+        <p:txBody>
+          <a:bodyPr wrap="square" anchor="t" lIns="0" rIns="0" tIns="0" bIns="0">
+            <a:spAutoFit/>
+          </a:bodyPr>
+          <a:lstStyle/>
+          <a:p>
+            <a:pPr algn="l">
+              <a:lnSpc>
+                <a:spcPct val="100000"/>
+              </a:lnSpc>
+            </a:pPr>
+            <a:r>
+              <a:rPr sz="1900" b="1" i="0">
+                <a:solidFill>
+                  <a:srgbClr val="E7AC51"/>
+                </a:solidFill>
+                <a:latin typeface="Arial"/>
+              </a:rPr>
+              <a:t>+11.5%</a:t>
+            </a:r>
+          </a:p>
+        </p:txBody>
+      </p:sp>
+      <p:sp>
+        <p:nvSpPr>
+          <p:cNvPr id="12" name="TextBox 11"/>
+          <p:cNvSpPr txBox="1"/>
+          <p:nvPr/>
+        </p:nvSpPr>
+        <p:spPr>
+          <a:xfrm>
+            <a:off x="777240" y="5038344"/>
+            <a:ext cx="5669280" cy="310896"/>
+          </a:xfrm>
+          <a:prstGeom prst="rect">
+            <a:avLst/>
+          </a:prstGeom>
+          <a:noFill/>
+        </p:spPr>
+        <p:txBody>
+          <a:bodyPr wrap="square" anchor="t" lIns="0" rIns="0" tIns="0" bIns="0">
+            <a:spAutoFit/>
+          </a:bodyPr>
+          <a:lstStyle/>
+          <a:p>
+            <a:pPr algn="l">
+              <a:lnSpc>
+                <a:spcPct val="100000"/>
+              </a:lnSpc>
+            </a:pPr>
+            <a:r>
+              <a:rPr sz="1100" b="0" i="0">
+                <a:solidFill>
+                  <a:srgbClr val="9DA9B5"/>
+                </a:solidFill>
+                <a:latin typeface="Consolas"/>
+              </a:rPr>
+              <a:t>AUC over the average radiologist</a:t>
+            </a:r>
+          </a:p>
+        </p:txBody>
+      </p:sp>
+      <p:sp>
+        <p:nvSpPr>
+          <p:cNvPr id="13" name="TextBox 12"/>
+          <p:cNvSpPr txBox="1"/>
+          <p:nvPr/>
+        </p:nvSpPr>
+        <p:spPr>
+          <a:xfrm>
+            <a:off x="777240" y="5385816"/>
+            <a:ext cx="5669280" cy="384048"/>
+          </a:xfrm>
+          <a:prstGeom prst="rect">
+            <a:avLst/>
+          </a:prstGeom>
+          <a:noFill/>
+        </p:spPr>
+        <p:txBody>
+          <a:bodyPr wrap="square" anchor="t" lIns="0" rIns="0" tIns="0" bIns="0">
+            <a:spAutoFit/>
+          </a:bodyPr>
+          <a:lstStyle/>
+          <a:p>
+            <a:pPr algn="l">
+              <a:lnSpc>
+                <a:spcPct val="100000"/>
+              </a:lnSpc>
+            </a:pPr>
+            <a:r>
+              <a:rPr sz="1900" b="1" i="0">
+                <a:solidFill>
+                  <a:srgbClr val="E7AC51"/>
+                </a:solidFill>
+                <a:latin typeface="Arial"/>
+              </a:rPr>
+              <a:t>−88%</a:t>
+            </a:r>
+          </a:p>
+        </p:txBody>
+      </p:sp>
+      <p:sp>
+        <p:nvSpPr>
+          <p:cNvPr id="14" name="TextBox 13"/>
+          <p:cNvSpPr txBox="1"/>
+          <p:nvPr/>
+        </p:nvSpPr>
+        <p:spPr>
+          <a:xfrm>
+            <a:off x="777240" y="5751576"/>
+            <a:ext cx="5669280" cy="310896"/>
+          </a:xfrm>
+          <a:prstGeom prst="rect">
+            <a:avLst/>
+          </a:prstGeom>
+          <a:noFill/>
+        </p:spPr>
+        <p:txBody>
+          <a:bodyPr wrap="square" anchor="t" lIns="0" rIns="0" tIns="0" bIns="0">
+            <a:spAutoFit/>
+          </a:bodyPr>
+          <a:lstStyle/>
+          <a:p>
+            <a:pPr algn="l">
+              <a:lnSpc>
+                <a:spcPct val="100000"/>
+              </a:lnSpc>
+            </a:pPr>
+            <a:r>
+              <a:rPr sz="1100" b="0" i="0">
+                <a:solidFill>
+                  <a:srgbClr val="9DA9B5"/>
+                </a:solidFill>
+                <a:latin typeface="Consolas"/>
+              </a:rPr>
+              <a:t>simulated second-reader workload</a:t>
+            </a:r>
+          </a:p>
+        </p:txBody>
+      </p:sp>
+      <p:sp>
+        <p:nvSpPr>
+          <p:cNvPr id="15" name="TextBox 14"/>
+          <p:cNvSpPr txBox="1"/>
+          <p:nvPr/>
+        </p:nvSpPr>
+        <p:spPr>
+          <a:xfrm>
+            <a:off x="777240" y="6199632"/>
+            <a:ext cx="5760720" cy="365760"/>
+          </a:xfrm>
+          <a:prstGeom prst="rect">
+            <a:avLst/>
+          </a:prstGeom>
+          <a:noFill/>
+        </p:spPr>
+        <p:txBody>
+          <a:bodyPr wrap="square" anchor="t" lIns="0" rIns="0" tIns="0" bIns="0">
+            <a:spAutoFit/>
+          </a:bodyPr>
+          <a:lstStyle/>
+          <a:p>
+            <a:pPr algn="l">
+              <a:lnSpc>
+                <a:spcPct val="100000"/>
+              </a:lnSpc>
+            </a:pPr>
+            <a:r>
+              <a:rPr sz="950" b="0" i="0">
+                <a:solidFill>
+                  <a:srgbClr val="5C6975"/>
+                </a:solidFill>
+                <a:latin typeface="Consolas"/>
+              </a:rPr>
+              <a:t>Results are promising — but again, only on clean, curated data. · McKinney et al., Nature 2020;577:89–94.</a:t>
+            </a:r>
+          </a:p>
+        </p:txBody>
+      </p:sp>
+      <p:sp>
+        <p:nvSpPr>
+          <p:cNvPr id="16" name="Rounded Rectangle 15"/>
           <p:cNvSpPr/>
           <p:nvPr/>
         </p:nvSpPr>
         <p:spPr>
           <a:xfrm>
-            <a:off x="777240" y="3788664"/>
-            <a:ext cx="3255708" cy="365760"/>
+            <a:off x="7900966" y="1280160"/>
+            <a:ext cx="2851827" cy="4754880"/>
           </a:xfrm>
           <a:prstGeom prst="roundRect">
             <a:avLst/>
           </a:prstGeom>
           <a:solidFill>
-            <a:srgbClr val="1B232D"/>
+            <a:srgbClr val="FFFFFF"/>
           </a:solidFill>
           <a:ln w="9525">
             <a:solidFill>
-              <a:srgbClr val="2A333E"/>
+              <a:srgbClr val="C98A2E"/>
             </a:solidFill>
           </a:ln>
           <a:effectLst/>
@@ -4887,489 +5252,6 @@
           </a:fontRef>
         </p:style>
         <p:txBody>
-          <a:bodyPr rtlCol="0" anchor="ctr" wrap="none" lIns="109728" rIns="73152" tIns="0" bIns="0"/>
-          <a:lstStyle/>
-          <a:p>
-            <a:pPr algn="ctr"/>
-            <a:r>
-              <a:rPr sz="1100">
-                <a:solidFill>
-                  <a:srgbClr val="ECEFF3"/>
-                </a:solidFill>
-                <a:latin typeface="Consolas"/>
-              </a:rPr>
-              <a:t>false positives </a:t>
-            </a:r>
-            <a:r>
-              <a:rPr sz="1100">
-                <a:solidFill>
-                  <a:srgbClr val="ECEFF3"/>
-                </a:solidFill>
-                <a:latin typeface="Consolas"/>
-              </a:rPr>
-              <a:t>−5.7% US / −1.2% UK</a:t>
-            </a:r>
-          </a:p>
-        </p:txBody>
-      </p:sp>
-      <p:sp>
-        <p:nvSpPr>
-          <p:cNvPr id="7" name="Rectangle 6"/>
-          <p:cNvSpPr/>
-          <p:nvPr/>
-        </p:nvSpPr>
-        <p:spPr>
-          <a:xfrm>
-            <a:off x="777240" y="3788664"/>
-            <a:ext cx="36576" cy="365760"/>
-          </a:xfrm>
-          <a:prstGeom prst="rect">
-            <a:avLst/>
-          </a:prstGeom>
-          <a:solidFill>
-            <a:srgbClr val="5FB7C9"/>
-          </a:solidFill>
-          <a:ln>
-            <a:noFill/>
-          </a:ln>
-          <a:effectLst/>
-        </p:spPr>
-        <p:style>
-          <a:lnRef idx="1">
-            <a:schemeClr val="accent1"/>
-          </a:lnRef>
-          <a:fillRef idx="3">
-            <a:schemeClr val="accent1"/>
-          </a:fillRef>
-          <a:effectRef idx="2">
-            <a:schemeClr val="accent1"/>
-          </a:effectRef>
-          <a:fontRef idx="minor">
-            <a:schemeClr val="lt1"/>
-          </a:fontRef>
-        </p:style>
-        <p:txBody>
-          <a:bodyPr rtlCol="0" anchor="ctr"/>
-          <a:lstStyle/>
-          <a:p>
-            <a:pPr algn="ctr"/>
-          </a:p>
-        </p:txBody>
-      </p:sp>
-      <p:sp>
-        <p:nvSpPr>
-          <p:cNvPr id="8" name="Rounded Rectangle 7"/>
-          <p:cNvSpPr/>
-          <p:nvPr/>
-        </p:nvSpPr>
-        <p:spPr>
-          <a:xfrm>
-            <a:off x="777240" y="4227576"/>
-            <a:ext cx="3255708" cy="365760"/>
-          </a:xfrm>
-          <a:prstGeom prst="roundRect">
-            <a:avLst/>
-          </a:prstGeom>
-          <a:solidFill>
-            <a:srgbClr val="1B232D"/>
-          </a:solidFill>
-          <a:ln w="9525">
-            <a:solidFill>
-              <a:srgbClr val="2A333E"/>
-            </a:solidFill>
-          </a:ln>
-          <a:effectLst/>
-        </p:spPr>
-        <p:style>
-          <a:lnRef idx="1">
-            <a:schemeClr val="accent1"/>
-          </a:lnRef>
-          <a:fillRef idx="3">
-            <a:schemeClr val="accent1"/>
-          </a:fillRef>
-          <a:effectRef idx="2">
-            <a:schemeClr val="accent1"/>
-          </a:effectRef>
-          <a:fontRef idx="minor">
-            <a:schemeClr val="lt1"/>
-          </a:fontRef>
-        </p:style>
-        <p:txBody>
-          <a:bodyPr rtlCol="0" anchor="ctr" wrap="none" lIns="109728" rIns="73152" tIns="0" bIns="0"/>
-          <a:lstStyle/>
-          <a:p>
-            <a:pPr algn="ctr"/>
-            <a:r>
-              <a:rPr sz="1100">
-                <a:solidFill>
-                  <a:srgbClr val="ECEFF3"/>
-                </a:solidFill>
-                <a:latin typeface="Consolas"/>
-              </a:rPr>
-              <a:t>false negatives </a:t>
-            </a:r>
-            <a:r>
-              <a:rPr sz="1100">
-                <a:solidFill>
-                  <a:srgbClr val="ECEFF3"/>
-                </a:solidFill>
-                <a:latin typeface="Consolas"/>
-              </a:rPr>
-              <a:t>−9.4% US / −2.7% UK</a:t>
-            </a:r>
-          </a:p>
-        </p:txBody>
-      </p:sp>
-      <p:sp>
-        <p:nvSpPr>
-          <p:cNvPr id="9" name="Rectangle 8"/>
-          <p:cNvSpPr/>
-          <p:nvPr/>
-        </p:nvSpPr>
-        <p:spPr>
-          <a:xfrm>
-            <a:off x="777240" y="4227576"/>
-            <a:ext cx="36576" cy="365760"/>
-          </a:xfrm>
-          <a:prstGeom prst="rect">
-            <a:avLst/>
-          </a:prstGeom>
-          <a:solidFill>
-            <a:srgbClr val="5FB7C9"/>
-          </a:solidFill>
-          <a:ln>
-            <a:noFill/>
-          </a:ln>
-          <a:effectLst/>
-        </p:spPr>
-        <p:style>
-          <a:lnRef idx="1">
-            <a:schemeClr val="accent1"/>
-          </a:lnRef>
-          <a:fillRef idx="3">
-            <a:schemeClr val="accent1"/>
-          </a:fillRef>
-          <a:effectRef idx="2">
-            <a:schemeClr val="accent1"/>
-          </a:effectRef>
-          <a:fontRef idx="minor">
-            <a:schemeClr val="lt1"/>
-          </a:fontRef>
-        </p:style>
-        <p:txBody>
-          <a:bodyPr rtlCol="0" anchor="ctr"/>
-          <a:lstStyle/>
-          <a:p>
-            <a:pPr algn="ctr"/>
-          </a:p>
-        </p:txBody>
-      </p:sp>
-      <p:sp>
-        <p:nvSpPr>
-          <p:cNvPr id="10" name="Rounded Rectangle 9"/>
-          <p:cNvSpPr/>
-          <p:nvPr/>
-        </p:nvSpPr>
-        <p:spPr>
-          <a:xfrm>
-            <a:off x="777240" y="4666488"/>
-            <a:ext cx="2750883" cy="365760"/>
-          </a:xfrm>
-          <a:prstGeom prst="roundRect">
-            <a:avLst/>
-          </a:prstGeom>
-          <a:solidFill>
-            <a:srgbClr val="1B232D"/>
-          </a:solidFill>
-          <a:ln w="9525">
-            <a:solidFill>
-              <a:srgbClr val="2A333E"/>
-            </a:solidFill>
-          </a:ln>
-          <a:effectLst/>
-        </p:spPr>
-        <p:style>
-          <a:lnRef idx="1">
-            <a:schemeClr val="accent1"/>
-          </a:lnRef>
-          <a:fillRef idx="3">
-            <a:schemeClr val="accent1"/>
-          </a:fillRef>
-          <a:effectRef idx="2">
-            <a:schemeClr val="accent1"/>
-          </a:effectRef>
-          <a:fontRef idx="minor">
-            <a:schemeClr val="lt1"/>
-          </a:fontRef>
-        </p:style>
-        <p:txBody>
-          <a:bodyPr rtlCol="0" anchor="ctr" wrap="none" lIns="109728" rIns="73152" tIns="0" bIns="0"/>
-          <a:lstStyle/>
-          <a:p>
-            <a:pPr algn="ctr"/>
-            <a:r>
-              <a:rPr sz="1100">
-                <a:solidFill>
-                  <a:srgbClr val="ECEFF3"/>
-                </a:solidFill>
-                <a:latin typeface="Consolas"/>
-              </a:rPr>
-              <a:t>AUC </a:t>
-            </a:r>
-            <a:r>
-              <a:rPr sz="1100">
-                <a:solidFill>
-                  <a:srgbClr val="ECEFF3"/>
-                </a:solidFill>
-                <a:latin typeface="Consolas"/>
-              </a:rPr>
-              <a:t>+11.5%</a:t>
-            </a:r>
-            <a:r>
-              <a:rPr sz="1100">
-                <a:solidFill>
-                  <a:srgbClr val="ECEFF3"/>
-                </a:solidFill>
-                <a:latin typeface="Consolas"/>
-              </a:rPr>
-              <a:t> vs avg radiologist</a:t>
-            </a:r>
-          </a:p>
-        </p:txBody>
-      </p:sp>
-      <p:sp>
-        <p:nvSpPr>
-          <p:cNvPr id="11" name="Rectangle 10"/>
-          <p:cNvSpPr/>
-          <p:nvPr/>
-        </p:nvSpPr>
-        <p:spPr>
-          <a:xfrm>
-            <a:off x="777240" y="4666488"/>
-            <a:ext cx="36576" cy="365760"/>
-          </a:xfrm>
-          <a:prstGeom prst="rect">
-            <a:avLst/>
-          </a:prstGeom>
-          <a:solidFill>
-            <a:srgbClr val="5FB7C9"/>
-          </a:solidFill>
-          <a:ln>
-            <a:noFill/>
-          </a:ln>
-          <a:effectLst/>
-        </p:spPr>
-        <p:style>
-          <a:lnRef idx="1">
-            <a:schemeClr val="accent1"/>
-          </a:lnRef>
-          <a:fillRef idx="3">
-            <a:schemeClr val="accent1"/>
-          </a:fillRef>
-          <a:effectRef idx="2">
-            <a:schemeClr val="accent1"/>
-          </a:effectRef>
-          <a:fontRef idx="minor">
-            <a:schemeClr val="lt1"/>
-          </a:fontRef>
-        </p:style>
-        <p:txBody>
-          <a:bodyPr rtlCol="0" anchor="ctr"/>
-          <a:lstStyle/>
-          <a:p>
-            <a:pPr algn="ctr"/>
-          </a:p>
-        </p:txBody>
-      </p:sp>
-      <p:sp>
-        <p:nvSpPr>
-          <p:cNvPr id="12" name="Rounded Rectangle 11"/>
-          <p:cNvSpPr/>
-          <p:nvPr/>
-        </p:nvSpPr>
-        <p:spPr>
-          <a:xfrm>
-            <a:off x="3619563" y="4666488"/>
-            <a:ext cx="2330196" cy="365760"/>
-          </a:xfrm>
-          <a:prstGeom prst="roundRect">
-            <a:avLst/>
-          </a:prstGeom>
-          <a:solidFill>
-            <a:srgbClr val="1B232D"/>
-          </a:solidFill>
-          <a:ln w="9525">
-            <a:solidFill>
-              <a:srgbClr val="2A333E"/>
-            </a:solidFill>
-          </a:ln>
-          <a:effectLst/>
-        </p:spPr>
-        <p:style>
-          <a:lnRef idx="1">
-            <a:schemeClr val="accent1"/>
-          </a:lnRef>
-          <a:fillRef idx="3">
-            <a:schemeClr val="accent1"/>
-          </a:fillRef>
-          <a:effectRef idx="2">
-            <a:schemeClr val="accent1"/>
-          </a:effectRef>
-          <a:fontRef idx="minor">
-            <a:schemeClr val="lt1"/>
-          </a:fontRef>
-        </p:style>
-        <p:txBody>
-          <a:bodyPr rtlCol="0" anchor="ctr" wrap="none" lIns="109728" rIns="73152" tIns="0" bIns="0"/>
-          <a:lstStyle/>
-          <a:p>
-            <a:pPr algn="ctr"/>
-            <a:r>
-              <a:rPr sz="1100">
-                <a:solidFill>
-                  <a:srgbClr val="ECEFF3"/>
-                </a:solidFill>
-                <a:latin typeface="Consolas"/>
-              </a:rPr>
-              <a:t>2nd-reader workload </a:t>
-            </a:r>
-            <a:r>
-              <a:rPr sz="1100">
-                <a:solidFill>
-                  <a:srgbClr val="ECEFF3"/>
-                </a:solidFill>
-                <a:latin typeface="Consolas"/>
-              </a:rPr>
-              <a:t>−88%</a:t>
-            </a:r>
-          </a:p>
-        </p:txBody>
-      </p:sp>
-      <p:sp>
-        <p:nvSpPr>
-          <p:cNvPr id="13" name="Rectangle 12"/>
-          <p:cNvSpPr/>
-          <p:nvPr/>
-        </p:nvSpPr>
-        <p:spPr>
-          <a:xfrm>
-            <a:off x="3619563" y="4666488"/>
-            <a:ext cx="36576" cy="365760"/>
-          </a:xfrm>
-          <a:prstGeom prst="rect">
-            <a:avLst/>
-          </a:prstGeom>
-          <a:solidFill>
-            <a:srgbClr val="5FB7C9"/>
-          </a:solidFill>
-          <a:ln>
-            <a:noFill/>
-          </a:ln>
-          <a:effectLst/>
-        </p:spPr>
-        <p:style>
-          <a:lnRef idx="1">
-            <a:schemeClr val="accent1"/>
-          </a:lnRef>
-          <a:fillRef idx="3">
-            <a:schemeClr val="accent1"/>
-          </a:fillRef>
-          <a:effectRef idx="2">
-            <a:schemeClr val="accent1"/>
-          </a:effectRef>
-          <a:fontRef idx="minor">
-            <a:schemeClr val="lt1"/>
-          </a:fontRef>
-        </p:style>
-        <p:txBody>
-          <a:bodyPr rtlCol="0" anchor="ctr"/>
-          <a:lstStyle/>
-          <a:p>
-            <a:pPr algn="ctr"/>
-          </a:p>
-        </p:txBody>
-      </p:sp>
-      <p:sp>
-        <p:nvSpPr>
-          <p:cNvPr id="14" name="TextBox 13"/>
-          <p:cNvSpPr txBox="1"/>
-          <p:nvPr/>
-        </p:nvSpPr>
-        <p:spPr>
-          <a:xfrm>
-            <a:off x="777240" y="5160264"/>
-            <a:ext cx="5989320" cy="346456"/>
-          </a:xfrm>
-          <a:prstGeom prst="rect">
-            <a:avLst/>
-          </a:prstGeom>
-          <a:noFill/>
-        </p:spPr>
-        <p:txBody>
-          <a:bodyPr wrap="square" lIns="25400" rIns="25400" tIns="12700" bIns="12700">
-            <a:noAutofit/>
-          </a:bodyPr>
-          <a:lstStyle/>
-          <a:p>
-            <a:pPr algn="l">
-              <a:lnSpc>
-                <a:spcPct val="128000"/>
-              </a:lnSpc>
-              <a:spcAft>
-                <a:spcPts val="400"/>
-              </a:spcAft>
-            </a:pPr>
-            <a:r>
-              <a:rPr sz="1400" b="0">
-                <a:solidFill>
-                  <a:srgbClr val="9DA9B5"/>
-                </a:solidFill>
-                <a:latin typeface="Arial"/>
-              </a:rPr>
-              <a:t>Results are promising — but again, only on clean, curated data.</a:t>
-            </a:r>
-          </a:p>
-        </p:txBody>
-      </p:sp>
-      <p:sp>
-        <p:nvSpPr>
-          <p:cNvPr id="15" name="Rounded Rectangle 14"/>
-          <p:cNvSpPr/>
-          <p:nvPr/>
-        </p:nvSpPr>
-        <p:spPr>
-          <a:xfrm>
-            <a:off x="7753803" y="832104"/>
-            <a:ext cx="3100433" cy="5193792"/>
-          </a:xfrm>
-          <a:prstGeom prst="roundRect">
-            <a:avLst/>
-          </a:prstGeom>
-          <a:solidFill>
-            <a:srgbClr val="FFFFFF"/>
-          </a:solidFill>
-          <a:ln w="9525">
-            <a:solidFill>
-              <a:srgbClr val="C98A2E"/>
-            </a:solidFill>
-          </a:ln>
-          <a:effectLst/>
-        </p:spPr>
-        <p:style>
-          <a:lnRef idx="1">
-            <a:schemeClr val="accent1"/>
-          </a:lnRef>
-          <a:fillRef idx="3">
-            <a:schemeClr val="accent1"/>
-          </a:fillRef>
-          <a:effectRef idx="2">
-            <a:schemeClr val="accent1"/>
-          </a:effectRef>
-          <a:fontRef idx="minor">
-            <a:schemeClr val="lt1"/>
-          </a:fontRef>
-        </p:style>
-        <p:txBody>
           <a:bodyPr rtlCol="0" anchor="ctr"/>
           <a:lstStyle/>
           <a:p>
@@ -5379,22 +5261,22 @@
       </p:sp>
       <p:pic>
         <p:nvPicPr>
-          <p:cNvPr id="16" name="Picture 15" descr="i_6cb54df20e.png"/>
+          <p:cNvPr id="17" name="Picture 16" descr="img_6cb54df20e.png"/>
           <p:cNvPicPr>
             <a:picLocks noChangeAspect="1"/>
           </p:cNvPicPr>
           <p:nvPr/>
         </p:nvPicPr>
         <p:blipFill>
-          <a:blip r:embed="rId3"/>
+          <a:blip r:embed="rId4"/>
           <a:stretch>
             <a:fillRect/>
           </a:stretch>
         </p:blipFill>
         <p:spPr>
           <a:xfrm>
-            <a:off x="7836099" y="914400"/>
-            <a:ext cx="2935841" cy="5029200"/>
+            <a:off x="7992406" y="1371600"/>
+            <a:ext cx="2668947" cy="4572000"/>
           </a:xfrm>
           <a:prstGeom prst="rect">
             <a:avLst/>
@@ -5427,16 +5309,40 @@
         <p:nvPr/>
       </p:nvGrpSpPr>
       <p:grpSpPr/>
-      <p:sp>
-        <p:nvSpPr>
-          <p:cNvPr id="2" name="Rectangle 1"/>
+      <p:pic>
+        <p:nvPicPr>
+          <p:cNvPr id="2" name="Picture 1" descr="bg_motif.png"/>
+          <p:cNvPicPr>
+            <a:picLocks noChangeAspect="1"/>
+          </p:cNvPicPr>
+          <p:nvPr/>
+        </p:nvPicPr>
+        <p:blipFill>
+          <a:blip r:embed="rId2"/>
+          <a:stretch>
+            <a:fillRect/>
+          </a:stretch>
+        </p:blipFill>
+        <p:spPr>
+          <a:xfrm>
+            <a:off x="0" y="0"/>
+            <a:ext cx="12191695" cy="6858000"/>
+          </a:xfrm>
+          <a:prstGeom prst="rect">
+            <a:avLst/>
+          </a:prstGeom>
+        </p:spPr>
+      </p:pic>
+      <p:sp>
+        <p:nvSpPr>
+          <p:cNvPr id="3" name="Rectangle 2"/>
           <p:cNvSpPr/>
           <p:nvPr/>
         </p:nvSpPr>
         <p:spPr>
           <a:xfrm>
             <a:off x="0" y="0"/>
-            <a:ext cx="12191695" cy="38100"/>
+            <a:ext cx="5486400" cy="38100"/>
           </a:xfrm>
           <a:prstGeom prst="rect">
             <a:avLst/>
@@ -5473,14 +5379,14 @@
       </p:sp>
       <p:sp>
         <p:nvSpPr>
-          <p:cNvPr id="3" name="TextBox 2"/>
+          <p:cNvPr id="4" name="TextBox 3"/>
           <p:cNvSpPr txBox="1"/>
           <p:nvPr/>
         </p:nvSpPr>
         <p:spPr>
           <a:xfrm>
-            <a:off x="777240" y="411480"/>
-            <a:ext cx="8686800" cy="365760"/>
+            <a:off x="777240" y="502920"/>
+            <a:ext cx="8229600" cy="320040"/>
           </a:xfrm>
           <a:prstGeom prst="rect">
             <a:avLst/>
@@ -5488,21 +5394,18 @@
           <a:noFill/>
         </p:spPr>
         <p:txBody>
-          <a:bodyPr wrap="square" lIns="25400" rIns="25400" tIns="12700" bIns="12700">
-            <a:noAutofit/>
+          <a:bodyPr wrap="square" anchor="t" lIns="0" rIns="0" tIns="0" bIns="0">
+            <a:spAutoFit/>
           </a:bodyPr>
           <a:lstStyle/>
           <a:p>
             <a:pPr algn="l">
               <a:lnSpc>
-                <a:spcPct val="128000"/>
+                <a:spcPct val="100000"/>
               </a:lnSpc>
-              <a:spcAft>
-                <a:spcPts val="400"/>
-              </a:spcAft>
             </a:pPr>
             <a:r>
-              <a:rPr sz="1100" b="1">
+              <a:rPr sz="1100" b="1" i="0">
                 <a:solidFill>
                   <a:srgbClr val="E7AC51"/>
                 </a:solidFill>
@@ -5515,14 +5418,14 @@
       </p:sp>
       <p:sp>
         <p:nvSpPr>
-          <p:cNvPr id="4" name="TextBox 3"/>
+          <p:cNvPr id="5" name="TextBox 4"/>
           <p:cNvSpPr txBox="1"/>
           <p:nvPr/>
         </p:nvSpPr>
         <p:spPr>
           <a:xfrm>
-            <a:off x="777240" y="1897887"/>
-            <a:ext cx="5989320" cy="1274064"/>
+            <a:off x="777240" y="1051560"/>
+            <a:ext cx="5852160" cy="1463040"/>
           </a:xfrm>
           <a:prstGeom prst="rect">
             <a:avLst/>
@@ -5530,21 +5433,18 @@
           <a:noFill/>
         </p:spPr>
         <p:txBody>
-          <a:bodyPr wrap="square" lIns="25400" rIns="25400" tIns="12700" bIns="12700">
-            <a:noAutofit/>
+          <a:bodyPr wrap="square" anchor="t" lIns="0" rIns="0" tIns="0" bIns="0">
+            <a:spAutoFit/>
           </a:bodyPr>
           <a:lstStyle/>
           <a:p>
             <a:pPr algn="l">
               <a:lnSpc>
-                <a:spcPct val="106000"/>
+                <a:spcPct val="112000"/>
               </a:lnSpc>
-              <a:spcAft>
-                <a:spcPts val="400"/>
-              </a:spcAft>
             </a:pPr>
             <a:r>
-              <a:rPr sz="2600" b="0">
+              <a:rPr sz="2400" b="1" i="0">
                 <a:solidFill>
                   <a:srgbClr val="ECEFF3"/>
                 </a:solidFill>
@@ -5553,7 +5453,7 @@
               <a:t>2020: three commercial models, independently validated on </a:t>
             </a:r>
             <a:r>
-              <a:rPr sz="2600" b="0">
+              <a:rPr sz="2400" b="1" i="0">
                 <a:solidFill>
                   <a:srgbClr val="E7AC51"/>
                 </a:solidFill>
@@ -5566,14 +5466,14 @@
       </p:sp>
       <p:sp>
         <p:nvSpPr>
-          <p:cNvPr id="5" name="TextBox 4"/>
+          <p:cNvPr id="6" name="TextBox 5"/>
           <p:cNvSpPr txBox="1"/>
           <p:nvPr/>
         </p:nvSpPr>
         <p:spPr>
           <a:xfrm>
-            <a:off x="777240" y="3171952"/>
-            <a:ext cx="5989320" cy="574040"/>
+            <a:off x="777240" y="2743200"/>
+            <a:ext cx="5852160" cy="731520"/>
           </a:xfrm>
           <a:prstGeom prst="rect">
             <a:avLst/>
@@ -5581,21 +5481,18 @@
           <a:noFill/>
         </p:spPr>
         <p:txBody>
-          <a:bodyPr wrap="square" lIns="25400" rIns="25400" tIns="12700" bIns="12700">
-            <a:noAutofit/>
+          <a:bodyPr wrap="square" anchor="t" lIns="0" rIns="0" tIns="0" bIns="0">
+            <a:spAutoFit/>
           </a:bodyPr>
           <a:lstStyle/>
           <a:p>
             <a:pPr algn="l">
               <a:lnSpc>
-                <a:spcPct val="128000"/>
+                <a:spcPct val="135000"/>
               </a:lnSpc>
-              <a:spcAft>
-                <a:spcPts val="400"/>
-              </a:spcAft>
             </a:pPr>
             <a:r>
-              <a:rPr sz="1400" b="1">
+              <a:rPr sz="1400" b="1" i="0">
                 <a:solidFill>
                   <a:srgbClr val="ECEFF3"/>
                 </a:solidFill>
@@ -5604,7 +5501,7 @@
               <a:t>Salim et al., JAMA Oncology 2020</a:t>
             </a:r>
             <a:r>
-              <a:rPr sz="1400" b="0">
+              <a:rPr sz="1400" b="0" i="0">
                 <a:solidFill>
                   <a:srgbClr val="9DA9B5"/>
                 </a:solidFill>
@@ -5617,24 +5514,315 @@
       </p:sp>
       <p:sp>
         <p:nvSpPr>
-          <p:cNvPr id="6" name="Rounded Rectangle 5"/>
+          <p:cNvPr id="7" name="TextBox 6"/>
+          <p:cNvSpPr txBox="1"/>
+          <p:nvPr/>
+        </p:nvSpPr>
+        <p:spPr>
+          <a:xfrm>
+            <a:off x="777240" y="3611880"/>
+            <a:ext cx="5852160" cy="457200"/>
+          </a:xfrm>
+          <a:prstGeom prst="rect">
+            <a:avLst/>
+          </a:prstGeom>
+          <a:noFill/>
+        </p:spPr>
+        <p:txBody>
+          <a:bodyPr wrap="square" anchor="t" lIns="0" rIns="0" tIns="0" bIns="0">
+            <a:spAutoFit/>
+          </a:bodyPr>
+          <a:lstStyle/>
+          <a:p>
+            <a:pPr algn="l">
+              <a:lnSpc>
+                <a:spcPct val="130000"/>
+              </a:lnSpc>
+            </a:pPr>
+            <a:r>
+              <a:rPr sz="1400" b="0" i="0">
+                <a:solidFill>
+                  <a:srgbClr val="9DA9B5"/>
+                </a:solidFill>
+                <a:latin typeface="Arial"/>
+              </a:rPr>
+              <a:t>AUC — AI-1 </a:t>
+            </a:r>
+            <a:r>
+              <a:rPr sz="1400" b="1" i="0">
+                <a:solidFill>
+                  <a:srgbClr val="E7AC51"/>
+                </a:solidFill>
+                <a:latin typeface="Arial"/>
+              </a:rPr>
+              <a:t>0.956</a:t>
+            </a:r>
+            <a:r>
+              <a:rPr sz="1400" b="0" i="0">
+                <a:solidFill>
+                  <a:srgbClr val="9DA9B5"/>
+                </a:solidFill>
+                <a:latin typeface="Arial"/>
+              </a:rPr>
+              <a:t> · AI-2 </a:t>
+            </a:r>
+            <a:r>
+              <a:rPr sz="1400" b="1" i="0">
+                <a:solidFill>
+                  <a:srgbClr val="E7AC51"/>
+                </a:solidFill>
+                <a:latin typeface="Arial"/>
+              </a:rPr>
+              <a:t>0.922</a:t>
+            </a:r>
+            <a:r>
+              <a:rPr sz="1400" b="0" i="0">
+                <a:solidFill>
+                  <a:srgbClr val="9DA9B5"/>
+                </a:solidFill>
+                <a:latin typeface="Arial"/>
+              </a:rPr>
+              <a:t> · AI-3 </a:t>
+            </a:r>
+            <a:r>
+              <a:rPr sz="1400" b="1" i="0">
+                <a:solidFill>
+                  <a:srgbClr val="E7AC51"/>
+                </a:solidFill>
+                <a:latin typeface="Arial"/>
+              </a:rPr>
+              <a:t>0.920</a:t>
+            </a:r>
+          </a:p>
+        </p:txBody>
+      </p:sp>
+      <p:sp>
+        <p:nvSpPr>
+          <p:cNvPr id="8" name="TextBox 7"/>
+          <p:cNvSpPr txBox="1"/>
+          <p:nvPr/>
+        </p:nvSpPr>
+        <p:spPr>
+          <a:xfrm>
+            <a:off x="777240" y="4206240"/>
+            <a:ext cx="5852160" cy="640080"/>
+          </a:xfrm>
+          <a:prstGeom prst="rect">
+            <a:avLst/>
+          </a:prstGeom>
+          <a:noFill/>
+        </p:spPr>
+        <p:txBody>
+          <a:bodyPr wrap="square" anchor="t" lIns="0" rIns="0" tIns="0" bIns="0">
+            <a:spAutoFit/>
+          </a:bodyPr>
+          <a:lstStyle/>
+          <a:p>
+            <a:pPr algn="l">
+              <a:lnSpc>
+                <a:spcPct val="130000"/>
+              </a:lnSpc>
+            </a:pPr>
+            <a:r>
+              <a:rPr sz="1400" b="0" i="0">
+                <a:solidFill>
+                  <a:srgbClr val="9DA9B5"/>
+                </a:solidFill>
+                <a:latin typeface="Arial"/>
+              </a:rPr>
+              <a:t>At readers' specificity (</a:t>
+            </a:r>
+            <a:r>
+              <a:rPr sz="1400" b="1" i="0">
+                <a:solidFill>
+                  <a:srgbClr val="ECEFF3"/>
+                </a:solidFill>
+                <a:latin typeface="Arial"/>
+              </a:rPr>
+              <a:t>96.6%</a:t>
+            </a:r>
+            <a:r>
+              <a:rPr sz="1400" b="0" i="0">
+                <a:solidFill>
+                  <a:srgbClr val="9DA9B5"/>
+                </a:solidFill>
+                <a:latin typeface="Arial"/>
+              </a:rPr>
+              <a:t>): AI-1 </a:t>
+            </a:r>
+            <a:r>
+              <a:rPr sz="1400" b="1" i="0">
+                <a:solidFill>
+                  <a:srgbClr val="ECEFF3"/>
+                </a:solidFill>
+                <a:latin typeface="Arial"/>
+              </a:rPr>
+              <a:t>81.9%</a:t>
+            </a:r>
+            <a:r>
+              <a:rPr sz="1400" b="0" i="0">
+                <a:solidFill>
+                  <a:srgbClr val="9DA9B5"/>
+                </a:solidFill>
+                <a:latin typeface="Arial"/>
+              </a:rPr>
+              <a:t> sensitivity vs readers </a:t>
+            </a:r>
+            <a:r>
+              <a:rPr sz="1400" b="1" i="0">
+                <a:solidFill>
+                  <a:srgbClr val="ECEFF3"/>
+                </a:solidFill>
+                <a:latin typeface="Arial"/>
+              </a:rPr>
+              <a:t>77.4%</a:t>
+            </a:r>
+            <a:r>
+              <a:rPr sz="1400" b="0" i="0">
+                <a:solidFill>
+                  <a:srgbClr val="9DA9B5"/>
+                </a:solidFill>
+                <a:latin typeface="Arial"/>
+              </a:rPr>
+              <a:t>.</a:t>
+            </a:r>
+          </a:p>
+        </p:txBody>
+      </p:sp>
+      <p:sp>
+        <p:nvSpPr>
+          <p:cNvPr id="9" name="TextBox 8"/>
+          <p:cNvSpPr txBox="1"/>
+          <p:nvPr/>
+        </p:nvSpPr>
+        <p:spPr>
+          <a:xfrm>
+            <a:off x="777240" y="4846320"/>
+            <a:ext cx="5852160" cy="548640"/>
+          </a:xfrm>
+          <a:prstGeom prst="rect">
+            <a:avLst/>
+          </a:prstGeom>
+          <a:noFill/>
+        </p:spPr>
+        <p:txBody>
+          <a:bodyPr wrap="square" anchor="t" lIns="0" rIns="0" tIns="0" bIns="0">
+            <a:spAutoFit/>
+          </a:bodyPr>
+          <a:lstStyle/>
+          <a:p>
+            <a:pPr algn="l">
+              <a:lnSpc>
+                <a:spcPct val="130000"/>
+              </a:lnSpc>
+            </a:pPr>
+            <a:r>
+              <a:rPr sz="1400" b="0" i="0">
+                <a:solidFill>
+                  <a:srgbClr val="9DA9B5"/>
+                </a:solidFill>
+                <a:latin typeface="Arial"/>
+              </a:rPr>
+              <a:t>AI + reader: </a:t>
+            </a:r>
+            <a:r>
+              <a:rPr sz="1400" b="1" i="0">
+                <a:solidFill>
+                  <a:srgbClr val="E7AC51"/>
+                </a:solidFill>
+                <a:latin typeface="Arial"/>
+              </a:rPr>
+              <a:t>+77%</a:t>
+            </a:r>
+            <a:r>
+              <a:rPr sz="1400" b="0" i="0">
+                <a:solidFill>
+                  <a:srgbClr val="9DA9B5"/>
+                </a:solidFill>
+                <a:latin typeface="Arial"/>
+              </a:rPr>
+              <a:t> abnormal calls for </a:t>
+            </a:r>
+            <a:r>
+              <a:rPr sz="1400" b="1" i="0">
+                <a:solidFill>
+                  <a:srgbClr val="E7AC51"/>
+                </a:solidFill>
+                <a:latin typeface="Arial"/>
+              </a:rPr>
+              <a:t>+8%</a:t>
+            </a:r>
+            <a:r>
+              <a:rPr sz="1400" b="0" i="0">
+                <a:solidFill>
+                  <a:srgbClr val="9DA9B5"/>
+                </a:solidFill>
+                <a:latin typeface="Arial"/>
+              </a:rPr>
+              <a:t> detection — the operating-point tension in miniature.</a:t>
+            </a:r>
+          </a:p>
+        </p:txBody>
+      </p:sp>
+      <p:sp>
+        <p:nvSpPr>
+          <p:cNvPr id="10" name="TextBox 9"/>
+          <p:cNvSpPr txBox="1"/>
+          <p:nvPr/>
+        </p:nvSpPr>
+        <p:spPr>
+          <a:xfrm>
+            <a:off x="777240" y="5989320"/>
+            <a:ext cx="5852160" cy="457200"/>
+          </a:xfrm>
+          <a:prstGeom prst="rect">
+            <a:avLst/>
+          </a:prstGeom>
+          <a:noFill/>
+        </p:spPr>
+        <p:txBody>
+          <a:bodyPr wrap="square" anchor="t" lIns="0" rIns="0" tIns="0" bIns="0">
+            <a:spAutoFit/>
+          </a:bodyPr>
+          <a:lstStyle/>
+          <a:p>
+            <a:pPr algn="l">
+              <a:lnSpc>
+                <a:spcPct val="100000"/>
+              </a:lnSpc>
+            </a:pPr>
+            <a:r>
+              <a:rPr sz="1000" b="0" i="0">
+                <a:solidFill>
+                  <a:srgbClr val="5C6975"/>
+                </a:solidFill>
+                <a:latin typeface="Consolas"/>
+              </a:rPr>
+              <a:t>Salim et al., JAMA Oncology 2020 (Stockholm, 8,805 women).</a:t>
+            </a:r>
+          </a:p>
+        </p:txBody>
+      </p:sp>
+      <p:sp>
+        <p:nvSpPr>
+          <p:cNvPr id="11" name="Rounded Rectangle 10"/>
           <p:cNvSpPr/>
           <p:nvPr/>
         </p:nvSpPr>
         <p:spPr>
           <a:xfrm>
-            <a:off x="777240" y="3745992"/>
-            <a:ext cx="3844671" cy="365760"/>
+            <a:off x="6949440" y="2219999"/>
+            <a:ext cx="4754880" cy="2875201"/>
           </a:xfrm>
           <a:prstGeom prst="roundRect">
             <a:avLst/>
           </a:prstGeom>
           <a:solidFill>
-            <a:srgbClr val="1B232D"/>
+            <a:srgbClr val="FFFFFF"/>
           </a:solidFill>
           <a:ln w="9525">
             <a:solidFill>
-              <a:srgbClr val="2A333E"/>
+              <a:srgbClr val="C98A2E"/>
             </a:solidFill>
           </a:ln>
           <a:effectLst/>
@@ -5654,480 +5842,6 @@
           </a:fontRef>
         </p:style>
         <p:txBody>
-          <a:bodyPr rtlCol="0" anchor="ctr" wrap="none" lIns="109728" rIns="73152" tIns="0" bIns="0"/>
-          <a:lstStyle/>
-          <a:p>
-            <a:pPr algn="ctr"/>
-            <a:r>
-              <a:rPr sz="1100">
-                <a:solidFill>
-                  <a:srgbClr val="ECEFF3"/>
-                </a:solidFill>
-                <a:latin typeface="Consolas"/>
-              </a:rPr>
-              <a:t>AUC — AI-1 </a:t>
-            </a:r>
-            <a:r>
-              <a:rPr sz="1100">
-                <a:solidFill>
-                  <a:srgbClr val="ECEFF3"/>
-                </a:solidFill>
-                <a:latin typeface="Consolas"/>
-              </a:rPr>
-              <a:t>0.956</a:t>
-            </a:r>
-            <a:r>
-              <a:rPr sz="1100">
-                <a:solidFill>
-                  <a:srgbClr val="ECEFF3"/>
-                </a:solidFill>
-                <a:latin typeface="Consolas"/>
-              </a:rPr>
-              <a:t> · AI-2 </a:t>
-            </a:r>
-            <a:r>
-              <a:rPr sz="1100">
-                <a:solidFill>
-                  <a:srgbClr val="ECEFF3"/>
-                </a:solidFill>
-                <a:latin typeface="Consolas"/>
-              </a:rPr>
-              <a:t>0.922</a:t>
-            </a:r>
-            <a:r>
-              <a:rPr sz="1100">
-                <a:solidFill>
-                  <a:srgbClr val="ECEFF3"/>
-                </a:solidFill>
-                <a:latin typeface="Consolas"/>
-              </a:rPr>
-              <a:t> · AI-3 </a:t>
-            </a:r>
-            <a:r>
-              <a:rPr sz="1100">
-                <a:solidFill>
-                  <a:srgbClr val="ECEFF3"/>
-                </a:solidFill>
-                <a:latin typeface="Consolas"/>
-              </a:rPr>
-              <a:t>0.920</a:t>
-            </a:r>
-          </a:p>
-        </p:txBody>
-      </p:sp>
-      <p:sp>
-        <p:nvSpPr>
-          <p:cNvPr id="7" name="Rectangle 6"/>
-          <p:cNvSpPr/>
-          <p:nvPr/>
-        </p:nvSpPr>
-        <p:spPr>
-          <a:xfrm>
-            <a:off x="777240" y="3745992"/>
-            <a:ext cx="36576" cy="365760"/>
-          </a:xfrm>
-          <a:prstGeom prst="rect">
-            <a:avLst/>
-          </a:prstGeom>
-          <a:solidFill>
-            <a:srgbClr val="5FB7C9"/>
-          </a:solidFill>
-          <a:ln>
-            <a:noFill/>
-          </a:ln>
-          <a:effectLst/>
-        </p:spPr>
-        <p:style>
-          <a:lnRef idx="1">
-            <a:schemeClr val="accent1"/>
-          </a:lnRef>
-          <a:fillRef idx="3">
-            <a:schemeClr val="accent1"/>
-          </a:fillRef>
-          <a:effectRef idx="2">
-            <a:schemeClr val="accent1"/>
-          </a:effectRef>
-          <a:fontRef idx="minor">
-            <a:schemeClr val="lt1"/>
-          </a:fontRef>
-        </p:style>
-        <p:txBody>
-          <a:bodyPr rtlCol="0" anchor="ctr"/>
-          <a:lstStyle/>
-          <a:p>
-            <a:pPr algn="ctr"/>
-          </a:p>
-        </p:txBody>
-      </p:sp>
-      <p:sp>
-        <p:nvSpPr>
-          <p:cNvPr id="8" name="Rounded Rectangle 7"/>
-          <p:cNvSpPr/>
-          <p:nvPr/>
-        </p:nvSpPr>
-        <p:spPr>
-          <a:xfrm>
-            <a:off x="777240" y="4184904"/>
-            <a:ext cx="6200521" cy="365760"/>
-          </a:xfrm>
-          <a:prstGeom prst="roundRect">
-            <a:avLst/>
-          </a:prstGeom>
-          <a:solidFill>
-            <a:srgbClr val="1B232D"/>
-          </a:solidFill>
-          <a:ln w="9525">
-            <a:solidFill>
-              <a:srgbClr val="2A333E"/>
-            </a:solidFill>
-          </a:ln>
-          <a:effectLst/>
-        </p:spPr>
-        <p:style>
-          <a:lnRef idx="1">
-            <a:schemeClr val="accent1"/>
-          </a:lnRef>
-          <a:fillRef idx="3">
-            <a:schemeClr val="accent1"/>
-          </a:fillRef>
-          <a:effectRef idx="2">
-            <a:schemeClr val="accent1"/>
-          </a:effectRef>
-          <a:fontRef idx="minor">
-            <a:schemeClr val="lt1"/>
-          </a:fontRef>
-        </p:style>
-        <p:txBody>
-          <a:bodyPr rtlCol="0" anchor="ctr" wrap="none" lIns="109728" rIns="73152" tIns="0" bIns="0"/>
-          <a:lstStyle/>
-          <a:p>
-            <a:pPr algn="ctr"/>
-            <a:r>
-              <a:rPr sz="1100">
-                <a:solidFill>
-                  <a:srgbClr val="ECEFF3"/>
-                </a:solidFill>
-                <a:latin typeface="Consolas"/>
-              </a:rPr>
-              <a:t>at radiologists' specificity (</a:t>
-            </a:r>
-            <a:r>
-              <a:rPr sz="1100">
-                <a:solidFill>
-                  <a:srgbClr val="ECEFF3"/>
-                </a:solidFill>
-                <a:latin typeface="Consolas"/>
-              </a:rPr>
-              <a:t>96.6%</a:t>
-            </a:r>
-            <a:r>
-              <a:rPr sz="1100">
-                <a:solidFill>
-                  <a:srgbClr val="ECEFF3"/>
-                </a:solidFill>
-                <a:latin typeface="Consolas"/>
-              </a:rPr>
-              <a:t>): AI-1 </a:t>
-            </a:r>
-            <a:r>
-              <a:rPr sz="1100">
-                <a:solidFill>
-                  <a:srgbClr val="ECEFF3"/>
-                </a:solidFill>
-                <a:latin typeface="Consolas"/>
-              </a:rPr>
-              <a:t>81.9%</a:t>
-            </a:r>
-            <a:r>
-              <a:rPr sz="1100">
-                <a:solidFill>
-                  <a:srgbClr val="ECEFF3"/>
-                </a:solidFill>
-                <a:latin typeface="Consolas"/>
-              </a:rPr>
-              <a:t> sens vs readers </a:t>
-            </a:r>
-            <a:r>
-              <a:rPr sz="1100">
-                <a:solidFill>
-                  <a:srgbClr val="ECEFF3"/>
-                </a:solidFill>
-                <a:latin typeface="Consolas"/>
-              </a:rPr>
-              <a:t>77.4%</a:t>
-            </a:r>
-          </a:p>
-        </p:txBody>
-      </p:sp>
-      <p:sp>
-        <p:nvSpPr>
-          <p:cNvPr id="9" name="Rectangle 8"/>
-          <p:cNvSpPr/>
-          <p:nvPr/>
-        </p:nvSpPr>
-        <p:spPr>
-          <a:xfrm>
-            <a:off x="777240" y="4184904"/>
-            <a:ext cx="36576" cy="365760"/>
-          </a:xfrm>
-          <a:prstGeom prst="rect">
-            <a:avLst/>
-          </a:prstGeom>
-          <a:solidFill>
-            <a:srgbClr val="5FB7C9"/>
-          </a:solidFill>
-          <a:ln>
-            <a:noFill/>
-          </a:ln>
-          <a:effectLst/>
-        </p:spPr>
-        <p:style>
-          <a:lnRef idx="1">
-            <a:schemeClr val="accent1"/>
-          </a:lnRef>
-          <a:fillRef idx="3">
-            <a:schemeClr val="accent1"/>
-          </a:fillRef>
-          <a:effectRef idx="2">
-            <a:schemeClr val="accent1"/>
-          </a:effectRef>
-          <a:fontRef idx="minor">
-            <a:schemeClr val="lt1"/>
-          </a:fontRef>
-        </p:style>
-        <p:txBody>
-          <a:bodyPr rtlCol="0" anchor="ctr"/>
-          <a:lstStyle/>
-          <a:p>
-            <a:pPr algn="ctr"/>
-          </a:p>
-        </p:txBody>
-      </p:sp>
-      <p:sp>
-        <p:nvSpPr>
-          <p:cNvPr id="10" name="Rounded Rectangle 9"/>
-          <p:cNvSpPr/>
-          <p:nvPr/>
-        </p:nvSpPr>
-        <p:spPr>
-          <a:xfrm>
-            <a:off x="777240" y="4623816"/>
-            <a:ext cx="4517771" cy="365760"/>
-          </a:xfrm>
-          <a:prstGeom prst="roundRect">
-            <a:avLst/>
-          </a:prstGeom>
-          <a:solidFill>
-            <a:srgbClr val="1B232D"/>
-          </a:solidFill>
-          <a:ln w="9525">
-            <a:solidFill>
-              <a:srgbClr val="2A333E"/>
-            </a:solidFill>
-          </a:ln>
-          <a:effectLst/>
-        </p:spPr>
-        <p:style>
-          <a:lnRef idx="1">
-            <a:schemeClr val="accent1"/>
-          </a:lnRef>
-          <a:fillRef idx="3">
-            <a:schemeClr val="accent1"/>
-          </a:fillRef>
-          <a:effectRef idx="2">
-            <a:schemeClr val="accent1"/>
-          </a:effectRef>
-          <a:fontRef idx="minor">
-            <a:schemeClr val="lt1"/>
-          </a:fontRef>
-        </p:style>
-        <p:txBody>
-          <a:bodyPr rtlCol="0" anchor="ctr" wrap="none" lIns="109728" rIns="73152" tIns="0" bIns="0"/>
-          <a:lstStyle/>
-          <a:p>
-            <a:pPr algn="ctr"/>
-            <a:r>
-              <a:rPr sz="1100">
-                <a:solidFill>
-                  <a:srgbClr val="ECEFF3"/>
-                </a:solidFill>
-                <a:latin typeface="Consolas"/>
-              </a:rPr>
-              <a:t>AI + reader: </a:t>
-            </a:r>
-            <a:r>
-              <a:rPr sz="1100">
-                <a:solidFill>
-                  <a:srgbClr val="ECEFF3"/>
-                </a:solidFill>
-                <a:latin typeface="Consolas"/>
-              </a:rPr>
-              <a:t>+77%</a:t>
-            </a:r>
-            <a:r>
-              <a:rPr sz="1100">
-                <a:solidFill>
-                  <a:srgbClr val="ECEFF3"/>
-                </a:solidFill>
-                <a:latin typeface="Consolas"/>
-              </a:rPr>
-              <a:t> abnormal calls for </a:t>
-            </a:r>
-            <a:r>
-              <a:rPr sz="1100">
-                <a:solidFill>
-                  <a:srgbClr val="ECEFF3"/>
-                </a:solidFill>
-                <a:latin typeface="Consolas"/>
-              </a:rPr>
-              <a:t>+8%</a:t>
-            </a:r>
-            <a:r>
-              <a:rPr sz="1100">
-                <a:solidFill>
-                  <a:srgbClr val="ECEFF3"/>
-                </a:solidFill>
-                <a:latin typeface="Consolas"/>
-              </a:rPr>
-              <a:t> detection</a:t>
-            </a:r>
-          </a:p>
-        </p:txBody>
-      </p:sp>
-      <p:sp>
-        <p:nvSpPr>
-          <p:cNvPr id="11" name="Rectangle 10"/>
-          <p:cNvSpPr/>
-          <p:nvPr/>
-        </p:nvSpPr>
-        <p:spPr>
-          <a:xfrm>
-            <a:off x="777240" y="4623816"/>
-            <a:ext cx="36576" cy="365760"/>
-          </a:xfrm>
-          <a:prstGeom prst="rect">
-            <a:avLst/>
-          </a:prstGeom>
-          <a:solidFill>
-            <a:srgbClr val="5FB7C9"/>
-          </a:solidFill>
-          <a:ln>
-            <a:noFill/>
-          </a:ln>
-          <a:effectLst/>
-        </p:spPr>
-        <p:style>
-          <a:lnRef idx="1">
-            <a:schemeClr val="accent1"/>
-          </a:lnRef>
-          <a:fillRef idx="3">
-            <a:schemeClr val="accent1"/>
-          </a:fillRef>
-          <a:effectRef idx="2">
-            <a:schemeClr val="accent1"/>
-          </a:effectRef>
-          <a:fontRef idx="minor">
-            <a:schemeClr val="lt1"/>
-          </a:fontRef>
-        </p:style>
-        <p:txBody>
-          <a:bodyPr rtlCol="0" anchor="ctr"/>
-          <a:lstStyle/>
-          <a:p>
-            <a:pPr algn="ctr"/>
-          </a:p>
-        </p:txBody>
-      </p:sp>
-      <p:sp>
-        <p:nvSpPr>
-          <p:cNvPr id="12" name="TextBox 11"/>
-          <p:cNvSpPr txBox="1"/>
-          <p:nvPr/>
-        </p:nvSpPr>
-        <p:spPr>
-          <a:xfrm>
-            <a:off x="777240" y="5117592"/>
-            <a:ext cx="5989320" cy="574040"/>
-          </a:xfrm>
-          <a:prstGeom prst="rect">
-            <a:avLst/>
-          </a:prstGeom>
-          <a:noFill/>
-        </p:spPr>
-        <p:txBody>
-          <a:bodyPr wrap="square" lIns="25400" rIns="25400" tIns="12700" bIns="12700">
-            <a:noAutofit/>
-          </a:bodyPr>
-          <a:lstStyle/>
-          <a:p>
-            <a:pPr algn="l">
-              <a:lnSpc>
-                <a:spcPct val="128000"/>
-              </a:lnSpc>
-              <a:spcAft>
-                <a:spcPts val="400"/>
-              </a:spcAft>
-            </a:pPr>
-            <a:r>
-              <a:rPr sz="1400" b="0">
-                <a:solidFill>
-                  <a:srgbClr val="9DA9B5"/>
-                </a:solidFill>
-                <a:latin typeface="Arial"/>
-              </a:rPr>
-              <a:t>The combination's recall cost is the </a:t>
-            </a:r>
-            <a:r>
-              <a:rPr sz="1400" b="0">
-                <a:solidFill>
-                  <a:srgbClr val="E7AC51"/>
-                </a:solidFill>
-                <a:latin typeface="Arial"/>
-              </a:rPr>
-              <a:t>operating-point tension in miniature.</a:t>
-            </a:r>
-          </a:p>
-        </p:txBody>
-      </p:sp>
-      <p:sp>
-        <p:nvSpPr>
-          <p:cNvPr id="13" name="Rounded Rectangle 12"/>
-          <p:cNvSpPr/>
-          <p:nvPr/>
-        </p:nvSpPr>
-        <p:spPr>
-          <a:xfrm>
-            <a:off x="6912864" y="1987081"/>
-            <a:ext cx="4782312" cy="2883836"/>
-          </a:xfrm>
-          <a:prstGeom prst="roundRect">
-            <a:avLst/>
-          </a:prstGeom>
-          <a:solidFill>
-            <a:srgbClr val="FFFFFF"/>
-          </a:solidFill>
-          <a:ln w="9525">
-            <a:solidFill>
-              <a:srgbClr val="C98A2E"/>
-            </a:solidFill>
-          </a:ln>
-          <a:effectLst/>
-        </p:spPr>
-        <p:style>
-          <a:lnRef idx="1">
-            <a:schemeClr val="accent1"/>
-          </a:lnRef>
-          <a:fillRef idx="3">
-            <a:schemeClr val="accent1"/>
-          </a:fillRef>
-          <a:effectRef idx="2">
-            <a:schemeClr val="accent1"/>
-          </a:effectRef>
-          <a:fontRef idx="minor">
-            <a:schemeClr val="lt1"/>
-          </a:fontRef>
-        </p:style>
-        <p:txBody>
           <a:bodyPr rtlCol="0" anchor="ctr"/>
           <a:lstStyle/>
           <a:p>
@@ -6137,22 +5851,22 @@
       </p:sp>
       <p:pic>
         <p:nvPicPr>
-          <p:cNvPr id="14" name="Picture 13" descr="i_1a0b098745.png"/>
+          <p:cNvPr id="12" name="Picture 11" descr="img_1a0b098745.png"/>
           <p:cNvPicPr>
             <a:picLocks noChangeAspect="1"/>
           </p:cNvPicPr>
           <p:nvPr/>
         </p:nvPicPr>
         <p:blipFill>
-          <a:blip r:embed="rId3"/>
+          <a:blip r:embed="rId4"/>
           <a:stretch>
             <a:fillRect/>
           </a:stretch>
         </p:blipFill>
         <p:spPr>
           <a:xfrm>
-            <a:off x="6995160" y="2069377"/>
-            <a:ext cx="4617720" cy="2719244"/>
+            <a:off x="7040880" y="2311439"/>
+            <a:ext cx="4572000" cy="2692321"/>
           </a:xfrm>
           <a:prstGeom prst="rect">
             <a:avLst/>
@@ -6185,16 +5899,40 @@
         <p:nvPr/>
       </p:nvGrpSpPr>
       <p:grpSpPr/>
-      <p:sp>
-        <p:nvSpPr>
-          <p:cNvPr id="2" name="Rectangle 1"/>
+      <p:pic>
+        <p:nvPicPr>
+          <p:cNvPr id="2" name="Picture 1" descr="bg_motif.png"/>
+          <p:cNvPicPr>
+            <a:picLocks noChangeAspect="1"/>
+          </p:cNvPicPr>
+          <p:nvPr/>
+        </p:nvPicPr>
+        <p:blipFill>
+          <a:blip r:embed="rId2"/>
+          <a:stretch>
+            <a:fillRect/>
+          </a:stretch>
+        </p:blipFill>
+        <p:spPr>
+          <a:xfrm>
+            <a:off x="0" y="0"/>
+            <a:ext cx="12191695" cy="6858000"/>
+          </a:xfrm>
+          <a:prstGeom prst="rect">
+            <a:avLst/>
+          </a:prstGeom>
+        </p:spPr>
+      </p:pic>
+      <p:sp>
+        <p:nvSpPr>
+          <p:cNvPr id="3" name="Rectangle 2"/>
           <p:cNvSpPr/>
           <p:nvPr/>
         </p:nvSpPr>
         <p:spPr>
           <a:xfrm>
             <a:off x="0" y="0"/>
-            <a:ext cx="12191695" cy="38100"/>
+            <a:ext cx="5486400" cy="38100"/>
           </a:xfrm>
           <a:prstGeom prst="rect">
             <a:avLst/>
@@ -6231,14 +5969,14 @@
       </p:sp>
       <p:sp>
         <p:nvSpPr>
-          <p:cNvPr id="3" name="TextBox 2"/>
+          <p:cNvPr id="4" name="TextBox 3"/>
           <p:cNvSpPr txBox="1"/>
           <p:nvPr/>
         </p:nvSpPr>
         <p:spPr>
           <a:xfrm>
-            <a:off x="777240" y="411480"/>
-            <a:ext cx="8686800" cy="365760"/>
+            <a:off x="777240" y="502920"/>
+            <a:ext cx="8229600" cy="320040"/>
           </a:xfrm>
           <a:prstGeom prst="rect">
             <a:avLst/>
@@ -6246,21 +5984,18 @@
           <a:noFill/>
         </p:spPr>
         <p:txBody>
-          <a:bodyPr wrap="square" lIns="25400" rIns="25400" tIns="12700" bIns="12700">
-            <a:noAutofit/>
+          <a:bodyPr wrap="square" anchor="t" lIns="0" rIns="0" tIns="0" bIns="0">
+            <a:spAutoFit/>
           </a:bodyPr>
           <a:lstStyle/>
           <a:p>
             <a:pPr algn="l">
               <a:lnSpc>
-                <a:spcPct val="128000"/>
+                <a:spcPct val="100000"/>
               </a:lnSpc>
-              <a:spcAft>
-                <a:spcPts val="400"/>
-              </a:spcAft>
             </a:pPr>
             <a:r>
-              <a:rPr sz="1100" b="1">
+              <a:rPr sz="1100" b="1" i="0">
                 <a:solidFill>
                   <a:srgbClr val="E7AC51"/>
                 </a:solidFill>
@@ -6273,14 +6008,14 @@
       </p:sp>
       <p:sp>
         <p:nvSpPr>
-          <p:cNvPr id="4" name="TextBox 3"/>
+          <p:cNvPr id="5" name="TextBox 4"/>
           <p:cNvSpPr txBox="1"/>
           <p:nvPr/>
         </p:nvSpPr>
         <p:spPr>
           <a:xfrm>
-            <a:off x="777240" y="2110994"/>
-            <a:ext cx="10607040" cy="534416"/>
+            <a:off x="777240" y="1051560"/>
+            <a:ext cx="10607040" cy="914400"/>
           </a:xfrm>
           <a:prstGeom prst="rect">
             <a:avLst/>
@@ -6288,21 +6023,18 @@
           <a:noFill/>
         </p:spPr>
         <p:txBody>
-          <a:bodyPr wrap="square" lIns="25400" rIns="25400" tIns="12700" bIns="12700">
-            <a:noAutofit/>
+          <a:bodyPr wrap="square" anchor="t" lIns="0" rIns="0" tIns="0" bIns="0">
+            <a:spAutoFit/>
           </a:bodyPr>
           <a:lstStyle/>
           <a:p>
             <a:pPr algn="l">
               <a:lnSpc>
-                <a:spcPct val="106000"/>
+                <a:spcPct val="110000"/>
               </a:lnSpc>
-              <a:spcAft>
-                <a:spcPts val="400"/>
-              </a:spcAft>
             </a:pPr>
             <a:r>
-              <a:rPr sz="2600" b="0">
+              <a:rPr sz="3000" b="1" i="0">
                 <a:solidFill>
                   <a:srgbClr val="ECEFF3"/>
                 </a:solidFill>
@@ -6311,7 +6043,7 @@
               <a:t>2023: MASAI publishes its </a:t>
             </a:r>
             <a:r>
-              <a:rPr sz="2600" b="0">
+              <a:rPr sz="3000" b="1" i="0">
                 <a:solidFill>
                   <a:srgbClr val="E7AC51"/>
                 </a:solidFill>
@@ -6324,14 +6056,14 @@
       </p:sp>
       <p:sp>
         <p:nvSpPr>
-          <p:cNvPr id="5" name="TextBox 4"/>
+          <p:cNvPr id="6" name="TextBox 5"/>
           <p:cNvSpPr txBox="1"/>
           <p:nvPr/>
         </p:nvSpPr>
         <p:spPr>
           <a:xfrm>
-            <a:off x="777240" y="2645410"/>
-            <a:ext cx="10607040" cy="346456"/>
+            <a:off x="777240" y="2148840"/>
+            <a:ext cx="10424160" cy="640080"/>
           </a:xfrm>
           <a:prstGeom prst="rect">
             <a:avLst/>
@@ -6339,21 +6071,18 @@
           <a:noFill/>
         </p:spPr>
         <p:txBody>
-          <a:bodyPr wrap="square" lIns="25400" rIns="25400" tIns="12700" bIns="12700">
-            <a:noAutofit/>
+          <a:bodyPr wrap="square" anchor="t" lIns="0" rIns="0" tIns="0" bIns="0">
+            <a:spAutoFit/>
           </a:bodyPr>
           <a:lstStyle/>
           <a:p>
             <a:pPr algn="l">
               <a:lnSpc>
-                <a:spcPct val="128000"/>
+                <a:spcPct val="130000"/>
               </a:lnSpc>
-              <a:spcAft>
-                <a:spcPts val="400"/>
-              </a:spcAft>
             </a:pPr>
             <a:r>
-              <a:rPr sz="1400" b="0">
+              <a:rPr sz="1600" b="0" i="0">
                 <a:solidFill>
                   <a:srgbClr val="9DA9B5"/>
                 </a:solidFill>
@@ -6362,7 +6091,7 @@
               <a:t>A randomized trial, </a:t>
             </a:r>
             <a:r>
-              <a:rPr sz="1400" b="1">
+              <a:rPr sz="1600" b="1" i="0">
                 <a:solidFill>
                   <a:srgbClr val="ECEFF3"/>
                 </a:solidFill>
@@ -6371,7 +6100,7 @@
               <a:t>~80,000 women</a:t>
             </a:r>
             <a:r>
-              <a:rPr sz="1400" b="0">
+              <a:rPr sz="1600" b="0" i="0">
                 <a:solidFill>
                   <a:srgbClr val="9DA9B5"/>
                 </a:solidFill>
@@ -6384,14 +6113,14 @@
       </p:sp>
       <p:sp>
         <p:nvSpPr>
-          <p:cNvPr id="6" name="TextBox 5"/>
+          <p:cNvPr id="7" name="TextBox 6"/>
           <p:cNvSpPr txBox="1"/>
           <p:nvPr/>
         </p:nvSpPr>
         <p:spPr>
           <a:xfrm>
-            <a:off x="777240" y="2991866"/>
-            <a:ext cx="10607040" cy="346456"/>
+            <a:off x="777240" y="2971800"/>
+            <a:ext cx="10424160" cy="1005840"/>
           </a:xfrm>
           <a:prstGeom prst="rect">
             <a:avLst/>
@@ -6399,69 +6128,66 @@
           <a:noFill/>
         </p:spPr>
         <p:txBody>
-          <a:bodyPr wrap="square" lIns="25400" rIns="25400" tIns="12700" bIns="12700">
-            <a:noAutofit/>
+          <a:bodyPr wrap="square" anchor="t" lIns="0" rIns="0" tIns="0" bIns="0">
+            <a:spAutoFit/>
           </a:bodyPr>
           <a:lstStyle/>
           <a:p>
             <a:pPr algn="l">
               <a:lnSpc>
-                <a:spcPct val="128000"/>
+                <a:spcPct val="100000"/>
               </a:lnSpc>
-              <a:spcAft>
-                <a:spcPts val="400"/>
-              </a:spcAft>
             </a:pPr>
             <a:r>
-              <a:rPr sz="1400" b="0">
-                <a:solidFill>
-                  <a:srgbClr val="9DA9B5"/>
+              <a:rPr sz="5400" b="1" i="0">
+                <a:solidFill>
+                  <a:srgbClr val="E7AC51"/>
                 </a:solidFill>
                 <a:latin typeface="Arial"/>
               </a:rPr>
               <a:t>6.1 </a:t>
             </a:r>
             <a:r>
-              <a:rPr sz="1400" b="0">
-                <a:solidFill>
-                  <a:srgbClr val="9DA9B5"/>
+              <a:rPr sz="3000" b="0" i="0">
+                <a:solidFill>
+                  <a:srgbClr val="5C6975"/>
                 </a:solidFill>
                 <a:latin typeface="Arial"/>
               </a:rPr>
-              <a:t>vs</a:t>
-            </a:r>
-            <a:r>
-              <a:rPr sz="1400" b="0">
-                <a:solidFill>
-                  <a:srgbClr val="9DA9B5"/>
+              <a:t>vs </a:t>
+            </a:r>
+            <a:r>
+              <a:rPr sz="5400" b="1" i="0">
+                <a:solidFill>
+                  <a:srgbClr val="E7AC51"/>
                 </a:solidFill>
                 <a:latin typeface="Arial"/>
               </a:rPr>
-              <a:t> 5.1</a:t>
-            </a:r>
-            <a:r>
-              <a:rPr sz="1400" b="0">
-                <a:solidFill>
-                  <a:srgbClr val="9DA9B5"/>
-                </a:solidFill>
-                <a:latin typeface="Arial"/>
+              <a:t>5.1</a:t>
+            </a:r>
+            <a:r>
+              <a:rPr sz="1300" b="0" i="0">
+                <a:solidFill>
+                  <a:srgbClr val="ECEFF3"/>
+                </a:solidFill>
+                <a:latin typeface="Consolas"/>
               </a:rPr>
-              <a:t>CDR per 1,000 · ratio 1.2 (95% CI 1.0–1.5)</a:t>
+              <a:t>   CDR per 1,000 · ratio 1.2 (95% CI 1.0–1.5)</a:t>
             </a:r>
           </a:p>
         </p:txBody>
       </p:sp>
       <p:graphicFrame>
         <p:nvGraphicFramePr>
-          <p:cNvPr id="7" name="Table 6"/>
+          <p:cNvPr id="8" name="Table 7"/>
           <p:cNvGraphicFramePr>
             <a:graphicFrameLocks noGrp="1"/>
           </p:cNvGraphicFramePr>
           <p:nvPr/>
         </p:nvGraphicFramePr>
         <p:xfrm>
-          <a:off x="777240" y="3338322"/>
-          <a:ext cx="6949440" cy="1554480"/>
+          <a:off x="777240" y="4297680"/>
+          <a:ext cx="6949438" cy="1645919"/>
         </p:xfrm>
         <a:graphic>
           <a:graphicData uri="http://schemas.openxmlformats.org/drawingml/2006/table">
@@ -6470,11 +6196,11 @@
                 <a:tableStyleId>{5C22544A-7EE6-4342-B048-85BDC9FD1C3A}</a:tableStyleId>
               </a:tblPr>
               <a:tblGrid>
-                <a:gridCol w="2316480"/>
-                <a:gridCol w="2316480"/>
-                <a:gridCol w="2316480"/>
+                <a:gridCol w="3291840"/>
+                <a:gridCol w="1828799"/>
+                <a:gridCol w="1828799"/>
               </a:tblGrid>
-              <a:tr h="310896">
+              <a:tr h="329183">
                 <a:tc>
                   <a:txBody>
                     <a:bodyPr/>
@@ -6482,7 +6208,7 @@
                     <a:p>
                       <a:pPr algn="l"/>
                       <a:r>
-                        <a:rPr sz="1000" b="1">
+                        <a:rPr sz="1250" b="1">
                           <a:solidFill>
                             <a:srgbClr val="E7AC51"/>
                           </a:solidFill>
@@ -6492,78 +6218,7 @@
                       </a:r>
                     </a:p>
                   </a:txBody>
-                  <a:tcPr marL="50800" marR="50800" marT="12700" marB="12700">
-                    <a:solidFill>
-                      <a:srgbClr val="1B232D"/>
-                    </a:solidFill>
-                  </a:tcPr>
-                </a:tc>
-                <a:tc>
-                  <a:txBody>
-                    <a:bodyPr/>
-                    <a:lstStyle/>
-                    <a:p>
-                      <a:pPr algn="ctr"/>
-                      <a:r>
-                        <a:rPr sz="1000" b="1">
-                          <a:solidFill>
-                            <a:srgbClr val="E7AC51"/>
-                          </a:solidFill>
-                          <a:latin typeface="Arial"/>
-                        </a:rPr>
-                        <a:t>AI</a:t>
-                      </a:r>
-                    </a:p>
-                  </a:txBody>
-                  <a:tcPr marL="50800" marR="50800" marT="12700" marB="12700">
-                    <a:solidFill>
-                      <a:srgbClr val="1B232D"/>
-                    </a:solidFill>
-                  </a:tcPr>
-                </a:tc>
-                <a:tc>
-                  <a:txBody>
-                    <a:bodyPr/>
-                    <a:lstStyle/>
-                    <a:p>
-                      <a:pPr algn="ctr"/>
-                      <a:r>
-                        <a:rPr sz="1000" b="1">
-                          <a:solidFill>
-                            <a:srgbClr val="E7AC51"/>
-                          </a:solidFill>
-                          <a:latin typeface="Arial"/>
-                        </a:rPr>
-                        <a:t>Control</a:t>
-                      </a:r>
-                    </a:p>
-                  </a:txBody>
-                  <a:tcPr marL="50800" marR="50800" marT="12700" marB="12700">
-                    <a:solidFill>
-                      <a:srgbClr val="1B232D"/>
-                    </a:solidFill>
-                  </a:tcPr>
-                </a:tc>
-              </a:tr>
-              <a:tr h="310896">
-                <a:tc>
-                  <a:txBody>
-                    <a:bodyPr/>
-                    <a:lstStyle/>
-                    <a:p>
-                      <a:pPr algn="l"/>
-                      <a:r>
-                        <a:rPr sz="1000" b="0">
-                          <a:solidFill>
-                            <a:srgbClr val="ECEFF3"/>
-                          </a:solidFill>
-                          <a:latin typeface="Arial"/>
-                        </a:rPr>
-                        <a:t>Recall rate</a:t>
-                      </a:r>
-                    </a:p>
-                  </a:txBody>
-                  <a:tcPr marL="50800" marR="50800" marT="12700" marB="12700">
+                  <a:tcPr anchor="ctr" marL="73152" marR="73152" marT="25400" marB="25400">
                     <a:solidFill>
                       <a:srgbClr val="0F141A"/>
                     </a:solidFill>
@@ -6576,17 +6231,17 @@
                     <a:p>
                       <a:pPr algn="ctr"/>
                       <a:r>
-                        <a:rPr sz="1000" b="0">
+                        <a:rPr sz="1250" b="1">
                           <a:solidFill>
-                            <a:srgbClr val="9DA9B5"/>
+                            <a:srgbClr val="E7AC51"/>
                           </a:solidFill>
                           <a:latin typeface="Arial"/>
                         </a:rPr>
-                        <a:t>2.2%</a:t>
+                        <a:t>AI</a:t>
                       </a:r>
                     </a:p>
                   </a:txBody>
-                  <a:tcPr marL="50800" marR="50800" marT="12700" marB="12700">
+                  <a:tcPr anchor="ctr" marL="73152" marR="73152" marT="25400" marB="25400">
                     <a:solidFill>
                       <a:srgbClr val="0F141A"/>
                     </a:solidFill>
@@ -6599,24 +6254,24 @@
                     <a:p>
                       <a:pPr algn="ctr"/>
                       <a:r>
-                        <a:rPr sz="1000" b="0">
+                        <a:rPr sz="1250" b="1">
                           <a:solidFill>
-                            <a:srgbClr val="9DA9B5"/>
+                            <a:srgbClr val="E7AC51"/>
                           </a:solidFill>
                           <a:latin typeface="Arial"/>
                         </a:rPr>
-                        <a:t>2.0%</a:t>
+                        <a:t>Control</a:t>
                       </a:r>
                     </a:p>
                   </a:txBody>
-                  <a:tcPr marL="50800" marR="50800" marT="12700" marB="12700">
+                  <a:tcPr anchor="ctr" marL="73152" marR="73152" marT="25400" marB="25400">
                     <a:solidFill>
                       <a:srgbClr val="0F141A"/>
                     </a:solidFill>
                   </a:tcPr>
                 </a:tc>
               </a:tr>
-              <a:tr h="310896">
+              <a:tr h="329183">
                 <a:tc>
                   <a:txBody>
                     <a:bodyPr/>
@@ -6624,17 +6279,17 @@
                     <a:p>
                       <a:pPr algn="l"/>
                       <a:r>
-                        <a:rPr sz="1000" b="0">
+                        <a:rPr sz="1250" b="0">
                           <a:solidFill>
                             <a:srgbClr val="ECEFF3"/>
                           </a:solidFill>
                           <a:latin typeface="Arial"/>
                         </a:rPr>
-                        <a:t>False-positive rate</a:t>
+                        <a:t>Recall rate</a:t>
                       </a:r>
                     </a:p>
                   </a:txBody>
-                  <a:tcPr marL="50800" marR="50800" marT="12700" marB="12700">
+                  <a:tcPr anchor="ctr" marL="73152" marR="73152" marT="25400" marB="25400">
                     <a:solidFill>
                       <a:srgbClr val="0F141A"/>
                     </a:solidFill>
@@ -6647,17 +6302,17 @@
                     <a:p>
                       <a:pPr algn="ctr"/>
                       <a:r>
-                        <a:rPr sz="1000" b="0">
+                        <a:rPr sz="1250" b="0">
                           <a:solidFill>
                             <a:srgbClr val="9DA9B5"/>
                           </a:solidFill>
                           <a:latin typeface="Arial"/>
                         </a:rPr>
-                        <a:t>1.5%</a:t>
+                        <a:t>2.2%</a:t>
                       </a:r>
                     </a:p>
                   </a:txBody>
-                  <a:tcPr marL="50800" marR="50800" marT="12700" marB="12700">
+                  <a:tcPr anchor="ctr" marL="73152" marR="73152" marT="25400" marB="25400">
                     <a:solidFill>
                       <a:srgbClr val="0F141A"/>
                     </a:solidFill>
@@ -6670,24 +6325,24 @@
                     <a:p>
                       <a:pPr algn="ctr"/>
                       <a:r>
-                        <a:rPr sz="1000" b="0">
+                        <a:rPr sz="1250" b="0">
                           <a:solidFill>
                             <a:srgbClr val="9DA9B5"/>
                           </a:solidFill>
                           <a:latin typeface="Arial"/>
                         </a:rPr>
-                        <a:t>1.5%</a:t>
+                        <a:t>2.0%</a:t>
                       </a:r>
                     </a:p>
                   </a:txBody>
-                  <a:tcPr marL="50800" marR="50800" marT="12700" marB="12700">
+                  <a:tcPr anchor="ctr" marL="73152" marR="73152" marT="25400" marB="25400">
                     <a:solidFill>
                       <a:srgbClr val="0F141A"/>
                     </a:solidFill>
                   </a:tcPr>
                 </a:tc>
               </a:tr>
-              <a:tr h="310896">
+              <a:tr h="329183">
                 <a:tc>
                   <a:txBody>
                     <a:bodyPr/>
@@ -6695,17 +6350,17 @@
                     <a:p>
                       <a:pPr algn="l"/>
                       <a:r>
-                        <a:rPr sz="1000" b="0">
+                        <a:rPr sz="1250" b="0">
                           <a:solidFill>
                             <a:srgbClr val="ECEFF3"/>
                           </a:solidFill>
                           <a:latin typeface="Arial"/>
                         </a:rPr>
-                        <a:t>PPV of recall</a:t>
+                        <a:t>False-positive rate</a:t>
                       </a:r>
                     </a:p>
                   </a:txBody>
-                  <a:tcPr marL="50800" marR="50800" marT="12700" marB="12700">
+                  <a:tcPr anchor="ctr" marL="73152" marR="73152" marT="25400" marB="25400">
                     <a:solidFill>
                       <a:srgbClr val="0F141A"/>
                     </a:solidFill>
@@ -6718,17 +6373,17 @@
                     <a:p>
                       <a:pPr algn="ctr"/>
                       <a:r>
-                        <a:rPr sz="1000" b="0">
+                        <a:rPr sz="1250" b="0">
                           <a:solidFill>
                             <a:srgbClr val="9DA9B5"/>
                           </a:solidFill>
                           <a:latin typeface="Arial"/>
                         </a:rPr>
-                        <a:t>28.3%</a:t>
+                        <a:t>1.5%</a:t>
                       </a:r>
                     </a:p>
                   </a:txBody>
-                  <a:tcPr marL="50800" marR="50800" marT="12700" marB="12700">
+                  <a:tcPr anchor="ctr" marL="73152" marR="73152" marT="25400" marB="25400">
                     <a:solidFill>
                       <a:srgbClr val="0F141A"/>
                     </a:solidFill>
@@ -6741,24 +6396,24 @@
                     <a:p>
                       <a:pPr algn="ctr"/>
                       <a:r>
-                        <a:rPr sz="1000" b="0">
+                        <a:rPr sz="1250" b="0">
                           <a:solidFill>
                             <a:srgbClr val="9DA9B5"/>
                           </a:solidFill>
                           <a:latin typeface="Arial"/>
                         </a:rPr>
-                        <a:t>24.8%</a:t>
+                        <a:t>1.5%</a:t>
                       </a:r>
                     </a:p>
                   </a:txBody>
-                  <a:tcPr marL="50800" marR="50800" marT="12700" marB="12700">
+                  <a:tcPr anchor="ctr" marL="73152" marR="73152" marT="25400" marB="25400">
                     <a:solidFill>
                       <a:srgbClr val="0F141A"/>
                     </a:solidFill>
                   </a:tcPr>
                 </a:tc>
               </a:tr>
-              <a:tr h="310896">
+              <a:tr h="329183">
                 <a:tc>
                   <a:txBody>
                     <a:bodyPr/>
@@ -6766,17 +6421,17 @@
                     <a:p>
                       <a:pPr algn="l"/>
                       <a:r>
-                        <a:rPr sz="1000" b="0">
+                        <a:rPr sz="1250" b="0">
                           <a:solidFill>
                             <a:srgbClr val="ECEFF3"/>
                           </a:solidFill>
                           <a:latin typeface="Arial"/>
                         </a:rPr>
-                        <a:t>Invasive cancers</a:t>
+                        <a:t>PPV of recall</a:t>
                       </a:r>
                     </a:p>
                   </a:txBody>
-                  <a:tcPr marL="50800" marR="50800" marT="12700" marB="12700">
+                  <a:tcPr anchor="ctr" marL="73152" marR="73152" marT="25400" marB="25400">
                     <a:solidFill>
                       <a:srgbClr val="0F141A"/>
                     </a:solidFill>
@@ -6789,17 +6444,17 @@
                     <a:p>
                       <a:pPr algn="ctr"/>
                       <a:r>
-                        <a:rPr sz="1000" b="0">
+                        <a:rPr sz="1250" b="0">
                           <a:solidFill>
                             <a:srgbClr val="9DA9B5"/>
                           </a:solidFill>
                           <a:latin typeface="Arial"/>
                         </a:rPr>
-                        <a:t>75%</a:t>
+                        <a:t>28.3%</a:t>
                       </a:r>
                     </a:p>
                   </a:txBody>
-                  <a:tcPr marL="50800" marR="50800" marT="12700" marB="12700">
+                  <a:tcPr anchor="ctr" marL="73152" marR="73152" marT="25400" marB="25400">
                     <a:solidFill>
                       <a:srgbClr val="0F141A"/>
                     </a:solidFill>
@@ -6812,7 +6467,78 @@
                     <a:p>
                       <a:pPr algn="ctr"/>
                       <a:r>
-                        <a:rPr sz="1000" b="0">
+                        <a:rPr sz="1250" b="0">
+                          <a:solidFill>
+                            <a:srgbClr val="9DA9B5"/>
+                          </a:solidFill>
+                          <a:latin typeface="Arial"/>
+                        </a:rPr>
+                        <a:t>24.8%</a:t>
+                      </a:r>
+                    </a:p>
+                  </a:txBody>
+                  <a:tcPr anchor="ctr" marL="73152" marR="73152" marT="25400" marB="25400">
+                    <a:solidFill>
+                      <a:srgbClr val="0F141A"/>
+                    </a:solidFill>
+                  </a:tcPr>
+                </a:tc>
+              </a:tr>
+              <a:tr h="329187">
+                <a:tc>
+                  <a:txBody>
+                    <a:bodyPr/>
+                    <a:lstStyle/>
+                    <a:p>
+                      <a:pPr algn="l"/>
+                      <a:r>
+                        <a:rPr sz="1250" b="0">
+                          <a:solidFill>
+                            <a:srgbClr val="ECEFF3"/>
+                          </a:solidFill>
+                          <a:latin typeface="Arial"/>
+                        </a:rPr>
+                        <a:t>Invasive cancers</a:t>
+                      </a:r>
+                    </a:p>
+                  </a:txBody>
+                  <a:tcPr anchor="ctr" marL="73152" marR="73152" marT="25400" marB="25400">
+                    <a:solidFill>
+                      <a:srgbClr val="0F141A"/>
+                    </a:solidFill>
+                  </a:tcPr>
+                </a:tc>
+                <a:tc>
+                  <a:txBody>
+                    <a:bodyPr/>
+                    <a:lstStyle/>
+                    <a:p>
+                      <a:pPr algn="ctr"/>
+                      <a:r>
+                        <a:rPr sz="1250" b="0">
+                          <a:solidFill>
+                            <a:srgbClr val="9DA9B5"/>
+                          </a:solidFill>
+                          <a:latin typeface="Arial"/>
+                        </a:rPr>
+                        <a:t>75%</a:t>
+                      </a:r>
+                    </a:p>
+                  </a:txBody>
+                  <a:tcPr anchor="ctr" marL="73152" marR="73152" marT="25400" marB="25400">
+                    <a:solidFill>
+                      <a:srgbClr val="0F141A"/>
+                    </a:solidFill>
+                  </a:tcPr>
+                </a:tc>
+                <a:tc>
+                  <a:txBody>
+                    <a:bodyPr/>
+                    <a:lstStyle/>
+                    <a:p>
+                      <a:pPr algn="ctr"/>
+                      <a:r>
+                        <a:rPr sz="1250" b="0">
                           <a:solidFill>
                             <a:srgbClr val="9DA9B5"/>
                           </a:solidFill>
@@ -6822,7 +6548,7 @@
                       </a:r>
                     </a:p>
                   </a:txBody>
-                  <a:tcPr marL="50800" marR="50800" marT="12700" marB="12700">
+                  <a:tcPr anchor="ctr" marL="73152" marR="73152" marT="25400" marB="25400">
                     <a:solidFill>
                       <a:srgbClr val="0F141A"/>
                     </a:solidFill>
@@ -6835,14 +6561,14 @@
       </p:graphicFrame>
       <p:sp>
         <p:nvSpPr>
-          <p:cNvPr id="8" name="TextBox 7"/>
+          <p:cNvPr id="9" name="TextBox 8"/>
           <p:cNvSpPr txBox="1"/>
           <p:nvPr/>
         </p:nvSpPr>
         <p:spPr>
           <a:xfrm>
-            <a:off x="777240" y="5057394"/>
-            <a:ext cx="10607040" cy="256540"/>
+            <a:off x="777240" y="6355080"/>
+            <a:ext cx="10515600" cy="365760"/>
           </a:xfrm>
           <a:prstGeom prst="rect">
             <a:avLst/>
@@ -6850,27 +6576,24 @@
           <a:noFill/>
         </p:spPr>
         <p:txBody>
-          <a:bodyPr wrap="square" lIns="25400" rIns="25400" tIns="12700" bIns="12700">
-            <a:noAutofit/>
+          <a:bodyPr wrap="square" anchor="t" lIns="0" rIns="0" tIns="0" bIns="0">
+            <a:spAutoFit/>
           </a:bodyPr>
           <a:lstStyle/>
           <a:p>
             <a:pPr algn="l">
               <a:lnSpc>
-                <a:spcPct val="130000"/>
+                <a:spcPct val="100000"/>
               </a:lnSpc>
-              <a:spcAft>
-                <a:spcPts val="400"/>
-              </a:spcAft>
             </a:pPr>
             <a:r>
-              <a:rPr sz="1000" b="0">
+              <a:rPr sz="1000" b="0" i="0">
                 <a:solidFill>
                   <a:srgbClr val="5C6975"/>
                 </a:solidFill>
                 <a:latin typeface="Consolas"/>
               </a:rPr>
-              <a:t>Lång et al., Lancet Oncology 2023 — above the lowest acceptable detection limit for safety</a:t>
+              <a:t>Lång et al., Lancet Oncology 2023 — above the lowest acceptable detection limit for safety.</a:t>
             </a:r>
           </a:p>
         </p:txBody>
@@ -6901,16 +6624,40 @@
         <p:nvPr/>
       </p:nvGrpSpPr>
       <p:grpSpPr/>
-      <p:sp>
-        <p:nvSpPr>
-          <p:cNvPr id="2" name="Rectangle 1"/>
+      <p:pic>
+        <p:nvPicPr>
+          <p:cNvPr id="2" name="Picture 1" descr="bg_motif.png"/>
+          <p:cNvPicPr>
+            <a:picLocks noChangeAspect="1"/>
+          </p:cNvPicPr>
+          <p:nvPr/>
+        </p:nvPicPr>
+        <p:blipFill>
+          <a:blip r:embed="rId2"/>
+          <a:stretch>
+            <a:fillRect/>
+          </a:stretch>
+        </p:blipFill>
+        <p:spPr>
+          <a:xfrm>
+            <a:off x="0" y="0"/>
+            <a:ext cx="12191695" cy="6858000"/>
+          </a:xfrm>
+          <a:prstGeom prst="rect">
+            <a:avLst/>
+          </a:prstGeom>
+        </p:spPr>
+      </p:pic>
+      <p:sp>
+        <p:nvSpPr>
+          <p:cNvPr id="3" name="Rectangle 2"/>
           <p:cNvSpPr/>
           <p:nvPr/>
         </p:nvSpPr>
         <p:spPr>
           <a:xfrm>
             <a:off x="0" y="0"/>
-            <a:ext cx="12191695" cy="38100"/>
+            <a:ext cx="5486400" cy="38100"/>
           </a:xfrm>
           <a:prstGeom prst="rect">
             <a:avLst/>
@@ -6947,14 +6694,14 @@
       </p:sp>
       <p:sp>
         <p:nvSpPr>
-          <p:cNvPr id="3" name="TextBox 2"/>
+          <p:cNvPr id="4" name="TextBox 3"/>
           <p:cNvSpPr txBox="1"/>
           <p:nvPr/>
         </p:nvSpPr>
         <p:spPr>
           <a:xfrm>
-            <a:off x="777240" y="411480"/>
-            <a:ext cx="8686800" cy="365760"/>
+            <a:off x="777240" y="502920"/>
+            <a:ext cx="8229600" cy="320040"/>
           </a:xfrm>
           <a:prstGeom prst="rect">
             <a:avLst/>
@@ -6962,21 +6709,18 @@
           <a:noFill/>
         </p:spPr>
         <p:txBody>
-          <a:bodyPr wrap="square" lIns="25400" rIns="25400" tIns="12700" bIns="12700">
-            <a:noAutofit/>
+          <a:bodyPr wrap="square" anchor="t" lIns="0" rIns="0" tIns="0" bIns="0">
+            <a:spAutoFit/>
           </a:bodyPr>
           <a:lstStyle/>
           <a:p>
             <a:pPr algn="l">
               <a:lnSpc>
-                <a:spcPct val="128000"/>
+                <a:spcPct val="100000"/>
               </a:lnSpc>
-              <a:spcAft>
-                <a:spcPts val="400"/>
-              </a:spcAft>
             </a:pPr>
             <a:r>
-              <a:rPr sz="1100" b="1">
+              <a:rPr sz="1100" b="1" i="0">
                 <a:solidFill>
                   <a:srgbClr val="E7AC51"/>
                 </a:solidFill>
@@ -6989,14 +6733,14 @@
       </p:sp>
       <p:sp>
         <p:nvSpPr>
-          <p:cNvPr id="4" name="TextBox 3"/>
+          <p:cNvPr id="5" name="TextBox 4"/>
           <p:cNvSpPr txBox="1"/>
           <p:nvPr/>
         </p:nvSpPr>
         <p:spPr>
           <a:xfrm>
-            <a:off x="777240" y="1712468"/>
-            <a:ext cx="10607040" cy="534416"/>
+            <a:off x="777240" y="1143000"/>
+            <a:ext cx="10607040" cy="914400"/>
           </a:xfrm>
           <a:prstGeom prst="rect">
             <a:avLst/>
@@ -7004,21 +6748,18 @@
           <a:noFill/>
         </p:spPr>
         <p:txBody>
-          <a:bodyPr wrap="square" lIns="25400" rIns="25400" tIns="12700" bIns="12700">
-            <a:noAutofit/>
+          <a:bodyPr wrap="square" anchor="t" lIns="0" rIns="0" tIns="0" bIns="0">
+            <a:spAutoFit/>
           </a:bodyPr>
           <a:lstStyle/>
           <a:p>
             <a:pPr algn="l">
               <a:lnSpc>
-                <a:spcPct val="106000"/>
+                <a:spcPct val="110000"/>
               </a:lnSpc>
-              <a:spcAft>
-                <a:spcPts val="400"/>
-              </a:spcAft>
             </a:pPr>
             <a:r>
-              <a:rPr sz="2600" b="0">
+              <a:rPr sz="3000" b="1" i="0">
                 <a:solidFill>
                   <a:srgbClr val="ECEFF3"/>
                 </a:solidFill>
@@ -7027,7 +6768,7 @@
               <a:t>Data isn't enough to </a:t>
             </a:r>
             <a:r>
-              <a:rPr sz="2600" b="0">
+              <a:rPr sz="3000" b="1" i="0">
                 <a:solidFill>
                   <a:srgbClr val="E7AC51"/>
                 </a:solidFill>
@@ -7040,14 +6781,14 @@
       </p:sp>
       <p:sp>
         <p:nvSpPr>
-          <p:cNvPr id="5" name="TextBox 4"/>
+          <p:cNvPr id="6" name="TextBox 5"/>
           <p:cNvSpPr txBox="1"/>
           <p:nvPr/>
         </p:nvSpPr>
         <p:spPr>
           <a:xfrm>
-            <a:off x="777240" y="2246884"/>
-            <a:ext cx="10607040" cy="574040"/>
+            <a:off x="777240" y="2286000"/>
+            <a:ext cx="10424160" cy="640080"/>
           </a:xfrm>
           <a:prstGeom prst="rect">
             <a:avLst/>
@@ -7055,21 +6796,18 @@
           <a:noFill/>
         </p:spPr>
         <p:txBody>
-          <a:bodyPr wrap="square" lIns="25400" rIns="25400" tIns="12700" bIns="12700">
-            <a:noAutofit/>
+          <a:bodyPr wrap="square" anchor="t" lIns="0" rIns="0" tIns="0" bIns="0">
+            <a:spAutoFit/>
           </a:bodyPr>
           <a:lstStyle/>
           <a:p>
             <a:pPr algn="l">
               <a:lnSpc>
-                <a:spcPct val="128000"/>
+                <a:spcPct val="130000"/>
               </a:lnSpc>
-              <a:spcAft>
-                <a:spcPts val="400"/>
-              </a:spcAft>
             </a:pPr>
             <a:r>
-              <a:rPr sz="1400" b="0">
+              <a:rPr sz="1500" b="0" i="0">
                 <a:solidFill>
                   <a:srgbClr val="9DA9B5"/>
                 </a:solidFill>
@@ -7082,14 +6820,14 @@
       </p:sp>
       <p:sp>
         <p:nvSpPr>
-          <p:cNvPr id="6" name="TextBox 5"/>
+          <p:cNvPr id="7" name="TextBox 6"/>
           <p:cNvSpPr txBox="1"/>
           <p:nvPr/>
         </p:nvSpPr>
         <p:spPr>
           <a:xfrm>
-            <a:off x="777240" y="2820924"/>
-            <a:ext cx="10607040" cy="525780"/>
+            <a:off x="777240" y="3383280"/>
+            <a:ext cx="3291840" cy="914400"/>
           </a:xfrm>
           <a:prstGeom prst="rect">
             <a:avLst/>
@@ -7097,21 +6835,18 @@
           <a:noFill/>
         </p:spPr>
         <p:txBody>
-          <a:bodyPr wrap="square" lIns="25400" rIns="25400" tIns="12700" bIns="12700">
-            <a:noAutofit/>
+          <a:bodyPr wrap="square" anchor="t" lIns="0" rIns="0" tIns="0" bIns="0">
+            <a:spAutoFit/>
           </a:bodyPr>
           <a:lstStyle/>
           <a:p>
             <a:pPr algn="l">
               <a:lnSpc>
-                <a:spcPct val="112000"/>
+                <a:spcPct val="100000"/>
               </a:lnSpc>
-              <a:spcAft>
-                <a:spcPts val="400"/>
-              </a:spcAft>
             </a:pPr>
             <a:r>
-              <a:rPr sz="3000" b="0">
+              <a:rPr sz="4600" b="1" i="0">
                 <a:solidFill>
                   <a:srgbClr val="E7AC51"/>
                 </a:solidFill>
@@ -7124,14 +6859,14 @@
       </p:sp>
       <p:sp>
         <p:nvSpPr>
-          <p:cNvPr id="7" name="TextBox 6"/>
+          <p:cNvPr id="8" name="TextBox 7"/>
           <p:cNvSpPr txBox="1"/>
           <p:nvPr/>
         </p:nvSpPr>
         <p:spPr>
           <a:xfrm>
-            <a:off x="777240" y="3346704"/>
-            <a:ext cx="10607040" cy="346456"/>
+            <a:off x="777240" y="4434840"/>
+            <a:ext cx="3291840" cy="1280160"/>
           </a:xfrm>
           <a:prstGeom prst="rect">
             <a:avLst/>
@@ -7139,25 +6874,22 @@
           <a:noFill/>
         </p:spPr>
         <p:txBody>
-          <a:bodyPr wrap="square" lIns="25400" rIns="25400" tIns="12700" bIns="12700">
-            <a:noAutofit/>
+          <a:bodyPr wrap="square" anchor="t" lIns="0" rIns="0" tIns="0" bIns="0">
+            <a:spAutoFit/>
           </a:bodyPr>
           <a:lstStyle/>
           <a:p>
             <a:pPr algn="l">
               <a:lnSpc>
-                <a:spcPct val="128000"/>
+                <a:spcPct val="130000"/>
               </a:lnSpc>
-              <a:spcAft>
-                <a:spcPts val="400"/>
-              </a:spcAft>
             </a:pPr>
             <a:r>
-              <a:rPr sz="1400" b="0">
-                <a:solidFill>
-                  <a:srgbClr val="9DA9B5"/>
-                </a:solidFill>
-                <a:latin typeface="Arial"/>
+              <a:rPr sz="1150" b="0" i="0">
+                <a:solidFill>
+                  <a:srgbClr val="ECEFF3"/>
+                </a:solidFill>
+                <a:latin typeface="Consolas"/>
               </a:rPr>
               <a:t>European radiologists use AI (2024) — up from 20% in 2018</a:t>
             </a:r>
@@ -7166,14 +6898,14 @@
       </p:sp>
       <p:sp>
         <p:nvSpPr>
-          <p:cNvPr id="8" name="TextBox 7"/>
+          <p:cNvPr id="9" name="TextBox 8"/>
           <p:cNvSpPr txBox="1"/>
           <p:nvPr/>
         </p:nvSpPr>
         <p:spPr>
           <a:xfrm>
-            <a:off x="777240" y="3693160"/>
-            <a:ext cx="10607040" cy="525780"/>
+            <a:off x="4434840" y="3383280"/>
+            <a:ext cx="3291840" cy="914400"/>
           </a:xfrm>
           <a:prstGeom prst="rect">
             <a:avLst/>
@@ -7181,21 +6913,18 @@
           <a:noFill/>
         </p:spPr>
         <p:txBody>
-          <a:bodyPr wrap="square" lIns="25400" rIns="25400" tIns="12700" bIns="12700">
-            <a:noAutofit/>
+          <a:bodyPr wrap="square" anchor="t" lIns="0" rIns="0" tIns="0" bIns="0">
+            <a:spAutoFit/>
           </a:bodyPr>
           <a:lstStyle/>
           <a:p>
             <a:pPr algn="l">
               <a:lnSpc>
-                <a:spcPct val="112000"/>
+                <a:spcPct val="100000"/>
               </a:lnSpc>
-              <a:spcAft>
-                <a:spcPts val="400"/>
-              </a:spcAft>
             </a:pPr>
             <a:r>
-              <a:rPr sz="3000" b="0">
+              <a:rPr sz="4600" b="1" i="0">
                 <a:solidFill>
                   <a:srgbClr val="E7AC51"/>
                 </a:solidFill>
@@ -7208,14 +6937,14 @@
       </p:sp>
       <p:sp>
         <p:nvSpPr>
-          <p:cNvPr id="9" name="TextBox 8"/>
+          <p:cNvPr id="10" name="TextBox 9"/>
           <p:cNvSpPr txBox="1"/>
           <p:nvPr/>
         </p:nvSpPr>
         <p:spPr>
           <a:xfrm>
-            <a:off x="777240" y="4218940"/>
-            <a:ext cx="10607040" cy="346456"/>
+            <a:off x="4434840" y="4434840"/>
+            <a:ext cx="3291840" cy="1280160"/>
           </a:xfrm>
           <a:prstGeom prst="rect">
             <a:avLst/>
@@ -7223,50 +6952,38 @@
           <a:noFill/>
         </p:spPr>
         <p:txBody>
-          <a:bodyPr wrap="square" lIns="25400" rIns="25400" tIns="12700" bIns="12700">
-            <a:noAutofit/>
+          <a:bodyPr wrap="square" anchor="t" lIns="0" rIns="0" tIns="0" bIns="0">
+            <a:spAutoFit/>
           </a:bodyPr>
           <a:lstStyle/>
           <a:p>
             <a:pPr algn="l">
               <a:lnSpc>
-                <a:spcPct val="128000"/>
+                <a:spcPct val="130000"/>
               </a:lnSpc>
-              <a:spcAft>
-                <a:spcPts val="400"/>
-              </a:spcAft>
             </a:pPr>
             <a:r>
-              <a:rPr sz="1400" b="0">
-                <a:solidFill>
-                  <a:srgbClr val="9DA9B5"/>
-                </a:solidFill>
-                <a:latin typeface="Arial"/>
+              <a:rPr sz="1150" b="0" i="0">
+                <a:solidFill>
+                  <a:srgbClr val="ECEFF3"/>
+                </a:solidFill>
+                <a:latin typeface="Consolas"/>
               </a:rPr>
-              <a:t>of them, for breast imaging — </a:t>
-            </a:r>
-            <a:r>
-              <a:rPr sz="1400" b="0">
-                <a:solidFill>
-                  <a:srgbClr val="5FB7C9"/>
-                </a:solidFill>
-                <a:latin typeface="Arial"/>
-              </a:rPr>
-              <a:t>about 1 in 8</a:t>
-            </a:r>
-          </a:p>
-        </p:txBody>
-      </p:sp>
-      <p:sp>
-        <p:nvSpPr>
-          <p:cNvPr id="10" name="TextBox 9"/>
+              <a:t>of them, for breast imaging — about 1 in 8</a:t>
+            </a:r>
+          </a:p>
+        </p:txBody>
+      </p:sp>
+      <p:sp>
+        <p:nvSpPr>
+          <p:cNvPr id="11" name="TextBox 10"/>
           <p:cNvSpPr txBox="1"/>
           <p:nvPr/>
         </p:nvSpPr>
         <p:spPr>
           <a:xfrm>
-            <a:off x="777240" y="4565396"/>
-            <a:ext cx="10607040" cy="525780"/>
+            <a:off x="8092440" y="3383280"/>
+            <a:ext cx="3291840" cy="914400"/>
           </a:xfrm>
           <a:prstGeom prst="rect">
             <a:avLst/>
@@ -7274,21 +6991,18 @@
           <a:noFill/>
         </p:spPr>
         <p:txBody>
-          <a:bodyPr wrap="square" lIns="25400" rIns="25400" tIns="12700" bIns="12700">
-            <a:noAutofit/>
+          <a:bodyPr wrap="square" anchor="t" lIns="0" rIns="0" tIns="0" bIns="0">
+            <a:spAutoFit/>
           </a:bodyPr>
           <a:lstStyle/>
           <a:p>
             <a:pPr algn="l">
               <a:lnSpc>
-                <a:spcPct val="112000"/>
+                <a:spcPct val="100000"/>
               </a:lnSpc>
-              <a:spcAft>
-                <a:spcPts val="400"/>
-              </a:spcAft>
             </a:pPr>
             <a:r>
-              <a:rPr sz="3000" b="0">
+              <a:rPr sz="4600" b="1" i="0">
                 <a:solidFill>
                   <a:srgbClr val="E7AC51"/>
                 </a:solidFill>
@@ -7301,14 +7015,14 @@
       </p:sp>
       <p:sp>
         <p:nvSpPr>
-          <p:cNvPr id="11" name="TextBox 10"/>
+          <p:cNvPr id="12" name="TextBox 11"/>
           <p:cNvSpPr txBox="1"/>
           <p:nvPr/>
         </p:nvSpPr>
         <p:spPr>
           <a:xfrm>
-            <a:off x="777240" y="5091176"/>
-            <a:ext cx="10607040" cy="346456"/>
+            <a:off x="8092440" y="4434840"/>
+            <a:ext cx="3291840" cy="1280160"/>
           </a:xfrm>
           <a:prstGeom prst="rect">
             <a:avLst/>
@@ -7316,25 +7030,22 @@
           <a:noFill/>
         </p:spPr>
         <p:txBody>
-          <a:bodyPr wrap="square" lIns="25400" rIns="25400" tIns="12700" bIns="12700">
-            <a:noAutofit/>
+          <a:bodyPr wrap="square" anchor="t" lIns="0" rIns="0" tIns="0" bIns="0">
+            <a:spAutoFit/>
           </a:bodyPr>
           <a:lstStyle/>
           <a:p>
             <a:pPr algn="l">
               <a:lnSpc>
-                <a:spcPct val="128000"/>
+                <a:spcPct val="130000"/>
               </a:lnSpc>
-              <a:spcAft>
-                <a:spcPts val="400"/>
-              </a:spcAft>
             </a:pPr>
             <a:r>
-              <a:rPr sz="1400" b="0">
-                <a:solidFill>
-                  <a:srgbClr val="9DA9B5"/>
-                </a:solidFill>
-                <a:latin typeface="Arial"/>
+              <a:rPr sz="1150" b="0" i="0">
+                <a:solidFill>
+                  <a:srgbClr val="ECEFF3"/>
+                </a:solidFill>
+                <a:latin typeface="Consolas"/>
               </a:rPr>
               <a:t>of US practices, by one estimate</a:t>
             </a:r>
@@ -7343,14 +7054,14 @@
       </p:sp>
       <p:sp>
         <p:nvSpPr>
-          <p:cNvPr id="12" name="TextBox 11"/>
+          <p:cNvPr id="13" name="TextBox 12"/>
           <p:cNvSpPr txBox="1"/>
           <p:nvPr/>
         </p:nvSpPr>
         <p:spPr>
           <a:xfrm>
-            <a:off x="777240" y="5437632"/>
-            <a:ext cx="10607040" cy="256540"/>
+            <a:off x="777240" y="6035040"/>
+            <a:ext cx="10515600" cy="365760"/>
           </a:xfrm>
           <a:prstGeom prst="rect">
             <a:avLst/>
@@ -7358,27 +7069,24 @@
           <a:noFill/>
         </p:spPr>
         <p:txBody>
-          <a:bodyPr wrap="square" lIns="25400" rIns="25400" tIns="12700" bIns="12700">
-            <a:noAutofit/>
+          <a:bodyPr wrap="square" anchor="t" lIns="0" rIns="0" tIns="0" bIns="0">
+            <a:spAutoFit/>
           </a:bodyPr>
           <a:lstStyle/>
           <a:p>
             <a:pPr algn="l">
               <a:lnSpc>
-                <a:spcPct val="130000"/>
+                <a:spcPct val="100000"/>
               </a:lnSpc>
-              <a:spcAft>
-                <a:spcPts val="400"/>
-              </a:spcAft>
             </a:pPr>
             <a:r>
-              <a:rPr sz="1000" b="0">
+              <a:rPr sz="1000" b="0" i="0">
                 <a:solidFill>
                   <a:srgbClr val="5C6975"/>
                 </a:solidFill>
                 <a:latin typeface="Consolas"/>
               </a:rPr>
-              <a:t>ESR EuroAIM/EuSoMII survey, Insights Imaging 2024 (n=572) · US estimate: industry report</a:t>
+              <a:t>ESR EuroAIM/EuSoMII survey, Insights Imaging 2024 (n=572) · US estimate: industry report.</a:t>
             </a:r>
           </a:p>
         </p:txBody>

</xml_diff>

<commit_message>
Section2: match HTML — McKinney/Salim/DREAM stats as cyan-accent chips (cyan-highlighted numbers, no wrap); MASAI table rebuilt transparent w/ thin row borders + amber AI column + white Control
</commit_message>
<xml_diff>
--- a/keynote-iwbi-2026/pptx/sections/IWBI2026_Trivedi_02_EraII.pptx
+++ b/keynote-iwbi-2026/pptx/sections/IWBI2026_Trivedi_02_EraII.pptx
@@ -4327,7 +4327,7 @@
         <p:spPr>
           <a:xfrm>
             <a:off x="777240" y="4617720"/>
-            <a:ext cx="5669280" cy="384048"/>
+            <a:ext cx="4005620" cy="384048"/>
           </a:xfrm>
           <a:prstGeom prst="roundRect">
             <a:avLst/>
@@ -4357,7 +4357,7 @@
           </a:fontRef>
         </p:style>
         <p:txBody>
-          <a:bodyPr rtlCol="0" anchor="ctr" wrap="square" lIns="128016"/>
+          <a:bodyPr rtlCol="0" anchor="ctr" wrap="none" lIns="137160" tIns="0" bIns="0"/>
           <a:lstStyle/>
           <a:p>
             <a:pPr algn="l">
@@ -4366,13 +4366,22 @@
               </a:lnSpc>
             </a:pPr>
             <a:r>
-              <a:rPr sz="1100" b="0" i="0">
+              <a:rPr sz="1050" b="1" i="0">
+                <a:solidFill>
+                  <a:srgbClr val="5FB7C9"/>
+                </a:solidFill>
+                <a:latin typeface="Consolas"/>
+              </a:rPr>
+              <a:t>1,000+</a:t>
+            </a:r>
+            <a:r>
+              <a:rPr sz="1050" b="0" i="0">
                 <a:solidFill>
                   <a:srgbClr val="ECEFF3"/>
                 </a:solidFill>
                 <a:latin typeface="Consolas"/>
               </a:rPr>
-              <a:t>1,000+ participants · 126 teams · 44 countries</a:t>
+              <a:t> participants · 126 teams · 44 countries</a:t>
             </a:r>
           </a:p>
         </p:txBody>
@@ -4386,7 +4395,7 @@
         <p:spPr>
           <a:xfrm>
             <a:off x="777240" y="4617720"/>
-            <a:ext cx="36576" cy="384048"/>
+            <a:ext cx="41148" cy="384048"/>
           </a:xfrm>
           <a:prstGeom prst="rect">
             <a:avLst/>
@@ -4429,8 +4438,8 @@
         </p:nvSpPr>
         <p:spPr>
           <a:xfrm>
-            <a:off x="777240" y="5074920"/>
-            <a:ext cx="5669280" cy="384048"/>
+            <a:off x="777240" y="5120640"/>
+            <a:ext cx="1879914" cy="384048"/>
           </a:xfrm>
           <a:prstGeom prst="roundRect">
             <a:avLst/>
@@ -4460,7 +4469,7 @@
           </a:fontRef>
         </p:style>
         <p:txBody>
-          <a:bodyPr rtlCol="0" anchor="ctr" wrap="square" lIns="128016"/>
+          <a:bodyPr rtlCol="0" anchor="ctr" wrap="none" lIns="137160" tIns="0" bIns="0"/>
           <a:lstStyle/>
           <a:p>
             <a:pPr algn="l">
@@ -4469,13 +4478,22 @@
               </a:lnSpc>
             </a:pPr>
             <a:r>
-              <a:rPr sz="1100" b="0" i="0">
+              <a:rPr sz="1050" b="1" i="0">
+                <a:solidFill>
+                  <a:srgbClr val="5FB7C9"/>
+                </a:solidFill>
+                <a:latin typeface="Consolas"/>
+              </a:rPr>
+              <a:t>~640,000</a:t>
+            </a:r>
+            <a:r>
+              <a:rPr sz="1050" b="0" i="0">
                 <a:solidFill>
                   <a:srgbClr val="ECEFF3"/>
                 </a:solidFill>
                 <a:latin typeface="Consolas"/>
               </a:rPr>
-              <a:t>~640,000 mammograms</a:t>
+              <a:t> mammograms</a:t>
             </a:r>
           </a:p>
         </p:txBody>
@@ -4488,8 +4506,8 @@
         </p:nvSpPr>
         <p:spPr>
           <a:xfrm>
-            <a:off x="777240" y="5074920"/>
-            <a:ext cx="36576" cy="384048"/>
+            <a:off x="777240" y="5120640"/>
+            <a:ext cx="41148" cy="384048"/>
           </a:xfrm>
           <a:prstGeom prst="rect">
             <a:avLst/>
@@ -4864,24 +4882,44 @@
       </p:sp>
       <p:sp>
         <p:nvSpPr>
-          <p:cNvPr id="7" name="TextBox 6"/>
-          <p:cNvSpPr txBox="1"/>
-          <p:nvPr/>
-        </p:nvSpPr>
-        <p:spPr>
-          <a:xfrm>
-            <a:off x="777240" y="3246120"/>
-            <a:ext cx="5669280" cy="384048"/>
-          </a:xfrm>
-          <a:prstGeom prst="rect">
-            <a:avLst/>
-          </a:prstGeom>
-          <a:noFill/>
-        </p:spPr>
-        <p:txBody>
-          <a:bodyPr wrap="square" anchor="t" lIns="0" rIns="0" tIns="0" bIns="0">
-            <a:spAutoFit/>
-          </a:bodyPr>
+          <p:cNvPr id="7" name="Rounded Rectangle 6"/>
+          <p:cNvSpPr/>
+          <p:nvPr/>
+        </p:nvSpPr>
+        <p:spPr>
+          <a:xfrm>
+            <a:off x="777240" y="3383280"/>
+            <a:ext cx="3218322" cy="384048"/>
+          </a:xfrm>
+          <a:prstGeom prst="roundRect">
+            <a:avLst/>
+          </a:prstGeom>
+          <a:solidFill>
+            <a:srgbClr val="1B232D"/>
+          </a:solidFill>
+          <a:ln w="9525">
+            <a:solidFill>
+              <a:srgbClr val="2A333D"/>
+            </a:solidFill>
+          </a:ln>
+          <a:effectLst/>
+        </p:spPr>
+        <p:style>
+          <a:lnRef idx="1">
+            <a:schemeClr val="accent1"/>
+          </a:lnRef>
+          <a:fillRef idx="3">
+            <a:schemeClr val="accent1"/>
+          </a:fillRef>
+          <a:effectRef idx="2">
+            <a:schemeClr val="accent1"/>
+          </a:effectRef>
+          <a:fontRef idx="minor">
+            <a:schemeClr val="lt1"/>
+          </a:fontRef>
+        </p:style>
+        <p:txBody>
+          <a:bodyPr rtlCol="0" anchor="ctr" wrap="none" lIns="137160" tIns="0" bIns="0"/>
           <a:lstStyle/>
           <a:p>
             <a:pPr algn="l">
@@ -4890,37 +4928,110 @@
               </a:lnSpc>
             </a:pPr>
             <a:r>
-              <a:rPr sz="1900" b="1" i="0">
-                <a:solidFill>
-                  <a:srgbClr val="E7AC51"/>
-                </a:solidFill>
-                <a:latin typeface="Arial"/>
-              </a:rPr>
-              <a:t>−5.7% / −1.2%</a:t>
-            </a:r>
-          </a:p>
-        </p:txBody>
-      </p:sp>
-      <p:sp>
-        <p:nvSpPr>
-          <p:cNvPr id="8" name="TextBox 7"/>
-          <p:cNvSpPr txBox="1"/>
-          <p:nvPr/>
-        </p:nvSpPr>
-        <p:spPr>
-          <a:xfrm>
-            <a:off x="777240" y="3611879"/>
-            <a:ext cx="5669280" cy="310896"/>
-          </a:xfrm>
-          <a:prstGeom prst="rect">
-            <a:avLst/>
-          </a:prstGeom>
-          <a:noFill/>
-        </p:spPr>
-        <p:txBody>
-          <a:bodyPr wrap="square" anchor="t" lIns="0" rIns="0" tIns="0" bIns="0">
-            <a:spAutoFit/>
-          </a:bodyPr>
+              <a:rPr sz="1050" b="0" i="0">
+                <a:solidFill>
+                  <a:srgbClr val="ECEFF3"/>
+                </a:solidFill>
+                <a:latin typeface="Consolas"/>
+              </a:rPr>
+              <a:t>false positives  </a:t>
+            </a:r>
+            <a:r>
+              <a:rPr sz="1050" b="1" i="0">
+                <a:solidFill>
+                  <a:srgbClr val="5FB7C9"/>
+                </a:solidFill>
+                <a:latin typeface="Consolas"/>
+              </a:rPr>
+              <a:t>−5.7% US / −1.2% UK</a:t>
+            </a:r>
+          </a:p>
+        </p:txBody>
+      </p:sp>
+      <p:sp>
+        <p:nvSpPr>
+          <p:cNvPr id="8" name="Rectangle 7"/>
+          <p:cNvSpPr/>
+          <p:nvPr/>
+        </p:nvSpPr>
+        <p:spPr>
+          <a:xfrm>
+            <a:off x="777240" y="3383280"/>
+            <a:ext cx="41148" cy="384048"/>
+          </a:xfrm>
+          <a:prstGeom prst="rect">
+            <a:avLst/>
+          </a:prstGeom>
+          <a:solidFill>
+            <a:srgbClr val="5FB7C9"/>
+          </a:solidFill>
+          <a:ln>
+            <a:noFill/>
+          </a:ln>
+          <a:effectLst/>
+        </p:spPr>
+        <p:style>
+          <a:lnRef idx="1">
+            <a:schemeClr val="accent1"/>
+          </a:lnRef>
+          <a:fillRef idx="3">
+            <a:schemeClr val="accent1"/>
+          </a:fillRef>
+          <a:effectRef idx="2">
+            <a:schemeClr val="accent1"/>
+          </a:effectRef>
+          <a:fontRef idx="minor">
+            <a:schemeClr val="lt1"/>
+          </a:fontRef>
+        </p:style>
+        <p:txBody>
+          <a:bodyPr rtlCol="0" anchor="ctr"/>
+          <a:lstStyle/>
+          <a:p>
+            <a:pPr algn="ctr"/>
+          </a:p>
+        </p:txBody>
+      </p:sp>
+      <p:sp>
+        <p:nvSpPr>
+          <p:cNvPr id="9" name="Rounded Rectangle 8"/>
+          <p:cNvSpPr/>
+          <p:nvPr/>
+        </p:nvSpPr>
+        <p:spPr>
+          <a:xfrm>
+            <a:off x="777240" y="3913632"/>
+            <a:ext cx="3218322" cy="384048"/>
+          </a:xfrm>
+          <a:prstGeom prst="roundRect">
+            <a:avLst/>
+          </a:prstGeom>
+          <a:solidFill>
+            <a:srgbClr val="1B232D"/>
+          </a:solidFill>
+          <a:ln w="9525">
+            <a:solidFill>
+              <a:srgbClr val="2A333D"/>
+            </a:solidFill>
+          </a:ln>
+          <a:effectLst/>
+        </p:spPr>
+        <p:style>
+          <a:lnRef idx="1">
+            <a:schemeClr val="accent1"/>
+          </a:lnRef>
+          <a:fillRef idx="3">
+            <a:schemeClr val="accent1"/>
+          </a:fillRef>
+          <a:effectRef idx="2">
+            <a:schemeClr val="accent1"/>
+          </a:effectRef>
+          <a:fontRef idx="minor">
+            <a:schemeClr val="lt1"/>
+          </a:fontRef>
+        </p:style>
+        <p:txBody>
+          <a:bodyPr rtlCol="0" anchor="ctr" wrap="none" lIns="137160" tIns="0" bIns="0"/>
           <a:lstStyle/>
           <a:p>
             <a:pPr algn="l">
@@ -4929,37 +5040,110 @@
               </a:lnSpc>
             </a:pPr>
             <a:r>
-              <a:rPr sz="1100" b="0" i="0">
-                <a:solidFill>
-                  <a:srgbClr val="9DA9B5"/>
+              <a:rPr sz="1050" b="0" i="0">
+                <a:solidFill>
+                  <a:srgbClr val="ECEFF3"/>
                 </a:solidFill>
                 <a:latin typeface="Consolas"/>
               </a:rPr>
-              <a:t>false positives (US / UK)</a:t>
-            </a:r>
-          </a:p>
-        </p:txBody>
-      </p:sp>
-      <p:sp>
-        <p:nvSpPr>
-          <p:cNvPr id="9" name="TextBox 8"/>
-          <p:cNvSpPr txBox="1"/>
-          <p:nvPr/>
-        </p:nvSpPr>
-        <p:spPr>
-          <a:xfrm>
-            <a:off x="777240" y="3959352"/>
-            <a:ext cx="5669280" cy="384048"/>
-          </a:xfrm>
-          <a:prstGeom prst="rect">
-            <a:avLst/>
-          </a:prstGeom>
-          <a:noFill/>
-        </p:spPr>
-        <p:txBody>
-          <a:bodyPr wrap="square" anchor="t" lIns="0" rIns="0" tIns="0" bIns="0">
-            <a:spAutoFit/>
-          </a:bodyPr>
+              <a:t>false negatives  </a:t>
+            </a:r>
+            <a:r>
+              <a:rPr sz="1050" b="1" i="0">
+                <a:solidFill>
+                  <a:srgbClr val="5FB7C9"/>
+                </a:solidFill>
+                <a:latin typeface="Consolas"/>
+              </a:rPr>
+              <a:t>−9.4% US / −2.7% UK</a:t>
+            </a:r>
+          </a:p>
+        </p:txBody>
+      </p:sp>
+      <p:sp>
+        <p:nvSpPr>
+          <p:cNvPr id="10" name="Rectangle 9"/>
+          <p:cNvSpPr/>
+          <p:nvPr/>
+        </p:nvSpPr>
+        <p:spPr>
+          <a:xfrm>
+            <a:off x="777240" y="3913632"/>
+            <a:ext cx="41148" cy="384048"/>
+          </a:xfrm>
+          <a:prstGeom prst="rect">
+            <a:avLst/>
+          </a:prstGeom>
+          <a:solidFill>
+            <a:srgbClr val="5FB7C9"/>
+          </a:solidFill>
+          <a:ln>
+            <a:noFill/>
+          </a:ln>
+          <a:effectLst/>
+        </p:spPr>
+        <p:style>
+          <a:lnRef idx="1">
+            <a:schemeClr val="accent1"/>
+          </a:lnRef>
+          <a:fillRef idx="3">
+            <a:schemeClr val="accent1"/>
+          </a:fillRef>
+          <a:effectRef idx="2">
+            <a:schemeClr val="accent1"/>
+          </a:effectRef>
+          <a:fontRef idx="minor">
+            <a:schemeClr val="lt1"/>
+          </a:fontRef>
+        </p:style>
+        <p:txBody>
+          <a:bodyPr rtlCol="0" anchor="ctr"/>
+          <a:lstStyle/>
+          <a:p>
+            <a:pPr algn="ctr"/>
+          </a:p>
+        </p:txBody>
+      </p:sp>
+      <p:sp>
+        <p:nvSpPr>
+          <p:cNvPr id="11" name="Rounded Rectangle 10"/>
+          <p:cNvSpPr/>
+          <p:nvPr/>
+        </p:nvSpPr>
+        <p:spPr>
+          <a:xfrm>
+            <a:off x="777240" y="4443984"/>
+            <a:ext cx="2667213" cy="384048"/>
+          </a:xfrm>
+          <a:prstGeom prst="roundRect">
+            <a:avLst/>
+          </a:prstGeom>
+          <a:solidFill>
+            <a:srgbClr val="1B232D"/>
+          </a:solidFill>
+          <a:ln w="9525">
+            <a:solidFill>
+              <a:srgbClr val="2A333D"/>
+            </a:solidFill>
+          </a:ln>
+          <a:effectLst/>
+        </p:spPr>
+        <p:style>
+          <a:lnRef idx="1">
+            <a:schemeClr val="accent1"/>
+          </a:lnRef>
+          <a:fillRef idx="3">
+            <a:schemeClr val="accent1"/>
+          </a:fillRef>
+          <a:effectRef idx="2">
+            <a:schemeClr val="accent1"/>
+          </a:effectRef>
+          <a:fontRef idx="minor">
+            <a:schemeClr val="lt1"/>
+          </a:fontRef>
+        </p:style>
+        <p:txBody>
+          <a:bodyPr rtlCol="0" anchor="ctr" wrap="none" lIns="137160" tIns="0" bIns="0"/>
           <a:lstStyle/>
           <a:p>
             <a:pPr algn="l">
@@ -4968,37 +5152,119 @@
               </a:lnSpc>
             </a:pPr>
             <a:r>
-              <a:rPr sz="1900" b="1" i="0">
-                <a:solidFill>
-                  <a:srgbClr val="E7AC51"/>
-                </a:solidFill>
-                <a:latin typeface="Arial"/>
-              </a:rPr>
-              <a:t>−9.4% / −2.7%</a:t>
-            </a:r>
-          </a:p>
-        </p:txBody>
-      </p:sp>
-      <p:sp>
-        <p:nvSpPr>
-          <p:cNvPr id="10" name="TextBox 9"/>
-          <p:cNvSpPr txBox="1"/>
-          <p:nvPr/>
-        </p:nvSpPr>
-        <p:spPr>
-          <a:xfrm>
-            <a:off x="777240" y="4325112"/>
-            <a:ext cx="5669280" cy="310896"/>
-          </a:xfrm>
-          <a:prstGeom prst="rect">
-            <a:avLst/>
-          </a:prstGeom>
-          <a:noFill/>
-        </p:spPr>
-        <p:txBody>
-          <a:bodyPr wrap="square" anchor="t" lIns="0" rIns="0" tIns="0" bIns="0">
-            <a:spAutoFit/>
-          </a:bodyPr>
+              <a:rPr sz="1050" b="0" i="0">
+                <a:solidFill>
+                  <a:srgbClr val="ECEFF3"/>
+                </a:solidFill>
+                <a:latin typeface="Consolas"/>
+              </a:rPr>
+              <a:t>AUC </a:t>
+            </a:r>
+            <a:r>
+              <a:rPr sz="1050" b="1" i="0">
+                <a:solidFill>
+                  <a:srgbClr val="5FB7C9"/>
+                </a:solidFill>
+                <a:latin typeface="Consolas"/>
+              </a:rPr>
+              <a:t>+11.5%</a:t>
+            </a:r>
+            <a:r>
+              <a:rPr sz="1050" b="0" i="0">
+                <a:solidFill>
+                  <a:srgbClr val="ECEFF3"/>
+                </a:solidFill>
+                <a:latin typeface="Consolas"/>
+              </a:rPr>
+              <a:t> vs avg radiologist</a:t>
+            </a:r>
+          </a:p>
+        </p:txBody>
+      </p:sp>
+      <p:sp>
+        <p:nvSpPr>
+          <p:cNvPr id="12" name="Rectangle 11"/>
+          <p:cNvSpPr/>
+          <p:nvPr/>
+        </p:nvSpPr>
+        <p:spPr>
+          <a:xfrm>
+            <a:off x="777240" y="4443984"/>
+            <a:ext cx="41148" cy="384048"/>
+          </a:xfrm>
+          <a:prstGeom prst="rect">
+            <a:avLst/>
+          </a:prstGeom>
+          <a:solidFill>
+            <a:srgbClr val="5FB7C9"/>
+          </a:solidFill>
+          <a:ln>
+            <a:noFill/>
+          </a:ln>
+          <a:effectLst/>
+        </p:spPr>
+        <p:style>
+          <a:lnRef idx="1">
+            <a:schemeClr val="accent1"/>
+          </a:lnRef>
+          <a:fillRef idx="3">
+            <a:schemeClr val="accent1"/>
+          </a:fillRef>
+          <a:effectRef idx="2">
+            <a:schemeClr val="accent1"/>
+          </a:effectRef>
+          <a:fontRef idx="minor">
+            <a:schemeClr val="lt1"/>
+          </a:fontRef>
+        </p:style>
+        <p:txBody>
+          <a:bodyPr rtlCol="0" anchor="ctr"/>
+          <a:lstStyle/>
+          <a:p>
+            <a:pPr algn="ctr"/>
+          </a:p>
+        </p:txBody>
+      </p:sp>
+      <p:sp>
+        <p:nvSpPr>
+          <p:cNvPr id="13" name="Rounded Rectangle 12"/>
+          <p:cNvSpPr/>
+          <p:nvPr/>
+        </p:nvSpPr>
+        <p:spPr>
+          <a:xfrm>
+            <a:off x="777240" y="4974336"/>
+            <a:ext cx="2352294" cy="384048"/>
+          </a:xfrm>
+          <a:prstGeom prst="roundRect">
+            <a:avLst/>
+          </a:prstGeom>
+          <a:solidFill>
+            <a:srgbClr val="1B232D"/>
+          </a:solidFill>
+          <a:ln w="9525">
+            <a:solidFill>
+              <a:srgbClr val="2A333D"/>
+            </a:solidFill>
+          </a:ln>
+          <a:effectLst/>
+        </p:spPr>
+        <p:style>
+          <a:lnRef idx="1">
+            <a:schemeClr val="accent1"/>
+          </a:lnRef>
+          <a:fillRef idx="3">
+            <a:schemeClr val="accent1"/>
+          </a:fillRef>
+          <a:effectRef idx="2">
+            <a:schemeClr val="accent1"/>
+          </a:effectRef>
+          <a:fontRef idx="minor">
+            <a:schemeClr val="lt1"/>
+          </a:fontRef>
+        </p:style>
+        <p:txBody>
+          <a:bodyPr rtlCol="0" anchor="ctr" wrap="none" lIns="137160" tIns="0" bIns="0"/>
           <a:lstStyle/>
           <a:p>
             <a:pPr algn="l">
@@ -5007,27 +5273,119 @@
               </a:lnSpc>
             </a:pPr>
             <a:r>
-              <a:rPr sz="1100" b="0" i="0">
+              <a:rPr sz="1050" b="0" i="0">
+                <a:solidFill>
+                  <a:srgbClr val="ECEFF3"/>
+                </a:solidFill>
+                <a:latin typeface="Consolas"/>
+              </a:rPr>
+              <a:t>2nd-reader workload  </a:t>
+            </a:r>
+            <a:r>
+              <a:rPr sz="1050" b="1" i="0">
+                <a:solidFill>
+                  <a:srgbClr val="5FB7C9"/>
+                </a:solidFill>
+                <a:latin typeface="Consolas"/>
+              </a:rPr>
+              <a:t>−88%</a:t>
+            </a:r>
+          </a:p>
+        </p:txBody>
+      </p:sp>
+      <p:sp>
+        <p:nvSpPr>
+          <p:cNvPr id="14" name="Rectangle 13"/>
+          <p:cNvSpPr/>
+          <p:nvPr/>
+        </p:nvSpPr>
+        <p:spPr>
+          <a:xfrm>
+            <a:off x="777240" y="4974336"/>
+            <a:ext cx="41148" cy="384048"/>
+          </a:xfrm>
+          <a:prstGeom prst="rect">
+            <a:avLst/>
+          </a:prstGeom>
+          <a:solidFill>
+            <a:srgbClr val="5FB7C9"/>
+          </a:solidFill>
+          <a:ln>
+            <a:noFill/>
+          </a:ln>
+          <a:effectLst/>
+        </p:spPr>
+        <p:style>
+          <a:lnRef idx="1">
+            <a:schemeClr val="accent1"/>
+          </a:lnRef>
+          <a:fillRef idx="3">
+            <a:schemeClr val="accent1"/>
+          </a:fillRef>
+          <a:effectRef idx="2">
+            <a:schemeClr val="accent1"/>
+          </a:effectRef>
+          <a:fontRef idx="minor">
+            <a:schemeClr val="lt1"/>
+          </a:fontRef>
+        </p:style>
+        <p:txBody>
+          <a:bodyPr rtlCol="0" anchor="ctr"/>
+          <a:lstStyle/>
+          <a:p>
+            <a:pPr algn="ctr"/>
+          </a:p>
+        </p:txBody>
+      </p:sp>
+      <p:sp>
+        <p:nvSpPr>
+          <p:cNvPr id="15" name="TextBox 14"/>
+          <p:cNvSpPr txBox="1"/>
+          <p:nvPr/>
+        </p:nvSpPr>
+        <p:spPr>
+          <a:xfrm>
+            <a:off x="777240" y="5559552"/>
+            <a:ext cx="5760720" cy="457200"/>
+          </a:xfrm>
+          <a:prstGeom prst="rect">
+            <a:avLst/>
+          </a:prstGeom>
+          <a:noFill/>
+        </p:spPr>
+        <p:txBody>
+          <a:bodyPr wrap="square" anchor="t" lIns="0" rIns="0" tIns="0" bIns="0">
+            <a:spAutoFit/>
+          </a:bodyPr>
+          <a:lstStyle/>
+          <a:p>
+            <a:pPr algn="l">
+              <a:lnSpc>
+                <a:spcPct val="130000"/>
+              </a:lnSpc>
+            </a:pPr>
+            <a:r>
+              <a:rPr sz="1300" b="0" i="0">
                 <a:solidFill>
                   <a:srgbClr val="9DA9B5"/>
                 </a:solidFill>
-                <a:latin typeface="Consolas"/>
-              </a:rPr>
-              <a:t>false negatives (US / UK)</a:t>
-            </a:r>
-          </a:p>
-        </p:txBody>
-      </p:sp>
-      <p:sp>
-        <p:nvSpPr>
-          <p:cNvPr id="11" name="TextBox 10"/>
+                <a:latin typeface="Arial"/>
+              </a:rPr>
+              <a:t>Results are promising — but again, only on clean, curated data.</a:t>
+            </a:r>
+          </a:p>
+        </p:txBody>
+      </p:sp>
+      <p:sp>
+        <p:nvSpPr>
+          <p:cNvPr id="16" name="TextBox 15"/>
           <p:cNvSpPr txBox="1"/>
           <p:nvPr/>
         </p:nvSpPr>
         <p:spPr>
           <a:xfrm>
-            <a:off x="777240" y="4672584"/>
-            <a:ext cx="5669280" cy="384048"/>
+            <a:off x="777240" y="6236208"/>
+            <a:ext cx="5760720" cy="365760"/>
           </a:xfrm>
           <a:prstGeom prst="rect">
             <a:avLst/>
@@ -5046,176 +5404,20 @@
               </a:lnSpc>
             </a:pPr>
             <a:r>
-              <a:rPr sz="1900" b="1" i="0">
-                <a:solidFill>
-                  <a:srgbClr val="E7AC51"/>
-                </a:solidFill>
-                <a:latin typeface="Arial"/>
-              </a:rPr>
-              <a:t>+11.5%</a:t>
-            </a:r>
-          </a:p>
-        </p:txBody>
-      </p:sp>
-      <p:sp>
-        <p:nvSpPr>
-          <p:cNvPr id="12" name="TextBox 11"/>
-          <p:cNvSpPr txBox="1"/>
-          <p:nvPr/>
-        </p:nvSpPr>
-        <p:spPr>
-          <a:xfrm>
-            <a:off x="777240" y="5038344"/>
-            <a:ext cx="5669280" cy="310896"/>
-          </a:xfrm>
-          <a:prstGeom prst="rect">
-            <a:avLst/>
-          </a:prstGeom>
-          <a:noFill/>
-        </p:spPr>
-        <p:txBody>
-          <a:bodyPr wrap="square" anchor="t" lIns="0" rIns="0" tIns="0" bIns="0">
-            <a:spAutoFit/>
-          </a:bodyPr>
-          <a:lstStyle/>
-          <a:p>
-            <a:pPr algn="l">
-              <a:lnSpc>
-                <a:spcPct val="100000"/>
-              </a:lnSpc>
-            </a:pPr>
-            <a:r>
-              <a:rPr sz="1100" b="0" i="0">
-                <a:solidFill>
-                  <a:srgbClr val="9DA9B5"/>
+              <a:rPr sz="950" b="0" i="0">
+                <a:solidFill>
+                  <a:srgbClr val="5C6975"/>
                 </a:solidFill>
                 <a:latin typeface="Consolas"/>
               </a:rPr>
-              <a:t>AUC over the average radiologist</a:t>
-            </a:r>
-          </a:p>
-        </p:txBody>
-      </p:sp>
-      <p:sp>
-        <p:nvSpPr>
-          <p:cNvPr id="13" name="TextBox 12"/>
-          <p:cNvSpPr txBox="1"/>
-          <p:nvPr/>
-        </p:nvSpPr>
-        <p:spPr>
-          <a:xfrm>
-            <a:off x="777240" y="5385816"/>
-            <a:ext cx="5669280" cy="384048"/>
-          </a:xfrm>
-          <a:prstGeom prst="rect">
-            <a:avLst/>
-          </a:prstGeom>
-          <a:noFill/>
-        </p:spPr>
-        <p:txBody>
-          <a:bodyPr wrap="square" anchor="t" lIns="0" rIns="0" tIns="0" bIns="0">
-            <a:spAutoFit/>
-          </a:bodyPr>
-          <a:lstStyle/>
-          <a:p>
-            <a:pPr algn="l">
-              <a:lnSpc>
-                <a:spcPct val="100000"/>
-              </a:lnSpc>
-            </a:pPr>
-            <a:r>
-              <a:rPr sz="1900" b="1" i="0">
-                <a:solidFill>
-                  <a:srgbClr val="E7AC51"/>
-                </a:solidFill>
-                <a:latin typeface="Arial"/>
-              </a:rPr>
-              <a:t>−88%</a:t>
-            </a:r>
-          </a:p>
-        </p:txBody>
-      </p:sp>
-      <p:sp>
-        <p:nvSpPr>
-          <p:cNvPr id="14" name="TextBox 13"/>
-          <p:cNvSpPr txBox="1"/>
-          <p:nvPr/>
-        </p:nvSpPr>
-        <p:spPr>
-          <a:xfrm>
-            <a:off x="777240" y="5751576"/>
-            <a:ext cx="5669280" cy="310896"/>
-          </a:xfrm>
-          <a:prstGeom prst="rect">
-            <a:avLst/>
-          </a:prstGeom>
-          <a:noFill/>
-        </p:spPr>
-        <p:txBody>
-          <a:bodyPr wrap="square" anchor="t" lIns="0" rIns="0" tIns="0" bIns="0">
-            <a:spAutoFit/>
-          </a:bodyPr>
-          <a:lstStyle/>
-          <a:p>
-            <a:pPr algn="l">
-              <a:lnSpc>
-                <a:spcPct val="100000"/>
-              </a:lnSpc>
-            </a:pPr>
-            <a:r>
-              <a:rPr sz="1100" b="0" i="0">
-                <a:solidFill>
-                  <a:srgbClr val="9DA9B5"/>
-                </a:solidFill>
-                <a:latin typeface="Consolas"/>
-              </a:rPr>
-              <a:t>simulated second-reader workload</a:t>
-            </a:r>
-          </a:p>
-        </p:txBody>
-      </p:sp>
-      <p:sp>
-        <p:nvSpPr>
-          <p:cNvPr id="15" name="TextBox 14"/>
-          <p:cNvSpPr txBox="1"/>
-          <p:nvPr/>
-        </p:nvSpPr>
-        <p:spPr>
-          <a:xfrm>
-            <a:off x="777240" y="6199632"/>
-            <a:ext cx="5760720" cy="365760"/>
-          </a:xfrm>
-          <a:prstGeom prst="rect">
-            <a:avLst/>
-          </a:prstGeom>
-          <a:noFill/>
-        </p:spPr>
-        <p:txBody>
-          <a:bodyPr wrap="square" anchor="t" lIns="0" rIns="0" tIns="0" bIns="0">
-            <a:spAutoFit/>
-          </a:bodyPr>
-          <a:lstStyle/>
-          <a:p>
-            <a:pPr algn="l">
-              <a:lnSpc>
-                <a:spcPct val="100000"/>
-              </a:lnSpc>
-            </a:pPr>
-            <a:r>
-              <a:rPr sz="950" b="0" i="0">
-                <a:solidFill>
-                  <a:srgbClr val="5C6975"/>
-                </a:solidFill>
-                <a:latin typeface="Consolas"/>
-              </a:rPr>
-              <a:t>Results are promising — but again, only on clean, curated data. · McKinney et al., Nature 2020;577:89–94.</a:t>
-            </a:r>
-          </a:p>
-        </p:txBody>
-      </p:sp>
-      <p:sp>
-        <p:nvSpPr>
-          <p:cNvPr id="16" name="Rounded Rectangle 15"/>
+              <a:t>McKinney et al., Nature 2020;577:89–94.</a:t>
+            </a:r>
+          </a:p>
+        </p:txBody>
+      </p:sp>
+      <p:sp>
+        <p:nvSpPr>
+          <p:cNvPr id="17" name="Rounded Rectangle 16"/>
           <p:cNvSpPr/>
           <p:nvPr/>
         </p:nvSpPr>
@@ -5261,7 +5463,7 @@
       </p:sp>
       <p:pic>
         <p:nvPicPr>
-          <p:cNvPr id="17" name="Picture 16" descr="img_6cb54df20e.png"/>
+          <p:cNvPr id="18" name="Picture 17" descr="img_6cb54df20e.png"/>
           <p:cNvPicPr>
             <a:picLocks noChangeAspect="1"/>
           </p:cNvPicPr>
@@ -5514,14 +5716,449 @@
       </p:sp>
       <p:sp>
         <p:nvSpPr>
-          <p:cNvPr id="7" name="TextBox 6"/>
+          <p:cNvPr id="7" name="Rounded Rectangle 6"/>
+          <p:cNvSpPr/>
+          <p:nvPr/>
+        </p:nvSpPr>
+        <p:spPr>
+          <a:xfrm>
+            <a:off x="777240" y="3611880"/>
+            <a:ext cx="3690701" cy="384048"/>
+          </a:xfrm>
+          <a:prstGeom prst="roundRect">
+            <a:avLst/>
+          </a:prstGeom>
+          <a:solidFill>
+            <a:srgbClr val="1B232D"/>
+          </a:solidFill>
+          <a:ln w="9525">
+            <a:solidFill>
+              <a:srgbClr val="2A333D"/>
+            </a:solidFill>
+          </a:ln>
+          <a:effectLst/>
+        </p:spPr>
+        <p:style>
+          <a:lnRef idx="1">
+            <a:schemeClr val="accent1"/>
+          </a:lnRef>
+          <a:fillRef idx="3">
+            <a:schemeClr val="accent1"/>
+          </a:fillRef>
+          <a:effectRef idx="2">
+            <a:schemeClr val="accent1"/>
+          </a:effectRef>
+          <a:fontRef idx="minor">
+            <a:schemeClr val="lt1"/>
+          </a:fontRef>
+        </p:style>
+        <p:txBody>
+          <a:bodyPr rtlCol="0" anchor="ctr" wrap="none" lIns="137160" tIns="0" bIns="0"/>
+          <a:lstStyle/>
+          <a:p>
+            <a:pPr algn="l">
+              <a:lnSpc>
+                <a:spcPct val="100000"/>
+              </a:lnSpc>
+            </a:pPr>
+            <a:r>
+              <a:rPr sz="1050" b="0" i="0">
+                <a:solidFill>
+                  <a:srgbClr val="ECEFF3"/>
+                </a:solidFill>
+                <a:latin typeface="Consolas"/>
+              </a:rPr>
+              <a:t>AUC — AI-1 </a:t>
+            </a:r>
+            <a:r>
+              <a:rPr sz="1050" b="1" i="0">
+                <a:solidFill>
+                  <a:srgbClr val="5FB7C9"/>
+                </a:solidFill>
+                <a:latin typeface="Consolas"/>
+              </a:rPr>
+              <a:t>0.956</a:t>
+            </a:r>
+            <a:r>
+              <a:rPr sz="1050" b="0" i="0">
+                <a:solidFill>
+                  <a:srgbClr val="ECEFF3"/>
+                </a:solidFill>
+                <a:latin typeface="Consolas"/>
+              </a:rPr>
+              <a:t> · AI-2 </a:t>
+            </a:r>
+            <a:r>
+              <a:rPr sz="1050" b="1" i="0">
+                <a:solidFill>
+                  <a:srgbClr val="5FB7C9"/>
+                </a:solidFill>
+                <a:latin typeface="Consolas"/>
+              </a:rPr>
+              <a:t>0.922</a:t>
+            </a:r>
+            <a:r>
+              <a:rPr sz="1050" b="0" i="0">
+                <a:solidFill>
+                  <a:srgbClr val="ECEFF3"/>
+                </a:solidFill>
+                <a:latin typeface="Consolas"/>
+              </a:rPr>
+              <a:t> · AI-3 </a:t>
+            </a:r>
+            <a:r>
+              <a:rPr sz="1050" b="1" i="0">
+                <a:solidFill>
+                  <a:srgbClr val="5FB7C9"/>
+                </a:solidFill>
+                <a:latin typeface="Consolas"/>
+              </a:rPr>
+              <a:t>0.920</a:t>
+            </a:r>
+          </a:p>
+        </p:txBody>
+      </p:sp>
+      <p:sp>
+        <p:nvSpPr>
+          <p:cNvPr id="8" name="Rectangle 7"/>
+          <p:cNvSpPr/>
+          <p:nvPr/>
+        </p:nvSpPr>
+        <p:spPr>
+          <a:xfrm>
+            <a:off x="777240" y="3611880"/>
+            <a:ext cx="41148" cy="384048"/>
+          </a:xfrm>
+          <a:prstGeom prst="rect">
+            <a:avLst/>
+          </a:prstGeom>
+          <a:solidFill>
+            <a:srgbClr val="5FB7C9"/>
+          </a:solidFill>
+          <a:ln>
+            <a:noFill/>
+          </a:ln>
+          <a:effectLst/>
+        </p:spPr>
+        <p:style>
+          <a:lnRef idx="1">
+            <a:schemeClr val="accent1"/>
+          </a:lnRef>
+          <a:fillRef idx="3">
+            <a:schemeClr val="accent1"/>
+          </a:fillRef>
+          <a:effectRef idx="2">
+            <a:schemeClr val="accent1"/>
+          </a:effectRef>
+          <a:fontRef idx="minor">
+            <a:schemeClr val="lt1"/>
+          </a:fontRef>
+        </p:style>
+        <p:txBody>
+          <a:bodyPr rtlCol="0" anchor="ctr"/>
+          <a:lstStyle/>
+          <a:p>
+            <a:pPr algn="ctr"/>
+          </a:p>
+        </p:txBody>
+      </p:sp>
+      <p:sp>
+        <p:nvSpPr>
+          <p:cNvPr id="9" name="Rounded Rectangle 8"/>
+          <p:cNvSpPr/>
+          <p:nvPr/>
+        </p:nvSpPr>
+        <p:spPr>
+          <a:xfrm>
+            <a:off x="777240" y="4142232"/>
+            <a:ext cx="5501487" cy="384048"/>
+          </a:xfrm>
+          <a:prstGeom prst="roundRect">
+            <a:avLst/>
+          </a:prstGeom>
+          <a:solidFill>
+            <a:srgbClr val="1B232D"/>
+          </a:solidFill>
+          <a:ln w="9525">
+            <a:solidFill>
+              <a:srgbClr val="2A333D"/>
+            </a:solidFill>
+          </a:ln>
+          <a:effectLst/>
+        </p:spPr>
+        <p:style>
+          <a:lnRef idx="1">
+            <a:schemeClr val="accent1"/>
+          </a:lnRef>
+          <a:fillRef idx="3">
+            <a:schemeClr val="accent1"/>
+          </a:fillRef>
+          <a:effectRef idx="2">
+            <a:schemeClr val="accent1"/>
+          </a:effectRef>
+          <a:fontRef idx="minor">
+            <a:schemeClr val="lt1"/>
+          </a:fontRef>
+        </p:style>
+        <p:txBody>
+          <a:bodyPr rtlCol="0" anchor="ctr" wrap="none" lIns="137160" tIns="0" bIns="0"/>
+          <a:lstStyle/>
+          <a:p>
+            <a:pPr algn="l">
+              <a:lnSpc>
+                <a:spcPct val="100000"/>
+              </a:lnSpc>
+            </a:pPr>
+            <a:r>
+              <a:rPr sz="1050" b="0" i="0">
+                <a:solidFill>
+                  <a:srgbClr val="ECEFF3"/>
+                </a:solidFill>
+                <a:latin typeface="Consolas"/>
+              </a:rPr>
+              <a:t>at readers' specificity (</a:t>
+            </a:r>
+            <a:r>
+              <a:rPr sz="1050" b="1" i="0">
+                <a:solidFill>
+                  <a:srgbClr val="5FB7C9"/>
+                </a:solidFill>
+                <a:latin typeface="Consolas"/>
+              </a:rPr>
+              <a:t>96.6%</a:t>
+            </a:r>
+            <a:r>
+              <a:rPr sz="1050" b="0" i="0">
+                <a:solidFill>
+                  <a:srgbClr val="ECEFF3"/>
+                </a:solidFill>
+                <a:latin typeface="Consolas"/>
+              </a:rPr>
+              <a:t>): AI-1 </a:t>
+            </a:r>
+            <a:r>
+              <a:rPr sz="1050" b="1" i="0">
+                <a:solidFill>
+                  <a:srgbClr val="5FB7C9"/>
+                </a:solidFill>
+                <a:latin typeface="Consolas"/>
+              </a:rPr>
+              <a:t>81.9%</a:t>
+            </a:r>
+            <a:r>
+              <a:rPr sz="1050" b="0" i="0">
+                <a:solidFill>
+                  <a:srgbClr val="ECEFF3"/>
+                </a:solidFill>
+                <a:latin typeface="Consolas"/>
+              </a:rPr>
+              <a:t> sens vs readers </a:t>
+            </a:r>
+            <a:r>
+              <a:rPr sz="1050" b="1" i="0">
+                <a:solidFill>
+                  <a:srgbClr val="5FB7C9"/>
+                </a:solidFill>
+                <a:latin typeface="Consolas"/>
+              </a:rPr>
+              <a:t>77.4%</a:t>
+            </a:r>
+          </a:p>
+        </p:txBody>
+      </p:sp>
+      <p:sp>
+        <p:nvSpPr>
+          <p:cNvPr id="10" name="Rectangle 9"/>
+          <p:cNvSpPr/>
+          <p:nvPr/>
+        </p:nvSpPr>
+        <p:spPr>
+          <a:xfrm>
+            <a:off x="777240" y="4142232"/>
+            <a:ext cx="41148" cy="384048"/>
+          </a:xfrm>
+          <a:prstGeom prst="rect">
+            <a:avLst/>
+          </a:prstGeom>
+          <a:solidFill>
+            <a:srgbClr val="5FB7C9"/>
+          </a:solidFill>
+          <a:ln>
+            <a:noFill/>
+          </a:ln>
+          <a:effectLst/>
+        </p:spPr>
+        <p:style>
+          <a:lnRef idx="1">
+            <a:schemeClr val="accent1"/>
+          </a:lnRef>
+          <a:fillRef idx="3">
+            <a:schemeClr val="accent1"/>
+          </a:fillRef>
+          <a:effectRef idx="2">
+            <a:schemeClr val="accent1"/>
+          </a:effectRef>
+          <a:fontRef idx="minor">
+            <a:schemeClr val="lt1"/>
+          </a:fontRef>
+        </p:style>
+        <p:txBody>
+          <a:bodyPr rtlCol="0" anchor="ctr"/>
+          <a:lstStyle/>
+          <a:p>
+            <a:pPr algn="ctr"/>
+          </a:p>
+        </p:txBody>
+      </p:sp>
+      <p:sp>
+        <p:nvSpPr>
+          <p:cNvPr id="11" name="Rounded Rectangle 10"/>
+          <p:cNvSpPr/>
+          <p:nvPr/>
+        </p:nvSpPr>
+        <p:spPr>
+          <a:xfrm>
+            <a:off x="777240" y="4672584"/>
+            <a:ext cx="4320540" cy="384048"/>
+          </a:xfrm>
+          <a:prstGeom prst="roundRect">
+            <a:avLst/>
+          </a:prstGeom>
+          <a:solidFill>
+            <a:srgbClr val="1B232D"/>
+          </a:solidFill>
+          <a:ln w="9525">
+            <a:solidFill>
+              <a:srgbClr val="2A333D"/>
+            </a:solidFill>
+          </a:ln>
+          <a:effectLst/>
+        </p:spPr>
+        <p:style>
+          <a:lnRef idx="1">
+            <a:schemeClr val="accent1"/>
+          </a:lnRef>
+          <a:fillRef idx="3">
+            <a:schemeClr val="accent1"/>
+          </a:fillRef>
+          <a:effectRef idx="2">
+            <a:schemeClr val="accent1"/>
+          </a:effectRef>
+          <a:fontRef idx="minor">
+            <a:schemeClr val="lt1"/>
+          </a:fontRef>
+        </p:style>
+        <p:txBody>
+          <a:bodyPr rtlCol="0" anchor="ctr" wrap="none" lIns="137160" tIns="0" bIns="0"/>
+          <a:lstStyle/>
+          <a:p>
+            <a:pPr algn="l">
+              <a:lnSpc>
+                <a:spcPct val="100000"/>
+              </a:lnSpc>
+            </a:pPr>
+            <a:r>
+              <a:rPr sz="1050" b="0" i="0">
+                <a:solidFill>
+                  <a:srgbClr val="ECEFF3"/>
+                </a:solidFill>
+                <a:latin typeface="Consolas"/>
+              </a:rPr>
+              <a:t>AI + reader: </a:t>
+            </a:r>
+            <a:r>
+              <a:rPr sz="1050" b="1" i="0">
+                <a:solidFill>
+                  <a:srgbClr val="5FB7C9"/>
+                </a:solidFill>
+                <a:latin typeface="Consolas"/>
+              </a:rPr>
+              <a:t>+77%</a:t>
+            </a:r>
+            <a:r>
+              <a:rPr sz="1050" b="0" i="0">
+                <a:solidFill>
+                  <a:srgbClr val="ECEFF3"/>
+                </a:solidFill>
+                <a:latin typeface="Consolas"/>
+              </a:rPr>
+              <a:t> abnormal calls for </a:t>
+            </a:r>
+            <a:r>
+              <a:rPr sz="1050" b="1" i="0">
+                <a:solidFill>
+                  <a:srgbClr val="5FB7C9"/>
+                </a:solidFill>
+                <a:latin typeface="Consolas"/>
+              </a:rPr>
+              <a:t>+8%</a:t>
+            </a:r>
+            <a:r>
+              <a:rPr sz="1050" b="0" i="0">
+                <a:solidFill>
+                  <a:srgbClr val="ECEFF3"/>
+                </a:solidFill>
+                <a:latin typeface="Consolas"/>
+              </a:rPr>
+              <a:t> detection</a:t>
+            </a:r>
+          </a:p>
+        </p:txBody>
+      </p:sp>
+      <p:sp>
+        <p:nvSpPr>
+          <p:cNvPr id="12" name="Rectangle 11"/>
+          <p:cNvSpPr/>
+          <p:nvPr/>
+        </p:nvSpPr>
+        <p:spPr>
+          <a:xfrm>
+            <a:off x="777240" y="4672584"/>
+            <a:ext cx="41148" cy="384048"/>
+          </a:xfrm>
+          <a:prstGeom prst="rect">
+            <a:avLst/>
+          </a:prstGeom>
+          <a:solidFill>
+            <a:srgbClr val="5FB7C9"/>
+          </a:solidFill>
+          <a:ln>
+            <a:noFill/>
+          </a:ln>
+          <a:effectLst/>
+        </p:spPr>
+        <p:style>
+          <a:lnRef idx="1">
+            <a:schemeClr val="accent1"/>
+          </a:lnRef>
+          <a:fillRef idx="3">
+            <a:schemeClr val="accent1"/>
+          </a:fillRef>
+          <a:effectRef idx="2">
+            <a:schemeClr val="accent1"/>
+          </a:effectRef>
+          <a:fontRef idx="minor">
+            <a:schemeClr val="lt1"/>
+          </a:fontRef>
+        </p:style>
+        <p:txBody>
+          <a:bodyPr rtlCol="0" anchor="ctr"/>
+          <a:lstStyle/>
+          <a:p>
+            <a:pPr algn="ctr"/>
+          </a:p>
+        </p:txBody>
+      </p:sp>
+      <p:sp>
+        <p:nvSpPr>
+          <p:cNvPr id="13" name="TextBox 12"/>
           <p:cNvSpPr txBox="1"/>
           <p:nvPr/>
         </p:nvSpPr>
         <p:spPr>
           <a:xfrm>
-            <a:off x="777240" y="3611880"/>
-            <a:ext cx="5852160" cy="457200"/>
+            <a:off x="777240" y="5257800"/>
+            <a:ext cx="5852160" cy="548640"/>
           </a:xfrm>
           <a:prstGeom prst="rect">
             <a:avLst/>
@@ -5540,240 +6177,27 @@
               </a:lnSpc>
             </a:pPr>
             <a:r>
-              <a:rPr sz="1400" b="0" i="0">
+              <a:rPr sz="1300" b="0" i="0">
                 <a:solidFill>
                   <a:srgbClr val="9DA9B5"/>
                 </a:solidFill>
                 <a:latin typeface="Arial"/>
               </a:rPr>
-              <a:t>AUC — AI-1 </a:t>
-            </a:r>
-            <a:r>
-              <a:rPr sz="1400" b="1" i="0">
-                <a:solidFill>
-                  <a:srgbClr val="E7AC51"/>
-                </a:solidFill>
-                <a:latin typeface="Arial"/>
-              </a:rPr>
-              <a:t>0.956</a:t>
-            </a:r>
-            <a:r>
-              <a:rPr sz="1400" b="0" i="0">
-                <a:solidFill>
-                  <a:srgbClr val="9DA9B5"/>
-                </a:solidFill>
-                <a:latin typeface="Arial"/>
-              </a:rPr>
-              <a:t> · AI-2 </a:t>
-            </a:r>
-            <a:r>
-              <a:rPr sz="1400" b="1" i="0">
-                <a:solidFill>
-                  <a:srgbClr val="E7AC51"/>
-                </a:solidFill>
-                <a:latin typeface="Arial"/>
-              </a:rPr>
-              <a:t>0.922</a:t>
-            </a:r>
-            <a:r>
-              <a:rPr sz="1400" b="0" i="0">
-                <a:solidFill>
-                  <a:srgbClr val="9DA9B5"/>
-                </a:solidFill>
-                <a:latin typeface="Arial"/>
-              </a:rPr>
-              <a:t> · AI-3 </a:t>
-            </a:r>
-            <a:r>
-              <a:rPr sz="1400" b="1" i="0">
-                <a:solidFill>
-                  <a:srgbClr val="E7AC51"/>
-                </a:solidFill>
-                <a:latin typeface="Arial"/>
-              </a:rPr>
-              <a:t>0.920</a:t>
-            </a:r>
-          </a:p>
-        </p:txBody>
-      </p:sp>
-      <p:sp>
-        <p:nvSpPr>
-          <p:cNvPr id="8" name="TextBox 7"/>
+              <a:t>The combination's recall cost is the operating-point tension in miniature.</a:t>
+            </a:r>
+          </a:p>
+        </p:txBody>
+      </p:sp>
+      <p:sp>
+        <p:nvSpPr>
+          <p:cNvPr id="14" name="TextBox 13"/>
           <p:cNvSpPr txBox="1"/>
           <p:nvPr/>
         </p:nvSpPr>
         <p:spPr>
           <a:xfrm>
-            <a:off x="777240" y="4206240"/>
-            <a:ext cx="5852160" cy="640080"/>
-          </a:xfrm>
-          <a:prstGeom prst="rect">
-            <a:avLst/>
-          </a:prstGeom>
-          <a:noFill/>
-        </p:spPr>
-        <p:txBody>
-          <a:bodyPr wrap="square" anchor="t" lIns="0" rIns="0" tIns="0" bIns="0">
-            <a:spAutoFit/>
-          </a:bodyPr>
-          <a:lstStyle/>
-          <a:p>
-            <a:pPr algn="l">
-              <a:lnSpc>
-                <a:spcPct val="130000"/>
-              </a:lnSpc>
-            </a:pPr>
-            <a:r>
-              <a:rPr sz="1400" b="0" i="0">
-                <a:solidFill>
-                  <a:srgbClr val="9DA9B5"/>
-                </a:solidFill>
-                <a:latin typeface="Arial"/>
-              </a:rPr>
-              <a:t>At readers' specificity (</a:t>
-            </a:r>
-            <a:r>
-              <a:rPr sz="1400" b="1" i="0">
-                <a:solidFill>
-                  <a:srgbClr val="ECEFF3"/>
-                </a:solidFill>
-                <a:latin typeface="Arial"/>
-              </a:rPr>
-              <a:t>96.6%</a:t>
-            </a:r>
-            <a:r>
-              <a:rPr sz="1400" b="0" i="0">
-                <a:solidFill>
-                  <a:srgbClr val="9DA9B5"/>
-                </a:solidFill>
-                <a:latin typeface="Arial"/>
-              </a:rPr>
-              <a:t>): AI-1 </a:t>
-            </a:r>
-            <a:r>
-              <a:rPr sz="1400" b="1" i="0">
-                <a:solidFill>
-                  <a:srgbClr val="ECEFF3"/>
-                </a:solidFill>
-                <a:latin typeface="Arial"/>
-              </a:rPr>
-              <a:t>81.9%</a:t>
-            </a:r>
-            <a:r>
-              <a:rPr sz="1400" b="0" i="0">
-                <a:solidFill>
-                  <a:srgbClr val="9DA9B5"/>
-                </a:solidFill>
-                <a:latin typeface="Arial"/>
-              </a:rPr>
-              <a:t> sensitivity vs readers </a:t>
-            </a:r>
-            <a:r>
-              <a:rPr sz="1400" b="1" i="0">
-                <a:solidFill>
-                  <a:srgbClr val="ECEFF3"/>
-                </a:solidFill>
-                <a:latin typeface="Arial"/>
-              </a:rPr>
-              <a:t>77.4%</a:t>
-            </a:r>
-            <a:r>
-              <a:rPr sz="1400" b="0" i="0">
-                <a:solidFill>
-                  <a:srgbClr val="9DA9B5"/>
-                </a:solidFill>
-                <a:latin typeface="Arial"/>
-              </a:rPr>
-              <a:t>.</a:t>
-            </a:r>
-          </a:p>
-        </p:txBody>
-      </p:sp>
-      <p:sp>
-        <p:nvSpPr>
-          <p:cNvPr id="9" name="TextBox 8"/>
-          <p:cNvSpPr txBox="1"/>
-          <p:nvPr/>
-        </p:nvSpPr>
-        <p:spPr>
-          <a:xfrm>
-            <a:off x="777240" y="4846320"/>
-            <a:ext cx="5852160" cy="548640"/>
-          </a:xfrm>
-          <a:prstGeom prst="rect">
-            <a:avLst/>
-          </a:prstGeom>
-          <a:noFill/>
-        </p:spPr>
-        <p:txBody>
-          <a:bodyPr wrap="square" anchor="t" lIns="0" rIns="0" tIns="0" bIns="0">
-            <a:spAutoFit/>
-          </a:bodyPr>
-          <a:lstStyle/>
-          <a:p>
-            <a:pPr algn="l">
-              <a:lnSpc>
-                <a:spcPct val="130000"/>
-              </a:lnSpc>
-            </a:pPr>
-            <a:r>
-              <a:rPr sz="1400" b="0" i="0">
-                <a:solidFill>
-                  <a:srgbClr val="9DA9B5"/>
-                </a:solidFill>
-                <a:latin typeface="Arial"/>
-              </a:rPr>
-              <a:t>AI + reader: </a:t>
-            </a:r>
-            <a:r>
-              <a:rPr sz="1400" b="1" i="0">
-                <a:solidFill>
-                  <a:srgbClr val="E7AC51"/>
-                </a:solidFill>
-                <a:latin typeface="Arial"/>
-              </a:rPr>
-              <a:t>+77%</a:t>
-            </a:r>
-            <a:r>
-              <a:rPr sz="1400" b="0" i="0">
-                <a:solidFill>
-                  <a:srgbClr val="9DA9B5"/>
-                </a:solidFill>
-                <a:latin typeface="Arial"/>
-              </a:rPr>
-              <a:t> abnormal calls for </a:t>
-            </a:r>
-            <a:r>
-              <a:rPr sz="1400" b="1" i="0">
-                <a:solidFill>
-                  <a:srgbClr val="E7AC51"/>
-                </a:solidFill>
-                <a:latin typeface="Arial"/>
-              </a:rPr>
-              <a:t>+8%</a:t>
-            </a:r>
-            <a:r>
-              <a:rPr sz="1400" b="0" i="0">
-                <a:solidFill>
-                  <a:srgbClr val="9DA9B5"/>
-                </a:solidFill>
-                <a:latin typeface="Arial"/>
-              </a:rPr>
-              <a:t> detection — the operating-point tension in miniature.</a:t>
-            </a:r>
-          </a:p>
-        </p:txBody>
-      </p:sp>
-      <p:sp>
-        <p:nvSpPr>
-          <p:cNvPr id="10" name="TextBox 9"/>
-          <p:cNvSpPr txBox="1"/>
-          <p:nvPr/>
-        </p:nvSpPr>
-        <p:spPr>
-          <a:xfrm>
-            <a:off x="777240" y="5989320"/>
-            <a:ext cx="5852160" cy="457200"/>
+            <a:off x="777240" y="6199632"/>
+            <a:ext cx="5852160" cy="365760"/>
           </a:xfrm>
           <a:prstGeom prst="rect">
             <a:avLst/>
@@ -5805,7 +6229,7 @@
       </p:sp>
       <p:sp>
         <p:nvSpPr>
-          <p:cNvPr id="11" name="Rounded Rectangle 10"/>
+          <p:cNvPr id="15" name="Rounded Rectangle 14"/>
           <p:cNvSpPr/>
           <p:nvPr/>
         </p:nvSpPr>
@@ -5851,7 +6275,7 @@
       </p:sp>
       <p:pic>
         <p:nvPicPr>
-          <p:cNvPr id="12" name="Picture 11" descr="img_1a0b098745.png"/>
+          <p:cNvPr id="16" name="Picture 15" descr="img_1a0b098745.png"/>
           <p:cNvPicPr>
             <a:picLocks noChangeAspect="1"/>
           </p:cNvPicPr>
@@ -6177,391 +6601,814 @@
           </a:p>
         </p:txBody>
       </p:sp>
-      <p:graphicFrame>
-        <p:nvGraphicFramePr>
-          <p:cNvPr id="8" name="Table 7"/>
-          <p:cNvGraphicFramePr>
-            <a:graphicFrameLocks noGrp="1"/>
-          </p:cNvGraphicFramePr>
-          <p:nvPr/>
-        </p:nvGraphicFramePr>
-        <p:xfrm>
-          <a:off x="777240" y="4297680"/>
-          <a:ext cx="6949438" cy="1645919"/>
-        </p:xfrm>
-        <a:graphic>
-          <a:graphicData uri="http://schemas.openxmlformats.org/drawingml/2006/table">
-            <a:tbl>
-              <a:tblPr firstRow="1" bandRow="1">
-                <a:tableStyleId>{5C22544A-7EE6-4342-B048-85BDC9FD1C3A}</a:tableStyleId>
-              </a:tblPr>
-              <a:tblGrid>
-                <a:gridCol w="3291840"/>
-                <a:gridCol w="1828799"/>
-                <a:gridCol w="1828799"/>
-              </a:tblGrid>
-              <a:tr h="329183">
-                <a:tc>
-                  <a:txBody>
-                    <a:bodyPr/>
-                    <a:lstStyle/>
-                    <a:p>
-                      <a:pPr algn="l"/>
-                      <a:r>
-                        <a:rPr sz="1250" b="1">
-                          <a:solidFill>
-                            <a:srgbClr val="E7AC51"/>
-                          </a:solidFill>
-                          <a:latin typeface="Arial"/>
-                        </a:rPr>
-                        <a:t>Measure</a:t>
-                      </a:r>
-                    </a:p>
-                  </a:txBody>
-                  <a:tcPr anchor="ctr" marL="73152" marR="73152" marT="25400" marB="25400">
-                    <a:solidFill>
-                      <a:srgbClr val="0F141A"/>
-                    </a:solidFill>
-                  </a:tcPr>
-                </a:tc>
-                <a:tc>
-                  <a:txBody>
-                    <a:bodyPr/>
-                    <a:lstStyle/>
-                    <a:p>
-                      <a:pPr algn="ctr"/>
-                      <a:r>
-                        <a:rPr sz="1250" b="1">
-                          <a:solidFill>
-                            <a:srgbClr val="E7AC51"/>
-                          </a:solidFill>
-                          <a:latin typeface="Arial"/>
-                        </a:rPr>
-                        <a:t>AI</a:t>
-                      </a:r>
-                    </a:p>
-                  </a:txBody>
-                  <a:tcPr anchor="ctr" marL="73152" marR="73152" marT="25400" marB="25400">
-                    <a:solidFill>
-                      <a:srgbClr val="0F141A"/>
-                    </a:solidFill>
-                  </a:tcPr>
-                </a:tc>
-                <a:tc>
-                  <a:txBody>
-                    <a:bodyPr/>
-                    <a:lstStyle/>
-                    <a:p>
-                      <a:pPr algn="ctr"/>
-                      <a:r>
-                        <a:rPr sz="1250" b="1">
-                          <a:solidFill>
-                            <a:srgbClr val="E7AC51"/>
-                          </a:solidFill>
-                          <a:latin typeface="Arial"/>
-                        </a:rPr>
-                        <a:t>Control</a:t>
-                      </a:r>
-                    </a:p>
-                  </a:txBody>
-                  <a:tcPr anchor="ctr" marL="73152" marR="73152" marT="25400" marB="25400">
-                    <a:solidFill>
-                      <a:srgbClr val="0F141A"/>
-                    </a:solidFill>
-                  </a:tcPr>
-                </a:tc>
-              </a:tr>
-              <a:tr h="329183">
-                <a:tc>
-                  <a:txBody>
-                    <a:bodyPr/>
-                    <a:lstStyle/>
-                    <a:p>
-                      <a:pPr algn="l"/>
-                      <a:r>
-                        <a:rPr sz="1250" b="0">
-                          <a:solidFill>
-                            <a:srgbClr val="ECEFF3"/>
-                          </a:solidFill>
-                          <a:latin typeface="Arial"/>
-                        </a:rPr>
-                        <a:t>Recall rate</a:t>
-                      </a:r>
-                    </a:p>
-                  </a:txBody>
-                  <a:tcPr anchor="ctr" marL="73152" marR="73152" marT="25400" marB="25400">
-                    <a:solidFill>
-                      <a:srgbClr val="0F141A"/>
-                    </a:solidFill>
-                  </a:tcPr>
-                </a:tc>
-                <a:tc>
-                  <a:txBody>
-                    <a:bodyPr/>
-                    <a:lstStyle/>
-                    <a:p>
-                      <a:pPr algn="ctr"/>
-                      <a:r>
-                        <a:rPr sz="1250" b="0">
-                          <a:solidFill>
-                            <a:srgbClr val="9DA9B5"/>
-                          </a:solidFill>
-                          <a:latin typeface="Arial"/>
-                        </a:rPr>
-                        <a:t>2.2%</a:t>
-                      </a:r>
-                    </a:p>
-                  </a:txBody>
-                  <a:tcPr anchor="ctr" marL="73152" marR="73152" marT="25400" marB="25400">
-                    <a:solidFill>
-                      <a:srgbClr val="0F141A"/>
-                    </a:solidFill>
-                  </a:tcPr>
-                </a:tc>
-                <a:tc>
-                  <a:txBody>
-                    <a:bodyPr/>
-                    <a:lstStyle/>
-                    <a:p>
-                      <a:pPr algn="ctr"/>
-                      <a:r>
-                        <a:rPr sz="1250" b="0">
-                          <a:solidFill>
-                            <a:srgbClr val="9DA9B5"/>
-                          </a:solidFill>
-                          <a:latin typeface="Arial"/>
-                        </a:rPr>
-                        <a:t>2.0%</a:t>
-                      </a:r>
-                    </a:p>
-                  </a:txBody>
-                  <a:tcPr anchor="ctr" marL="73152" marR="73152" marT="25400" marB="25400">
-                    <a:solidFill>
-                      <a:srgbClr val="0F141A"/>
-                    </a:solidFill>
-                  </a:tcPr>
-                </a:tc>
-              </a:tr>
-              <a:tr h="329183">
-                <a:tc>
-                  <a:txBody>
-                    <a:bodyPr/>
-                    <a:lstStyle/>
-                    <a:p>
-                      <a:pPr algn="l"/>
-                      <a:r>
-                        <a:rPr sz="1250" b="0">
-                          <a:solidFill>
-                            <a:srgbClr val="ECEFF3"/>
-                          </a:solidFill>
-                          <a:latin typeface="Arial"/>
-                        </a:rPr>
-                        <a:t>False-positive rate</a:t>
-                      </a:r>
-                    </a:p>
-                  </a:txBody>
-                  <a:tcPr anchor="ctr" marL="73152" marR="73152" marT="25400" marB="25400">
-                    <a:solidFill>
-                      <a:srgbClr val="0F141A"/>
-                    </a:solidFill>
-                  </a:tcPr>
-                </a:tc>
-                <a:tc>
-                  <a:txBody>
-                    <a:bodyPr/>
-                    <a:lstStyle/>
-                    <a:p>
-                      <a:pPr algn="ctr"/>
-                      <a:r>
-                        <a:rPr sz="1250" b="0">
-                          <a:solidFill>
-                            <a:srgbClr val="9DA9B5"/>
-                          </a:solidFill>
-                          <a:latin typeface="Arial"/>
-                        </a:rPr>
-                        <a:t>1.5%</a:t>
-                      </a:r>
-                    </a:p>
-                  </a:txBody>
-                  <a:tcPr anchor="ctr" marL="73152" marR="73152" marT="25400" marB="25400">
-                    <a:solidFill>
-                      <a:srgbClr val="0F141A"/>
-                    </a:solidFill>
-                  </a:tcPr>
-                </a:tc>
-                <a:tc>
-                  <a:txBody>
-                    <a:bodyPr/>
-                    <a:lstStyle/>
-                    <a:p>
-                      <a:pPr algn="ctr"/>
-                      <a:r>
-                        <a:rPr sz="1250" b="0">
-                          <a:solidFill>
-                            <a:srgbClr val="9DA9B5"/>
-                          </a:solidFill>
-                          <a:latin typeface="Arial"/>
-                        </a:rPr>
-                        <a:t>1.5%</a:t>
-                      </a:r>
-                    </a:p>
-                  </a:txBody>
-                  <a:tcPr anchor="ctr" marL="73152" marR="73152" marT="25400" marB="25400">
-                    <a:solidFill>
-                      <a:srgbClr val="0F141A"/>
-                    </a:solidFill>
-                  </a:tcPr>
-                </a:tc>
-              </a:tr>
-              <a:tr h="329183">
-                <a:tc>
-                  <a:txBody>
-                    <a:bodyPr/>
-                    <a:lstStyle/>
-                    <a:p>
-                      <a:pPr algn="l"/>
-                      <a:r>
-                        <a:rPr sz="1250" b="0">
-                          <a:solidFill>
-                            <a:srgbClr val="ECEFF3"/>
-                          </a:solidFill>
-                          <a:latin typeface="Arial"/>
-                        </a:rPr>
-                        <a:t>PPV of recall</a:t>
-                      </a:r>
-                    </a:p>
-                  </a:txBody>
-                  <a:tcPr anchor="ctr" marL="73152" marR="73152" marT="25400" marB="25400">
-                    <a:solidFill>
-                      <a:srgbClr val="0F141A"/>
-                    </a:solidFill>
-                  </a:tcPr>
-                </a:tc>
-                <a:tc>
-                  <a:txBody>
-                    <a:bodyPr/>
-                    <a:lstStyle/>
-                    <a:p>
-                      <a:pPr algn="ctr"/>
-                      <a:r>
-                        <a:rPr sz="1250" b="0">
-                          <a:solidFill>
-                            <a:srgbClr val="9DA9B5"/>
-                          </a:solidFill>
-                          <a:latin typeface="Arial"/>
-                        </a:rPr>
-                        <a:t>28.3%</a:t>
-                      </a:r>
-                    </a:p>
-                  </a:txBody>
-                  <a:tcPr anchor="ctr" marL="73152" marR="73152" marT="25400" marB="25400">
-                    <a:solidFill>
-                      <a:srgbClr val="0F141A"/>
-                    </a:solidFill>
-                  </a:tcPr>
-                </a:tc>
-                <a:tc>
-                  <a:txBody>
-                    <a:bodyPr/>
-                    <a:lstStyle/>
-                    <a:p>
-                      <a:pPr algn="ctr"/>
-                      <a:r>
-                        <a:rPr sz="1250" b="0">
-                          <a:solidFill>
-                            <a:srgbClr val="9DA9B5"/>
-                          </a:solidFill>
-                          <a:latin typeface="Arial"/>
-                        </a:rPr>
-                        <a:t>24.8%</a:t>
-                      </a:r>
-                    </a:p>
-                  </a:txBody>
-                  <a:tcPr anchor="ctr" marL="73152" marR="73152" marT="25400" marB="25400">
-                    <a:solidFill>
-                      <a:srgbClr val="0F141A"/>
-                    </a:solidFill>
-                  </a:tcPr>
-                </a:tc>
-              </a:tr>
-              <a:tr h="329187">
-                <a:tc>
-                  <a:txBody>
-                    <a:bodyPr/>
-                    <a:lstStyle/>
-                    <a:p>
-                      <a:pPr algn="l"/>
-                      <a:r>
-                        <a:rPr sz="1250" b="0">
-                          <a:solidFill>
-                            <a:srgbClr val="ECEFF3"/>
-                          </a:solidFill>
-                          <a:latin typeface="Arial"/>
-                        </a:rPr>
-                        <a:t>Invasive cancers</a:t>
-                      </a:r>
-                    </a:p>
-                  </a:txBody>
-                  <a:tcPr anchor="ctr" marL="73152" marR="73152" marT="25400" marB="25400">
-                    <a:solidFill>
-                      <a:srgbClr val="0F141A"/>
-                    </a:solidFill>
-                  </a:tcPr>
-                </a:tc>
-                <a:tc>
-                  <a:txBody>
-                    <a:bodyPr/>
-                    <a:lstStyle/>
-                    <a:p>
-                      <a:pPr algn="ctr"/>
-                      <a:r>
-                        <a:rPr sz="1250" b="0">
-                          <a:solidFill>
-                            <a:srgbClr val="9DA9B5"/>
-                          </a:solidFill>
-                          <a:latin typeface="Arial"/>
-                        </a:rPr>
-                        <a:t>75%</a:t>
-                      </a:r>
-                    </a:p>
-                  </a:txBody>
-                  <a:tcPr anchor="ctr" marL="73152" marR="73152" marT="25400" marB="25400">
-                    <a:solidFill>
-                      <a:srgbClr val="0F141A"/>
-                    </a:solidFill>
-                  </a:tcPr>
-                </a:tc>
-                <a:tc>
-                  <a:txBody>
-                    <a:bodyPr/>
-                    <a:lstStyle/>
-                    <a:p>
-                      <a:pPr algn="ctr"/>
-                      <a:r>
-                        <a:rPr sz="1250" b="0">
-                          <a:solidFill>
-                            <a:srgbClr val="9DA9B5"/>
-                          </a:solidFill>
-                          <a:latin typeface="Arial"/>
-                        </a:rPr>
-                        <a:t>81%</a:t>
-                      </a:r>
-                    </a:p>
-                  </a:txBody>
-                  <a:tcPr anchor="ctr" marL="73152" marR="73152" marT="25400" marB="25400">
-                    <a:solidFill>
-                      <a:srgbClr val="0F141A"/>
-                    </a:solidFill>
-                  </a:tcPr>
-                </a:tc>
-              </a:tr>
-            </a:tbl>
-          </a:graphicData>
-        </a:graphic>
-      </p:graphicFrame>
+      <p:sp>
+        <p:nvSpPr>
+          <p:cNvPr id="8" name="TextBox 7"/>
+          <p:cNvSpPr txBox="1"/>
+          <p:nvPr/>
+        </p:nvSpPr>
+        <p:spPr>
+          <a:xfrm>
+            <a:off x="777240" y="4160520"/>
+            <a:ext cx="3840480" cy="475488"/>
+          </a:xfrm>
+          <a:prstGeom prst="rect">
+            <a:avLst/>
+          </a:prstGeom>
+          <a:noFill/>
+        </p:spPr>
+        <p:txBody>
+          <a:bodyPr wrap="square" anchor="ctr" lIns="0" rIns="0" tIns="0" bIns="0">
+            <a:spAutoFit/>
+          </a:bodyPr>
+          <a:lstStyle/>
+          <a:p>
+            <a:pPr algn="l">
+              <a:lnSpc>
+                <a:spcPct val="100000"/>
+              </a:lnSpc>
+            </a:pPr>
+            <a:r>
+              <a:rPr sz="1100" b="0" i="0">
+                <a:solidFill>
+                  <a:srgbClr val="9DA9B5"/>
+                </a:solidFill>
+                <a:latin typeface="Consolas"/>
+              </a:rPr>
+              <a:t>Measure</a:t>
+            </a:r>
+          </a:p>
+        </p:txBody>
+      </p:sp>
       <p:sp>
         <p:nvSpPr>
           <p:cNvPr id="9" name="TextBox 8"/>
+          <p:cNvSpPr txBox="1"/>
+          <p:nvPr/>
+        </p:nvSpPr>
+        <p:spPr>
+          <a:xfrm>
+            <a:off x="4617720" y="4160520"/>
+            <a:ext cx="1463040" cy="475488"/>
+          </a:xfrm>
+          <a:prstGeom prst="rect">
+            <a:avLst/>
+          </a:prstGeom>
+          <a:noFill/>
+        </p:spPr>
+        <p:txBody>
+          <a:bodyPr wrap="square" anchor="ctr" lIns="0" rIns="0" tIns="0" bIns="0">
+            <a:spAutoFit/>
+          </a:bodyPr>
+          <a:lstStyle/>
+          <a:p>
+            <a:pPr algn="r">
+              <a:lnSpc>
+                <a:spcPct val="100000"/>
+              </a:lnSpc>
+            </a:pPr>
+            <a:r>
+              <a:rPr sz="1050" b="0" i="0">
+                <a:solidFill>
+                  <a:srgbClr val="9DA9B5"/>
+                </a:solidFill>
+                <a:latin typeface="Consolas"/>
+              </a:rPr>
+              <a:t>AI</a:t>
+            </a:r>
+          </a:p>
+        </p:txBody>
+      </p:sp>
+      <p:sp>
+        <p:nvSpPr>
+          <p:cNvPr id="10" name="TextBox 9"/>
+          <p:cNvSpPr txBox="1"/>
+          <p:nvPr/>
+        </p:nvSpPr>
+        <p:spPr>
+          <a:xfrm>
+            <a:off x="6080760" y="4160520"/>
+            <a:ext cx="1463040" cy="475488"/>
+          </a:xfrm>
+          <a:prstGeom prst="rect">
+            <a:avLst/>
+          </a:prstGeom>
+          <a:noFill/>
+        </p:spPr>
+        <p:txBody>
+          <a:bodyPr wrap="square" anchor="ctr" lIns="0" rIns="0" tIns="0" bIns="0">
+            <a:spAutoFit/>
+          </a:bodyPr>
+          <a:lstStyle/>
+          <a:p>
+            <a:pPr algn="r">
+              <a:lnSpc>
+                <a:spcPct val="100000"/>
+              </a:lnSpc>
+            </a:pPr>
+            <a:r>
+              <a:rPr sz="1050" b="0" i="0">
+                <a:solidFill>
+                  <a:srgbClr val="9DA9B5"/>
+                </a:solidFill>
+                <a:latin typeface="Consolas"/>
+              </a:rPr>
+              <a:t>Control</a:t>
+            </a:r>
+          </a:p>
+        </p:txBody>
+      </p:sp>
+      <p:sp>
+        <p:nvSpPr>
+          <p:cNvPr id="11" name="Rectangle 10"/>
+          <p:cNvSpPr/>
+          <p:nvPr/>
+        </p:nvSpPr>
+        <p:spPr>
+          <a:xfrm>
+            <a:off x="777240" y="4626864"/>
+            <a:ext cx="6766560" cy="12700"/>
+          </a:xfrm>
+          <a:prstGeom prst="rect">
+            <a:avLst/>
+          </a:prstGeom>
+          <a:solidFill>
+            <a:srgbClr val="2A333D"/>
+          </a:solidFill>
+          <a:ln>
+            <a:noFill/>
+          </a:ln>
+          <a:effectLst/>
+        </p:spPr>
+        <p:style>
+          <a:lnRef idx="1">
+            <a:schemeClr val="accent1"/>
+          </a:lnRef>
+          <a:fillRef idx="3">
+            <a:schemeClr val="accent1"/>
+          </a:fillRef>
+          <a:effectRef idx="2">
+            <a:schemeClr val="accent1"/>
+          </a:effectRef>
+          <a:fontRef idx="minor">
+            <a:schemeClr val="lt1"/>
+          </a:fontRef>
+        </p:style>
+        <p:txBody>
+          <a:bodyPr rtlCol="0" anchor="ctr"/>
+          <a:lstStyle/>
+          <a:p>
+            <a:pPr algn="ctr"/>
+          </a:p>
+        </p:txBody>
+      </p:sp>
+      <p:sp>
+        <p:nvSpPr>
+          <p:cNvPr id="12" name="TextBox 11"/>
+          <p:cNvSpPr txBox="1"/>
+          <p:nvPr/>
+        </p:nvSpPr>
+        <p:spPr>
+          <a:xfrm>
+            <a:off x="777240" y="4636008"/>
+            <a:ext cx="3840480" cy="475488"/>
+          </a:xfrm>
+          <a:prstGeom prst="rect">
+            <a:avLst/>
+          </a:prstGeom>
+          <a:noFill/>
+        </p:spPr>
+        <p:txBody>
+          <a:bodyPr wrap="square" anchor="ctr" lIns="0" rIns="0" tIns="0" bIns="0">
+            <a:spAutoFit/>
+          </a:bodyPr>
+          <a:lstStyle/>
+          <a:p>
+            <a:pPr algn="l">
+              <a:lnSpc>
+                <a:spcPct val="100000"/>
+              </a:lnSpc>
+            </a:pPr>
+            <a:r>
+              <a:rPr sz="1300" b="0" i="0">
+                <a:solidFill>
+                  <a:srgbClr val="9DA9B5"/>
+                </a:solidFill>
+                <a:latin typeface="Arial"/>
+              </a:rPr>
+              <a:t>Recall rate</a:t>
+            </a:r>
+          </a:p>
+        </p:txBody>
+      </p:sp>
+      <p:sp>
+        <p:nvSpPr>
+          <p:cNvPr id="13" name="TextBox 12"/>
+          <p:cNvSpPr txBox="1"/>
+          <p:nvPr/>
+        </p:nvSpPr>
+        <p:spPr>
+          <a:xfrm>
+            <a:off x="4617720" y="4636008"/>
+            <a:ext cx="1463040" cy="475488"/>
+          </a:xfrm>
+          <a:prstGeom prst="rect">
+            <a:avLst/>
+          </a:prstGeom>
+          <a:noFill/>
+        </p:spPr>
+        <p:txBody>
+          <a:bodyPr wrap="square" anchor="ctr" lIns="0" rIns="0" tIns="0" bIns="0">
+            <a:spAutoFit/>
+          </a:bodyPr>
+          <a:lstStyle/>
+          <a:p>
+            <a:pPr algn="r">
+              <a:lnSpc>
+                <a:spcPct val="100000"/>
+              </a:lnSpc>
+            </a:pPr>
+            <a:r>
+              <a:rPr sz="1400" b="1" i="0">
+                <a:solidFill>
+                  <a:srgbClr val="E7AC51"/>
+                </a:solidFill>
+                <a:latin typeface="Arial"/>
+              </a:rPr>
+              <a:t>2.2%</a:t>
+            </a:r>
+          </a:p>
+        </p:txBody>
+      </p:sp>
+      <p:sp>
+        <p:nvSpPr>
+          <p:cNvPr id="14" name="TextBox 13"/>
+          <p:cNvSpPr txBox="1"/>
+          <p:nvPr/>
+        </p:nvSpPr>
+        <p:spPr>
+          <a:xfrm>
+            <a:off x="6080760" y="4636008"/>
+            <a:ext cx="1463040" cy="475488"/>
+          </a:xfrm>
+          <a:prstGeom prst="rect">
+            <a:avLst/>
+          </a:prstGeom>
+          <a:noFill/>
+        </p:spPr>
+        <p:txBody>
+          <a:bodyPr wrap="square" anchor="ctr" lIns="0" rIns="0" tIns="0" bIns="0">
+            <a:spAutoFit/>
+          </a:bodyPr>
+          <a:lstStyle/>
+          <a:p>
+            <a:pPr algn="r">
+              <a:lnSpc>
+                <a:spcPct val="100000"/>
+              </a:lnSpc>
+            </a:pPr>
+            <a:r>
+              <a:rPr sz="1300" b="0" i="0">
+                <a:solidFill>
+                  <a:srgbClr val="ECEFF3"/>
+                </a:solidFill>
+                <a:latin typeface="Arial"/>
+              </a:rPr>
+              <a:t>2.0%</a:t>
+            </a:r>
+          </a:p>
+        </p:txBody>
+      </p:sp>
+      <p:sp>
+        <p:nvSpPr>
+          <p:cNvPr id="15" name="Rectangle 14"/>
+          <p:cNvSpPr/>
+          <p:nvPr/>
+        </p:nvSpPr>
+        <p:spPr>
+          <a:xfrm>
+            <a:off x="777240" y="5102352"/>
+            <a:ext cx="6766560" cy="12700"/>
+          </a:xfrm>
+          <a:prstGeom prst="rect">
+            <a:avLst/>
+          </a:prstGeom>
+          <a:solidFill>
+            <a:srgbClr val="2A333D"/>
+          </a:solidFill>
+          <a:ln>
+            <a:noFill/>
+          </a:ln>
+          <a:effectLst/>
+        </p:spPr>
+        <p:style>
+          <a:lnRef idx="1">
+            <a:schemeClr val="accent1"/>
+          </a:lnRef>
+          <a:fillRef idx="3">
+            <a:schemeClr val="accent1"/>
+          </a:fillRef>
+          <a:effectRef idx="2">
+            <a:schemeClr val="accent1"/>
+          </a:effectRef>
+          <a:fontRef idx="minor">
+            <a:schemeClr val="lt1"/>
+          </a:fontRef>
+        </p:style>
+        <p:txBody>
+          <a:bodyPr rtlCol="0" anchor="ctr"/>
+          <a:lstStyle/>
+          <a:p>
+            <a:pPr algn="ctr"/>
+          </a:p>
+        </p:txBody>
+      </p:sp>
+      <p:sp>
+        <p:nvSpPr>
+          <p:cNvPr id="16" name="TextBox 15"/>
+          <p:cNvSpPr txBox="1"/>
+          <p:nvPr/>
+        </p:nvSpPr>
+        <p:spPr>
+          <a:xfrm>
+            <a:off x="777240" y="5111496"/>
+            <a:ext cx="3840480" cy="475488"/>
+          </a:xfrm>
+          <a:prstGeom prst="rect">
+            <a:avLst/>
+          </a:prstGeom>
+          <a:noFill/>
+        </p:spPr>
+        <p:txBody>
+          <a:bodyPr wrap="square" anchor="ctr" lIns="0" rIns="0" tIns="0" bIns="0">
+            <a:spAutoFit/>
+          </a:bodyPr>
+          <a:lstStyle/>
+          <a:p>
+            <a:pPr algn="l">
+              <a:lnSpc>
+                <a:spcPct val="100000"/>
+              </a:lnSpc>
+            </a:pPr>
+            <a:r>
+              <a:rPr sz="1300" b="0" i="0">
+                <a:solidFill>
+                  <a:srgbClr val="9DA9B5"/>
+                </a:solidFill>
+                <a:latin typeface="Arial"/>
+              </a:rPr>
+              <a:t>False-positive rate</a:t>
+            </a:r>
+          </a:p>
+        </p:txBody>
+      </p:sp>
+      <p:sp>
+        <p:nvSpPr>
+          <p:cNvPr id="17" name="TextBox 16"/>
+          <p:cNvSpPr txBox="1"/>
+          <p:nvPr/>
+        </p:nvSpPr>
+        <p:spPr>
+          <a:xfrm>
+            <a:off x="4617720" y="5111496"/>
+            <a:ext cx="1463040" cy="475488"/>
+          </a:xfrm>
+          <a:prstGeom prst="rect">
+            <a:avLst/>
+          </a:prstGeom>
+          <a:noFill/>
+        </p:spPr>
+        <p:txBody>
+          <a:bodyPr wrap="square" anchor="ctr" lIns="0" rIns="0" tIns="0" bIns="0">
+            <a:spAutoFit/>
+          </a:bodyPr>
+          <a:lstStyle/>
+          <a:p>
+            <a:pPr algn="r">
+              <a:lnSpc>
+                <a:spcPct val="100000"/>
+              </a:lnSpc>
+            </a:pPr>
+            <a:r>
+              <a:rPr sz="1400" b="1" i="0">
+                <a:solidFill>
+                  <a:srgbClr val="E7AC51"/>
+                </a:solidFill>
+                <a:latin typeface="Arial"/>
+              </a:rPr>
+              <a:t>1.5%</a:t>
+            </a:r>
+          </a:p>
+        </p:txBody>
+      </p:sp>
+      <p:sp>
+        <p:nvSpPr>
+          <p:cNvPr id="18" name="TextBox 17"/>
+          <p:cNvSpPr txBox="1"/>
+          <p:nvPr/>
+        </p:nvSpPr>
+        <p:spPr>
+          <a:xfrm>
+            <a:off x="6080760" y="5111496"/>
+            <a:ext cx="1463040" cy="475488"/>
+          </a:xfrm>
+          <a:prstGeom prst="rect">
+            <a:avLst/>
+          </a:prstGeom>
+          <a:noFill/>
+        </p:spPr>
+        <p:txBody>
+          <a:bodyPr wrap="square" anchor="ctr" lIns="0" rIns="0" tIns="0" bIns="0">
+            <a:spAutoFit/>
+          </a:bodyPr>
+          <a:lstStyle/>
+          <a:p>
+            <a:pPr algn="r">
+              <a:lnSpc>
+                <a:spcPct val="100000"/>
+              </a:lnSpc>
+            </a:pPr>
+            <a:r>
+              <a:rPr sz="1300" b="0" i="0">
+                <a:solidFill>
+                  <a:srgbClr val="ECEFF3"/>
+                </a:solidFill>
+                <a:latin typeface="Arial"/>
+              </a:rPr>
+              <a:t>1.5%</a:t>
+            </a:r>
+          </a:p>
+        </p:txBody>
+      </p:sp>
+      <p:sp>
+        <p:nvSpPr>
+          <p:cNvPr id="19" name="Rectangle 18"/>
+          <p:cNvSpPr/>
+          <p:nvPr/>
+        </p:nvSpPr>
+        <p:spPr>
+          <a:xfrm>
+            <a:off x="777240" y="5577840"/>
+            <a:ext cx="6766560" cy="12700"/>
+          </a:xfrm>
+          <a:prstGeom prst="rect">
+            <a:avLst/>
+          </a:prstGeom>
+          <a:solidFill>
+            <a:srgbClr val="2A333D"/>
+          </a:solidFill>
+          <a:ln>
+            <a:noFill/>
+          </a:ln>
+          <a:effectLst/>
+        </p:spPr>
+        <p:style>
+          <a:lnRef idx="1">
+            <a:schemeClr val="accent1"/>
+          </a:lnRef>
+          <a:fillRef idx="3">
+            <a:schemeClr val="accent1"/>
+          </a:fillRef>
+          <a:effectRef idx="2">
+            <a:schemeClr val="accent1"/>
+          </a:effectRef>
+          <a:fontRef idx="minor">
+            <a:schemeClr val="lt1"/>
+          </a:fontRef>
+        </p:style>
+        <p:txBody>
+          <a:bodyPr rtlCol="0" anchor="ctr"/>
+          <a:lstStyle/>
+          <a:p>
+            <a:pPr algn="ctr"/>
+          </a:p>
+        </p:txBody>
+      </p:sp>
+      <p:sp>
+        <p:nvSpPr>
+          <p:cNvPr id="20" name="TextBox 19"/>
+          <p:cNvSpPr txBox="1"/>
+          <p:nvPr/>
+        </p:nvSpPr>
+        <p:spPr>
+          <a:xfrm>
+            <a:off x="777240" y="5586983"/>
+            <a:ext cx="3840480" cy="475488"/>
+          </a:xfrm>
+          <a:prstGeom prst="rect">
+            <a:avLst/>
+          </a:prstGeom>
+          <a:noFill/>
+        </p:spPr>
+        <p:txBody>
+          <a:bodyPr wrap="square" anchor="ctr" lIns="0" rIns="0" tIns="0" bIns="0">
+            <a:spAutoFit/>
+          </a:bodyPr>
+          <a:lstStyle/>
+          <a:p>
+            <a:pPr algn="l">
+              <a:lnSpc>
+                <a:spcPct val="100000"/>
+              </a:lnSpc>
+            </a:pPr>
+            <a:r>
+              <a:rPr sz="1300" b="0" i="0">
+                <a:solidFill>
+                  <a:srgbClr val="9DA9B5"/>
+                </a:solidFill>
+                <a:latin typeface="Arial"/>
+              </a:rPr>
+              <a:t>PPV of recall</a:t>
+            </a:r>
+          </a:p>
+        </p:txBody>
+      </p:sp>
+      <p:sp>
+        <p:nvSpPr>
+          <p:cNvPr id="21" name="TextBox 20"/>
+          <p:cNvSpPr txBox="1"/>
+          <p:nvPr/>
+        </p:nvSpPr>
+        <p:spPr>
+          <a:xfrm>
+            <a:off x="4617720" y="5586983"/>
+            <a:ext cx="1463040" cy="475488"/>
+          </a:xfrm>
+          <a:prstGeom prst="rect">
+            <a:avLst/>
+          </a:prstGeom>
+          <a:noFill/>
+        </p:spPr>
+        <p:txBody>
+          <a:bodyPr wrap="square" anchor="ctr" lIns="0" rIns="0" tIns="0" bIns="0">
+            <a:spAutoFit/>
+          </a:bodyPr>
+          <a:lstStyle/>
+          <a:p>
+            <a:pPr algn="r">
+              <a:lnSpc>
+                <a:spcPct val="100000"/>
+              </a:lnSpc>
+            </a:pPr>
+            <a:r>
+              <a:rPr sz="1400" b="1" i="0">
+                <a:solidFill>
+                  <a:srgbClr val="E7AC51"/>
+                </a:solidFill>
+                <a:latin typeface="Arial"/>
+              </a:rPr>
+              <a:t>28.3%</a:t>
+            </a:r>
+          </a:p>
+        </p:txBody>
+      </p:sp>
+      <p:sp>
+        <p:nvSpPr>
+          <p:cNvPr id="22" name="TextBox 21"/>
+          <p:cNvSpPr txBox="1"/>
+          <p:nvPr/>
+        </p:nvSpPr>
+        <p:spPr>
+          <a:xfrm>
+            <a:off x="6080760" y="5586983"/>
+            <a:ext cx="1463040" cy="475488"/>
+          </a:xfrm>
+          <a:prstGeom prst="rect">
+            <a:avLst/>
+          </a:prstGeom>
+          <a:noFill/>
+        </p:spPr>
+        <p:txBody>
+          <a:bodyPr wrap="square" anchor="ctr" lIns="0" rIns="0" tIns="0" bIns="0">
+            <a:spAutoFit/>
+          </a:bodyPr>
+          <a:lstStyle/>
+          <a:p>
+            <a:pPr algn="r">
+              <a:lnSpc>
+                <a:spcPct val="100000"/>
+              </a:lnSpc>
+            </a:pPr>
+            <a:r>
+              <a:rPr sz="1300" b="0" i="0">
+                <a:solidFill>
+                  <a:srgbClr val="ECEFF3"/>
+                </a:solidFill>
+                <a:latin typeface="Arial"/>
+              </a:rPr>
+              <a:t>24.8%</a:t>
+            </a:r>
+          </a:p>
+        </p:txBody>
+      </p:sp>
+      <p:sp>
+        <p:nvSpPr>
+          <p:cNvPr id="23" name="Rectangle 22"/>
+          <p:cNvSpPr/>
+          <p:nvPr/>
+        </p:nvSpPr>
+        <p:spPr>
+          <a:xfrm>
+            <a:off x="777240" y="6053327"/>
+            <a:ext cx="6766560" cy="12700"/>
+          </a:xfrm>
+          <a:prstGeom prst="rect">
+            <a:avLst/>
+          </a:prstGeom>
+          <a:solidFill>
+            <a:srgbClr val="2A333D"/>
+          </a:solidFill>
+          <a:ln>
+            <a:noFill/>
+          </a:ln>
+          <a:effectLst/>
+        </p:spPr>
+        <p:style>
+          <a:lnRef idx="1">
+            <a:schemeClr val="accent1"/>
+          </a:lnRef>
+          <a:fillRef idx="3">
+            <a:schemeClr val="accent1"/>
+          </a:fillRef>
+          <a:effectRef idx="2">
+            <a:schemeClr val="accent1"/>
+          </a:effectRef>
+          <a:fontRef idx="minor">
+            <a:schemeClr val="lt1"/>
+          </a:fontRef>
+        </p:style>
+        <p:txBody>
+          <a:bodyPr rtlCol="0" anchor="ctr"/>
+          <a:lstStyle/>
+          <a:p>
+            <a:pPr algn="ctr"/>
+          </a:p>
+        </p:txBody>
+      </p:sp>
+      <p:sp>
+        <p:nvSpPr>
+          <p:cNvPr id="24" name="TextBox 23"/>
+          <p:cNvSpPr txBox="1"/>
+          <p:nvPr/>
+        </p:nvSpPr>
+        <p:spPr>
+          <a:xfrm>
+            <a:off x="777240" y="6062472"/>
+            <a:ext cx="3840480" cy="475488"/>
+          </a:xfrm>
+          <a:prstGeom prst="rect">
+            <a:avLst/>
+          </a:prstGeom>
+          <a:noFill/>
+        </p:spPr>
+        <p:txBody>
+          <a:bodyPr wrap="square" anchor="ctr" lIns="0" rIns="0" tIns="0" bIns="0">
+            <a:spAutoFit/>
+          </a:bodyPr>
+          <a:lstStyle/>
+          <a:p>
+            <a:pPr algn="l">
+              <a:lnSpc>
+                <a:spcPct val="100000"/>
+              </a:lnSpc>
+            </a:pPr>
+            <a:r>
+              <a:rPr sz="1300" b="0" i="0">
+                <a:solidFill>
+                  <a:srgbClr val="9DA9B5"/>
+                </a:solidFill>
+                <a:latin typeface="Arial"/>
+              </a:rPr>
+              <a:t>Invasive cancers</a:t>
+            </a:r>
+          </a:p>
+        </p:txBody>
+      </p:sp>
+      <p:sp>
+        <p:nvSpPr>
+          <p:cNvPr id="25" name="TextBox 24"/>
+          <p:cNvSpPr txBox="1"/>
+          <p:nvPr/>
+        </p:nvSpPr>
+        <p:spPr>
+          <a:xfrm>
+            <a:off x="4617720" y="6062472"/>
+            <a:ext cx="1463040" cy="475488"/>
+          </a:xfrm>
+          <a:prstGeom prst="rect">
+            <a:avLst/>
+          </a:prstGeom>
+          <a:noFill/>
+        </p:spPr>
+        <p:txBody>
+          <a:bodyPr wrap="square" anchor="ctr" lIns="0" rIns="0" tIns="0" bIns="0">
+            <a:spAutoFit/>
+          </a:bodyPr>
+          <a:lstStyle/>
+          <a:p>
+            <a:pPr algn="r">
+              <a:lnSpc>
+                <a:spcPct val="100000"/>
+              </a:lnSpc>
+            </a:pPr>
+            <a:r>
+              <a:rPr sz="1400" b="1" i="0">
+                <a:solidFill>
+                  <a:srgbClr val="E7AC51"/>
+                </a:solidFill>
+                <a:latin typeface="Arial"/>
+              </a:rPr>
+              <a:t>75%</a:t>
+            </a:r>
+          </a:p>
+        </p:txBody>
+      </p:sp>
+      <p:sp>
+        <p:nvSpPr>
+          <p:cNvPr id="26" name="TextBox 25"/>
+          <p:cNvSpPr txBox="1"/>
+          <p:nvPr/>
+        </p:nvSpPr>
+        <p:spPr>
+          <a:xfrm>
+            <a:off x="6080760" y="6062472"/>
+            <a:ext cx="1463040" cy="475488"/>
+          </a:xfrm>
+          <a:prstGeom prst="rect">
+            <a:avLst/>
+          </a:prstGeom>
+          <a:noFill/>
+        </p:spPr>
+        <p:txBody>
+          <a:bodyPr wrap="square" anchor="ctr" lIns="0" rIns="0" tIns="0" bIns="0">
+            <a:spAutoFit/>
+          </a:bodyPr>
+          <a:lstStyle/>
+          <a:p>
+            <a:pPr algn="r">
+              <a:lnSpc>
+                <a:spcPct val="100000"/>
+              </a:lnSpc>
+            </a:pPr>
+            <a:r>
+              <a:rPr sz="1300" b="0" i="0">
+                <a:solidFill>
+                  <a:srgbClr val="ECEFF3"/>
+                </a:solidFill>
+                <a:latin typeface="Arial"/>
+              </a:rPr>
+              <a:t>81%</a:t>
+            </a:r>
+          </a:p>
+        </p:txBody>
+      </p:sp>
+      <p:sp>
+        <p:nvSpPr>
+          <p:cNvPr id="27" name="Rectangle 26"/>
+          <p:cNvSpPr/>
+          <p:nvPr/>
+        </p:nvSpPr>
+        <p:spPr>
+          <a:xfrm>
+            <a:off x="777240" y="6528816"/>
+            <a:ext cx="6766560" cy="12700"/>
+          </a:xfrm>
+          <a:prstGeom prst="rect">
+            <a:avLst/>
+          </a:prstGeom>
+          <a:solidFill>
+            <a:srgbClr val="2A333D"/>
+          </a:solidFill>
+          <a:ln>
+            <a:noFill/>
+          </a:ln>
+          <a:effectLst/>
+        </p:spPr>
+        <p:style>
+          <a:lnRef idx="1">
+            <a:schemeClr val="accent1"/>
+          </a:lnRef>
+          <a:fillRef idx="3">
+            <a:schemeClr val="accent1"/>
+          </a:fillRef>
+          <a:effectRef idx="2">
+            <a:schemeClr val="accent1"/>
+          </a:effectRef>
+          <a:fontRef idx="minor">
+            <a:schemeClr val="lt1"/>
+          </a:fontRef>
+        </p:style>
+        <p:txBody>
+          <a:bodyPr rtlCol="0" anchor="ctr"/>
+          <a:lstStyle/>
+          <a:p>
+            <a:pPr algn="ctr"/>
+          </a:p>
+        </p:txBody>
+      </p:sp>
+      <p:sp>
+        <p:nvSpPr>
+          <p:cNvPr id="28" name="TextBox 27"/>
           <p:cNvSpPr txBox="1"/>
           <p:nvPr/>
         </p:nvSpPr>

</xml_diff>

<commit_message>
Era II dividers (2016/2026/2035): tight vertically-centered eyebrow+title+subtitle group matching HTML flexbox (was eyebrow-at-top + large title/subtitle gap); title 44pt, subtitle 17pt
</commit_message>
<xml_diff>
--- a/keynote-iwbi-2026/pptx/sections/IWBI2026_Trivedi_02_EraII.pptx
+++ b/keynote-iwbi-2026/pptx/sections/IWBI2026_Trivedi_02_EraII.pptx
@@ -3947,8 +3947,8 @@
         </p:nvSpPr>
         <p:spPr>
           <a:xfrm>
-            <a:off x="777240" y="566928"/>
-            <a:ext cx="8229600" cy="365760"/>
+            <a:off x="777240" y="2240280"/>
+            <a:ext cx="8229600" cy="310896"/>
           </a:xfrm>
           <a:prstGeom prst="rect">
             <a:avLst/>
@@ -3986,8 +3986,8 @@
         </p:nvSpPr>
         <p:spPr>
           <a:xfrm>
-            <a:off x="777240" y="2286000"/>
-            <a:ext cx="6126480" cy="1463040"/>
+            <a:off x="777240" y="2606040"/>
+            <a:ext cx="6309360" cy="868680"/>
           </a:xfrm>
           <a:prstGeom prst="rect">
             <a:avLst/>
@@ -4006,7 +4006,7 @@
               </a:lnSpc>
             </a:pPr>
             <a:r>
-              <a:rPr sz="5000" b="1" i="0">
+              <a:rPr sz="4400" b="1" i="0">
                 <a:solidFill>
                   <a:srgbClr val="ECEFF3"/>
                 </a:solidFill>
@@ -4015,7 +4015,7 @@
               <a:t>The year is </a:t>
             </a:r>
             <a:r>
-              <a:rPr sz="5000" b="1" i="0">
+              <a:rPr sz="4400" b="1" i="0">
                 <a:solidFill>
                   <a:srgbClr val="E7AC51"/>
                 </a:solidFill>
@@ -4034,8 +4034,8 @@
         </p:nvSpPr>
         <p:spPr>
           <a:xfrm>
-            <a:off x="777240" y="3977639"/>
-            <a:ext cx="6035040" cy="1463040"/>
+            <a:off x="777240" y="3611880"/>
+            <a:ext cx="5760720" cy="1188720"/>
           </a:xfrm>
           <a:prstGeom prst="rect">
             <a:avLst/>
@@ -4050,11 +4050,11 @@
           <a:p>
             <a:pPr algn="l">
               <a:lnSpc>
-                <a:spcPct val="130000"/>
+                <a:spcPct val="140000"/>
               </a:lnSpc>
             </a:pPr>
             <a:r>
-              <a:rPr sz="1900" b="0" i="0">
+              <a:rPr sz="1700" b="0" i="0">
                 <a:solidFill>
                   <a:srgbClr val="9DA9B5"/>
                 </a:solidFill>
@@ -4063,7 +4063,7 @@
               <a:t>You're beginning to hear about AI — but still </a:t>
             </a:r>
             <a:r>
-              <a:rPr sz="1900" b="1" i="0">
+              <a:rPr sz="1700" b="1" i="0">
                 <a:solidFill>
                   <a:srgbClr val="ECEFF3"/>
                 </a:solidFill>
@@ -4090,8 +4090,8 @@
         </p:blipFill>
         <p:spPr>
           <a:xfrm>
-            <a:off x="7040880" y="2305594"/>
-            <a:ext cx="4572000" cy="2612571"/>
+            <a:off x="7132320" y="1828800"/>
+            <a:ext cx="4480560" cy="2560320"/>
           </a:xfrm>
           <a:prstGeom prst="rect">
             <a:avLst/>

</xml_diff>